<commit_message>
Annotate eGFR-ratio linear (sub)HR plots with per-0.1 decline + IQR
Both plot_subhr_linear_ratio (Fine-Gray) and plot_cox_linear_ratio
(Cox PH) in all three Jiaxuan files now carry a per-panel subtitle:

  "subHR per 0.1 ratio decline: X.XX (CI)  |  per IQR decline
   (delta = D.DD): Y.YY (CI)  |  IQR: [Q1, Q3]"

beta is the per-1-unit ratio coefficient; the reported HR for a
0.1-unit decline is exp(-0.1 * beta) with CI scaled by 0.1 * se(beta)
on the log scale. The per-IQR-decline estimate uses the same delta
method with |IQR_w| * se(beta).

This adds the same per-decline framing already used by the eGFR
Discrepancy plots (section 7/10) to the eGFR Ratio plots (Section 6
plus Section 8 "Hospitalization by Reason" in whole; Sections 9 and
12 in the carboplatin cohorts). Curves, axis limits, and reference
lines are unchanged.

Co-Authored-By: Claude Opus 4.6 (1M context) <noreply@anthropic.com>
</commit_message>
<xml_diff>
--- a/docs/pptx/auc3/jx-auc3-cox-linear-ratio-death.pptx
+++ b/docs/pptx/auc3/jx-auc3-cox-linear-ratio-death.pptx
@@ -2271,7 +2271,7 @@
           </p:nvSpPr>
           <p:spPr>
             <a:xfrm>
-              <a:off x="817517" y="5114368"/>
+              <a:off x="817517" y="5142518"/>
               <a:ext cx="7799693" cy="0"/>
             </a:xfrm>
             <a:custGeom>
@@ -2314,7 +2314,7 @@
           </p:nvSpPr>
           <p:spPr>
             <a:xfrm>
-              <a:off x="817517" y="4244691"/>
+              <a:off x="817517" y="4313054"/>
               <a:ext cx="7799693" cy="0"/>
             </a:xfrm>
             <a:custGeom>
@@ -2357,7 +2357,7 @@
           </p:nvSpPr>
           <p:spPr>
             <a:xfrm>
-              <a:off x="817517" y="3375014"/>
+              <a:off x="817517" y="3483591"/>
               <a:ext cx="7799693" cy="0"/>
             </a:xfrm>
             <a:custGeom>
@@ -2400,7 +2400,7 @@
           </p:nvSpPr>
           <p:spPr>
             <a:xfrm>
-              <a:off x="817517" y="2505337"/>
+              <a:off x="817517" y="2654127"/>
               <a:ext cx="7799693" cy="0"/>
             </a:xfrm>
             <a:custGeom>
@@ -2443,15 +2443,15 @@
           </p:nvSpPr>
           <p:spPr>
             <a:xfrm>
-              <a:off x="1615213" y="1896563"/>
-              <a:ext cx="0" cy="3826579"/>
+              <a:off x="1615213" y="2073503"/>
+              <a:ext cx="0" cy="3649639"/>
             </a:xfrm>
             <a:custGeom>
               <a:avLst/>
               <a:pathLst>
-                <a:path w="0" h="3826579">
+                <a:path w="0" h="3649639">
                   <a:moveTo>
-                    <a:pt x="0" y="3826579"/>
+                    <a:pt x="0" y="3649639"/>
                   </a:moveTo>
                   <a:lnTo>
                     <a:pt x="0" y="0"/>
@@ -2486,15 +2486,15 @@
           </p:nvSpPr>
           <p:spPr>
             <a:xfrm>
-              <a:off x="3387871" y="1896563"/>
-              <a:ext cx="0" cy="3826579"/>
+              <a:off x="3387871" y="2073503"/>
+              <a:ext cx="0" cy="3649639"/>
             </a:xfrm>
             <a:custGeom>
               <a:avLst/>
               <a:pathLst>
-                <a:path w="0" h="3826579">
+                <a:path w="0" h="3649639">
                   <a:moveTo>
-                    <a:pt x="0" y="3826579"/>
+                    <a:pt x="0" y="3649639"/>
                   </a:moveTo>
                   <a:lnTo>
                     <a:pt x="0" y="0"/>
@@ -2529,15 +2529,15 @@
           </p:nvSpPr>
           <p:spPr>
             <a:xfrm>
-              <a:off x="5160528" y="1896563"/>
-              <a:ext cx="0" cy="3826579"/>
+              <a:off x="5160528" y="2073503"/>
+              <a:ext cx="0" cy="3649639"/>
             </a:xfrm>
             <a:custGeom>
               <a:avLst/>
               <a:pathLst>
-                <a:path w="0" h="3826579">
+                <a:path w="0" h="3649639">
                   <a:moveTo>
-                    <a:pt x="0" y="3826579"/>
+                    <a:pt x="0" y="3649639"/>
                   </a:moveTo>
                   <a:lnTo>
                     <a:pt x="0" y="0"/>
@@ -2572,15 +2572,15 @@
           </p:nvSpPr>
           <p:spPr>
             <a:xfrm>
-              <a:off x="6933186" y="1896563"/>
-              <a:ext cx="0" cy="3826579"/>
+              <a:off x="6933186" y="2073503"/>
+              <a:ext cx="0" cy="3649639"/>
             </a:xfrm>
             <a:custGeom>
               <a:avLst/>
               <a:pathLst>
-                <a:path w="0" h="3826579">
+                <a:path w="0" h="3649639">
                   <a:moveTo>
-                    <a:pt x="0" y="3826579"/>
+                    <a:pt x="0" y="3649639"/>
                   </a:moveTo>
                   <a:lnTo>
                     <a:pt x="0" y="0"/>
@@ -2615,7 +2615,7 @@
           </p:nvSpPr>
           <p:spPr>
             <a:xfrm>
-              <a:off x="817517" y="5549207"/>
+              <a:off x="817517" y="5557249"/>
               <a:ext cx="7799693" cy="0"/>
             </a:xfrm>
             <a:custGeom>
@@ -2658,7 +2658,7 @@
           </p:nvSpPr>
           <p:spPr>
             <a:xfrm>
-              <a:off x="817517" y="4679530"/>
+              <a:off x="817517" y="4727786"/>
               <a:ext cx="7799693" cy="0"/>
             </a:xfrm>
             <a:custGeom>
@@ -2701,7 +2701,7 @@
           </p:nvSpPr>
           <p:spPr>
             <a:xfrm>
-              <a:off x="817517" y="3809853"/>
+              <a:off x="817517" y="3898322"/>
               <a:ext cx="7799693" cy="0"/>
             </a:xfrm>
             <a:custGeom>
@@ -2744,7 +2744,7 @@
           </p:nvSpPr>
           <p:spPr>
             <a:xfrm>
-              <a:off x="817517" y="2940175"/>
+              <a:off x="817517" y="3068859"/>
               <a:ext cx="7799693" cy="0"/>
             </a:xfrm>
             <a:custGeom>
@@ -2787,7 +2787,7 @@
           </p:nvSpPr>
           <p:spPr>
             <a:xfrm>
-              <a:off x="817517" y="2070498"/>
+              <a:off x="817517" y="2239395"/>
               <a:ext cx="7799693" cy="0"/>
             </a:xfrm>
             <a:custGeom>
@@ -2830,15 +2830,15 @@
           </p:nvSpPr>
           <p:spPr>
             <a:xfrm>
-              <a:off x="2501542" y="1896563"/>
-              <a:ext cx="0" cy="3826579"/>
+              <a:off x="2501542" y="2073503"/>
+              <a:ext cx="0" cy="3649639"/>
             </a:xfrm>
             <a:custGeom>
               <a:avLst/>
               <a:pathLst>
-                <a:path w="0" h="3826579">
+                <a:path w="0" h="3649639">
                   <a:moveTo>
-                    <a:pt x="0" y="3826579"/>
+                    <a:pt x="0" y="3649639"/>
                   </a:moveTo>
                   <a:lnTo>
                     <a:pt x="0" y="0"/>
@@ -2873,15 +2873,15 @@
           </p:nvSpPr>
           <p:spPr>
             <a:xfrm>
-              <a:off x="4274200" y="1896563"/>
-              <a:ext cx="0" cy="3826579"/>
+              <a:off x="4274200" y="2073503"/>
+              <a:ext cx="0" cy="3649639"/>
             </a:xfrm>
             <a:custGeom>
               <a:avLst/>
               <a:pathLst>
-                <a:path w="0" h="3826579">
+                <a:path w="0" h="3649639">
                   <a:moveTo>
-                    <a:pt x="0" y="3826579"/>
+                    <a:pt x="0" y="3649639"/>
                   </a:moveTo>
                   <a:lnTo>
                     <a:pt x="0" y="0"/>
@@ -2916,15 +2916,15 @@
           </p:nvSpPr>
           <p:spPr>
             <a:xfrm>
-              <a:off x="6046857" y="1896563"/>
-              <a:ext cx="0" cy="3826579"/>
+              <a:off x="6046857" y="2073503"/>
+              <a:ext cx="0" cy="3649639"/>
             </a:xfrm>
             <a:custGeom>
               <a:avLst/>
               <a:pathLst>
-                <a:path w="0" h="3826579">
+                <a:path w="0" h="3649639">
                   <a:moveTo>
-                    <a:pt x="0" y="3826579"/>
+                    <a:pt x="0" y="3649639"/>
                   </a:moveTo>
                   <a:lnTo>
                     <a:pt x="0" y="0"/>
@@ -2959,15 +2959,15 @@
           </p:nvSpPr>
           <p:spPr>
             <a:xfrm>
-              <a:off x="7819515" y="1896563"/>
-              <a:ext cx="0" cy="3826579"/>
+              <a:off x="7819515" y="2073503"/>
+              <a:ext cx="0" cy="3649639"/>
             </a:xfrm>
             <a:custGeom>
               <a:avLst/>
               <a:pathLst>
-                <a:path w="0" h="3826579">
+                <a:path w="0" h="3649639">
                   <a:moveTo>
-                    <a:pt x="0" y="3826579"/>
+                    <a:pt x="0" y="3649639"/>
                   </a:moveTo>
                   <a:lnTo>
                     <a:pt x="0" y="0"/>
@@ -3002,471 +3002,471 @@
           </p:nvSpPr>
           <p:spPr>
             <a:xfrm>
-              <a:off x="1537077" y="1896563"/>
-              <a:ext cx="6672481" cy="3651692"/>
+              <a:off x="1537077" y="2073503"/>
+              <a:ext cx="6672481" cy="3482839"/>
             </a:xfrm>
             <a:custGeom>
               <a:avLst/>
               <a:pathLst>
-                <a:path w="6672481" h="3651692">
+                <a:path w="6672481" h="3482839">
                   <a:moveTo>
                     <a:pt x="1719653" y="0"/>
                   </a:moveTo>
                   <a:lnTo>
-                    <a:pt x="1728893" y="59041"/>
-                  </a:lnTo>
-                  <a:lnTo>
-                    <a:pt x="1806136" y="493021"/>
-                  </a:lnTo>
-                  <a:lnTo>
-                    <a:pt x="1883380" y="874593"/>
-                  </a:lnTo>
-                  <a:lnTo>
-                    <a:pt x="1960623" y="1210083"/>
-                  </a:lnTo>
-                  <a:lnTo>
-                    <a:pt x="2037867" y="1505059"/>
-                  </a:lnTo>
-                  <a:lnTo>
-                    <a:pt x="2115111" y="1764411"/>
-                  </a:lnTo>
-                  <a:lnTo>
-                    <a:pt x="2192354" y="1992443"/>
-                  </a:lnTo>
-                  <a:lnTo>
-                    <a:pt x="2269598" y="2192937"/>
-                  </a:lnTo>
-                  <a:lnTo>
-                    <a:pt x="2346841" y="2369218"/>
-                  </a:lnTo>
-                  <a:lnTo>
-                    <a:pt x="2424085" y="2524211"/>
-                  </a:lnTo>
-                  <a:lnTo>
-                    <a:pt x="2501328" y="2660486"/>
-                  </a:lnTo>
-                  <a:lnTo>
-                    <a:pt x="2578572" y="2780304"/>
-                  </a:lnTo>
-                  <a:lnTo>
-                    <a:pt x="2655816" y="2818680"/>
-                  </a:lnTo>
-                  <a:lnTo>
-                    <a:pt x="2733059" y="2853742"/>
-                  </a:lnTo>
-                  <a:lnTo>
-                    <a:pt x="2810303" y="2887330"/>
-                  </a:lnTo>
-                  <a:lnTo>
-                    <a:pt x="2887546" y="2919506"/>
-                  </a:lnTo>
-                  <a:lnTo>
-                    <a:pt x="2964790" y="2950329"/>
-                  </a:lnTo>
-                  <a:lnTo>
-                    <a:pt x="3042033" y="2979856"/>
-                  </a:lnTo>
-                  <a:lnTo>
-                    <a:pt x="3119277" y="3008142"/>
-                  </a:lnTo>
-                  <a:lnTo>
-                    <a:pt x="3196521" y="3035239"/>
-                  </a:lnTo>
-                  <a:lnTo>
-                    <a:pt x="3273764" y="3061196"/>
-                  </a:lnTo>
-                  <a:lnTo>
-                    <a:pt x="3351008" y="3086062"/>
-                  </a:lnTo>
-                  <a:lnTo>
-                    <a:pt x="3428251" y="3109883"/>
-                  </a:lnTo>
-                  <a:lnTo>
-                    <a:pt x="3505495" y="3132702"/>
-                  </a:lnTo>
-                  <a:lnTo>
-                    <a:pt x="3582738" y="3154562"/>
-                  </a:lnTo>
-                  <a:lnTo>
-                    <a:pt x="3659982" y="3175503"/>
-                  </a:lnTo>
-                  <a:lnTo>
-                    <a:pt x="3737226" y="3195563"/>
-                  </a:lnTo>
-                  <a:lnTo>
-                    <a:pt x="3814469" y="3214780"/>
-                  </a:lnTo>
-                  <a:lnTo>
-                    <a:pt x="3891713" y="3233189"/>
-                  </a:lnTo>
-                  <a:lnTo>
-                    <a:pt x="3968956" y="3250824"/>
-                  </a:lnTo>
-                  <a:lnTo>
-                    <a:pt x="4046200" y="3267718"/>
-                  </a:lnTo>
-                  <a:lnTo>
-                    <a:pt x="4123443" y="3283901"/>
-                  </a:lnTo>
-                  <a:lnTo>
-                    <a:pt x="4200687" y="3299404"/>
-                  </a:lnTo>
-                  <a:lnTo>
-                    <a:pt x="4277931" y="3314255"/>
-                  </a:lnTo>
-                  <a:lnTo>
-                    <a:pt x="4355174" y="3328482"/>
-                  </a:lnTo>
-                  <a:lnTo>
-                    <a:pt x="4432418" y="3342111"/>
-                  </a:lnTo>
-                  <a:lnTo>
-                    <a:pt x="4509661" y="3355166"/>
-                  </a:lnTo>
-                  <a:lnTo>
-                    <a:pt x="4586905" y="3367673"/>
-                  </a:lnTo>
-                  <a:lnTo>
-                    <a:pt x="4664148" y="3379654"/>
-                  </a:lnTo>
-                  <a:lnTo>
-                    <a:pt x="4741392" y="3391131"/>
-                  </a:lnTo>
-                  <a:lnTo>
-                    <a:pt x="4818636" y="3402126"/>
-                  </a:lnTo>
-                  <a:lnTo>
-                    <a:pt x="4895879" y="3412658"/>
-                  </a:lnTo>
-                  <a:lnTo>
-                    <a:pt x="4973123" y="3422748"/>
-                  </a:lnTo>
-                  <a:lnTo>
-                    <a:pt x="5050366" y="3432413"/>
-                  </a:lnTo>
-                  <a:lnTo>
-                    <a:pt x="5127610" y="3441673"/>
-                  </a:lnTo>
-                  <a:lnTo>
-                    <a:pt x="5204853" y="3450542"/>
-                  </a:lnTo>
-                  <a:lnTo>
-                    <a:pt x="5282097" y="3459039"/>
-                  </a:lnTo>
-                  <a:lnTo>
-                    <a:pt x="5359341" y="3467179"/>
-                  </a:lnTo>
-                  <a:lnTo>
-                    <a:pt x="5436584" y="3474976"/>
-                  </a:lnTo>
-                  <a:lnTo>
-                    <a:pt x="5513828" y="3482446"/>
-                  </a:lnTo>
-                  <a:lnTo>
-                    <a:pt x="5591071" y="3489602"/>
-                  </a:lnTo>
-                  <a:lnTo>
-                    <a:pt x="5668315" y="3496456"/>
-                  </a:lnTo>
-                  <a:lnTo>
-                    <a:pt x="5745558" y="3503023"/>
-                  </a:lnTo>
-                  <a:lnTo>
-                    <a:pt x="5822802" y="3509313"/>
-                  </a:lnTo>
-                  <a:lnTo>
-                    <a:pt x="5900046" y="3515339"/>
-                  </a:lnTo>
-                  <a:lnTo>
-                    <a:pt x="5977289" y="3521112"/>
-                  </a:lnTo>
-                  <a:lnTo>
-                    <a:pt x="6054533" y="3526642"/>
-                  </a:lnTo>
-                  <a:lnTo>
-                    <a:pt x="6131776" y="3531939"/>
-                  </a:lnTo>
-                  <a:lnTo>
-                    <a:pt x="6209020" y="3537014"/>
-                  </a:lnTo>
-                  <a:lnTo>
-                    <a:pt x="6286263" y="3541875"/>
-                  </a:lnTo>
-                  <a:lnTo>
-                    <a:pt x="6363507" y="3546532"/>
-                  </a:lnTo>
-                  <a:lnTo>
-                    <a:pt x="6440751" y="3550994"/>
-                  </a:lnTo>
-                  <a:lnTo>
-                    <a:pt x="6517994" y="3555267"/>
-                  </a:lnTo>
-                  <a:lnTo>
-                    <a:pt x="6595238" y="3559361"/>
-                  </a:lnTo>
-                  <a:lnTo>
-                    <a:pt x="6672481" y="3563283"/>
-                  </a:lnTo>
-                  <a:lnTo>
-                    <a:pt x="6672481" y="3651692"/>
-                  </a:lnTo>
-                  <a:lnTo>
-                    <a:pt x="6595238" y="3651561"/>
-                  </a:lnTo>
-                  <a:lnTo>
-                    <a:pt x="6517994" y="3651413"/>
-                  </a:lnTo>
-                  <a:lnTo>
-                    <a:pt x="6440751" y="3651244"/>
-                  </a:lnTo>
-                  <a:lnTo>
-                    <a:pt x="6363507" y="3651052"/>
-                  </a:lnTo>
-                  <a:lnTo>
-                    <a:pt x="6286263" y="3650833"/>
-                  </a:lnTo>
-                  <a:lnTo>
-                    <a:pt x="6209020" y="3650584"/>
-                  </a:lnTo>
-                  <a:lnTo>
-                    <a:pt x="6131776" y="3650302"/>
-                  </a:lnTo>
-                  <a:lnTo>
-                    <a:pt x="6054533" y="3649980"/>
-                  </a:lnTo>
-                  <a:lnTo>
-                    <a:pt x="5977289" y="3649614"/>
-                  </a:lnTo>
-                  <a:lnTo>
-                    <a:pt x="5900046" y="3649198"/>
-                  </a:lnTo>
-                  <a:lnTo>
-                    <a:pt x="5822802" y="3648725"/>
-                  </a:lnTo>
-                  <a:lnTo>
-                    <a:pt x="5745558" y="3648187"/>
-                  </a:lnTo>
-                  <a:lnTo>
-                    <a:pt x="5668315" y="3647575"/>
-                  </a:lnTo>
-                  <a:lnTo>
-                    <a:pt x="5591071" y="3646879"/>
-                  </a:lnTo>
-                  <a:lnTo>
-                    <a:pt x="5513828" y="3646087"/>
-                  </a:lnTo>
-                  <a:lnTo>
-                    <a:pt x="5436584" y="3645186"/>
-                  </a:lnTo>
-                  <a:lnTo>
-                    <a:pt x="5359341" y="3644162"/>
-                  </a:lnTo>
-                  <a:lnTo>
-                    <a:pt x="5282097" y="3642997"/>
-                  </a:lnTo>
-                  <a:lnTo>
-                    <a:pt x="5204853" y="3641672"/>
-                  </a:lnTo>
-                  <a:lnTo>
-                    <a:pt x="5127610" y="3640165"/>
-                  </a:lnTo>
-                  <a:lnTo>
-                    <a:pt x="5050366" y="3638451"/>
-                  </a:lnTo>
-                  <a:lnTo>
-                    <a:pt x="4973123" y="3636502"/>
-                  </a:lnTo>
-                  <a:lnTo>
-                    <a:pt x="4895879" y="3634285"/>
-                  </a:lnTo>
-                  <a:lnTo>
-                    <a:pt x="4818636" y="3631763"/>
-                  </a:lnTo>
-                  <a:lnTo>
-                    <a:pt x="4741392" y="3628895"/>
-                  </a:lnTo>
-                  <a:lnTo>
-                    <a:pt x="4664148" y="3625633"/>
-                  </a:lnTo>
-                  <a:lnTo>
-                    <a:pt x="4586905" y="3621924"/>
-                  </a:lnTo>
-                  <a:lnTo>
-                    <a:pt x="4509661" y="3617704"/>
-                  </a:lnTo>
-                  <a:lnTo>
-                    <a:pt x="4432418" y="3612905"/>
-                  </a:lnTo>
-                  <a:lnTo>
-                    <a:pt x="4355174" y="3607447"/>
-                  </a:lnTo>
-                  <a:lnTo>
-                    <a:pt x="4277931" y="3601239"/>
-                  </a:lnTo>
-                  <a:lnTo>
-                    <a:pt x="4200687" y="3594179"/>
-                  </a:lnTo>
-                  <a:lnTo>
-                    <a:pt x="4123443" y="3586149"/>
-                  </a:lnTo>
-                  <a:lnTo>
-                    <a:pt x="4046200" y="3577015"/>
-                  </a:lnTo>
-                  <a:lnTo>
-                    <a:pt x="3968956" y="3566628"/>
-                  </a:lnTo>
-                  <a:lnTo>
-                    <a:pt x="3891713" y="3554813"/>
-                  </a:lnTo>
-                  <a:lnTo>
-                    <a:pt x="3814469" y="3541376"/>
-                  </a:lnTo>
-                  <a:lnTo>
-                    <a:pt x="3737226" y="3526093"/>
-                  </a:lnTo>
-                  <a:lnTo>
-                    <a:pt x="3659982" y="3508712"/>
-                  </a:lnTo>
-                  <a:lnTo>
-                    <a:pt x="3582738" y="3488942"/>
-                  </a:lnTo>
-                  <a:lnTo>
-                    <a:pt x="3505495" y="3466458"/>
-                  </a:lnTo>
-                  <a:lnTo>
-                    <a:pt x="3428251" y="3440885"/>
-                  </a:lnTo>
-                  <a:lnTo>
-                    <a:pt x="3351008" y="3411799"/>
-                  </a:lnTo>
-                  <a:lnTo>
-                    <a:pt x="3273764" y="3378719"/>
-                  </a:lnTo>
-                  <a:lnTo>
-                    <a:pt x="3196521" y="3341094"/>
-                  </a:lnTo>
-                  <a:lnTo>
-                    <a:pt x="3119277" y="3298303"/>
-                  </a:lnTo>
-                  <a:lnTo>
-                    <a:pt x="3042033" y="3249633"/>
-                  </a:lnTo>
-                  <a:lnTo>
-                    <a:pt x="2964790" y="3194279"/>
-                  </a:lnTo>
-                  <a:lnTo>
-                    <a:pt x="2887546" y="3131322"/>
-                  </a:lnTo>
-                  <a:lnTo>
-                    <a:pt x="2810303" y="3059717"/>
-                  </a:lnTo>
-                  <a:lnTo>
-                    <a:pt x="2733059" y="2978277"/>
-                  </a:lnTo>
-                  <a:lnTo>
-                    <a:pt x="2655816" y="2885652"/>
-                  </a:lnTo>
-                  <a:lnTo>
-                    <a:pt x="2578572" y="2782079"/>
-                  </a:lnTo>
-                  <a:lnTo>
-                    <a:pt x="2501328" y="2743871"/>
-                  </a:lnTo>
-                  <a:lnTo>
-                    <a:pt x="2424085" y="2703987"/>
-                  </a:lnTo>
-                  <a:lnTo>
-                    <a:pt x="2346841" y="2662352"/>
-                  </a:lnTo>
-                  <a:lnTo>
-                    <a:pt x="2269598" y="2618890"/>
-                  </a:lnTo>
-                  <a:lnTo>
-                    <a:pt x="2192354" y="2573521"/>
-                  </a:lnTo>
-                  <a:lnTo>
-                    <a:pt x="2115111" y="2526161"/>
-                  </a:lnTo>
-                  <a:lnTo>
-                    <a:pt x="2037867" y="2476722"/>
-                  </a:lnTo>
-                  <a:lnTo>
-                    <a:pt x="1960623" y="2425113"/>
-                  </a:lnTo>
-                  <a:lnTo>
-                    <a:pt x="1883380" y="2371239"/>
-                  </a:lnTo>
-                  <a:lnTo>
-                    <a:pt x="1806136" y="2315001"/>
-                  </a:lnTo>
-                  <a:lnTo>
-                    <a:pt x="1728893" y="2256294"/>
-                  </a:lnTo>
-                  <a:lnTo>
-                    <a:pt x="1651649" y="2195011"/>
-                  </a:lnTo>
-                  <a:lnTo>
-                    <a:pt x="1574405" y="2131039"/>
-                  </a:lnTo>
-                  <a:lnTo>
-                    <a:pt x="1497162" y="2064258"/>
-                  </a:lnTo>
-                  <a:lnTo>
-                    <a:pt x="1419918" y="1994547"/>
-                  </a:lnTo>
-                  <a:lnTo>
-                    <a:pt x="1342675" y="1921777"/>
-                  </a:lnTo>
-                  <a:lnTo>
-                    <a:pt x="1265431" y="1845812"/>
-                  </a:lnTo>
-                  <a:lnTo>
-                    <a:pt x="1188188" y="1766514"/>
-                  </a:lnTo>
-                  <a:lnTo>
-                    <a:pt x="1110944" y="1683736"/>
-                  </a:lnTo>
-                  <a:lnTo>
-                    <a:pt x="1033700" y="1597324"/>
-                  </a:lnTo>
-                  <a:lnTo>
-                    <a:pt x="956457" y="1507121"/>
-                  </a:lnTo>
-                  <a:lnTo>
-                    <a:pt x="879213" y="1412958"/>
-                  </a:lnTo>
-                  <a:lnTo>
-                    <a:pt x="801970" y="1314663"/>
-                  </a:lnTo>
-                  <a:lnTo>
-                    <a:pt x="724726" y="1212053"/>
-                  </a:lnTo>
-                  <a:lnTo>
-                    <a:pt x="647483" y="1104941"/>
-                  </a:lnTo>
-                  <a:lnTo>
-                    <a:pt x="570239" y="993127"/>
-                  </a:lnTo>
-                  <a:lnTo>
-                    <a:pt x="492995" y="876406"/>
-                  </a:lnTo>
-                  <a:lnTo>
-                    <a:pt x="415752" y="754563"/>
-                  </a:lnTo>
-                  <a:lnTo>
-                    <a:pt x="338508" y="627372"/>
-                  </a:lnTo>
-                  <a:lnTo>
-                    <a:pt x="261265" y="494599"/>
-                  </a:lnTo>
-                  <a:lnTo>
-                    <a:pt x="184021" y="355999"/>
-                  </a:lnTo>
-                  <a:lnTo>
-                    <a:pt x="106778" y="211315"/>
-                  </a:lnTo>
-                  <a:lnTo>
-                    <a:pt x="29534" y="60282"/>
+                    <a:pt x="1728893" y="56311"/>
+                  </a:lnTo>
+                  <a:lnTo>
+                    <a:pt x="1806136" y="470224"/>
+                  </a:lnTo>
+                  <a:lnTo>
+                    <a:pt x="1883380" y="834152"/>
+                  </a:lnTo>
+                  <a:lnTo>
+                    <a:pt x="1960623" y="1154130"/>
+                  </a:lnTo>
+                  <a:lnTo>
+                    <a:pt x="2037867" y="1435465"/>
+                  </a:lnTo>
+                  <a:lnTo>
+                    <a:pt x="2115111" y="1682826"/>
+                  </a:lnTo>
+                  <a:lnTo>
+                    <a:pt x="2192354" y="1900314"/>
+                  </a:lnTo>
+                  <a:lnTo>
+                    <a:pt x="2269598" y="2091537"/>
+                  </a:lnTo>
+                  <a:lnTo>
+                    <a:pt x="2346841" y="2259666"/>
+                  </a:lnTo>
+                  <a:lnTo>
+                    <a:pt x="2424085" y="2407492"/>
+                  </a:lnTo>
+                  <a:lnTo>
+                    <a:pt x="2501328" y="2537466"/>
+                  </a:lnTo>
+                  <a:lnTo>
+                    <a:pt x="2578572" y="2651743"/>
+                  </a:lnTo>
+                  <a:lnTo>
+                    <a:pt x="2655816" y="2688345"/>
+                  </a:lnTo>
+                  <a:lnTo>
+                    <a:pt x="2733059" y="2721786"/>
+                  </a:lnTo>
+                  <a:lnTo>
+                    <a:pt x="2810303" y="2753821"/>
+                  </a:lnTo>
+                  <a:lnTo>
+                    <a:pt x="2887546" y="2784509"/>
+                  </a:lnTo>
+                  <a:lnTo>
+                    <a:pt x="2964790" y="2813907"/>
+                  </a:lnTo>
+                  <a:lnTo>
+                    <a:pt x="3042033" y="2842069"/>
+                  </a:lnTo>
+                  <a:lnTo>
+                    <a:pt x="3119277" y="2869047"/>
+                  </a:lnTo>
+                  <a:lnTo>
+                    <a:pt x="3196521" y="2894890"/>
+                  </a:lnTo>
+                  <a:lnTo>
+                    <a:pt x="3273764" y="2919648"/>
+                  </a:lnTo>
+                  <a:lnTo>
+                    <a:pt x="3351008" y="2943364"/>
+                  </a:lnTo>
+                  <a:lnTo>
+                    <a:pt x="3428251" y="2966083"/>
+                  </a:lnTo>
+                  <a:lnTo>
+                    <a:pt x="3505495" y="2987847"/>
+                  </a:lnTo>
+                  <a:lnTo>
+                    <a:pt x="3582738" y="3008696"/>
+                  </a:lnTo>
+                  <a:lnTo>
+                    <a:pt x="3659982" y="3028669"/>
+                  </a:lnTo>
+                  <a:lnTo>
+                    <a:pt x="3737226" y="3047801"/>
+                  </a:lnTo>
+                  <a:lnTo>
+                    <a:pt x="3814469" y="3066130"/>
+                  </a:lnTo>
+                  <a:lnTo>
+                    <a:pt x="3891713" y="3083687"/>
+                  </a:lnTo>
+                  <a:lnTo>
+                    <a:pt x="3968956" y="3100507"/>
+                  </a:lnTo>
+                  <a:lnTo>
+                    <a:pt x="4046200" y="3116620"/>
+                  </a:lnTo>
+                  <a:lnTo>
+                    <a:pt x="4123443" y="3132055"/>
+                  </a:lnTo>
+                  <a:lnTo>
+                    <a:pt x="4200687" y="3146841"/>
+                  </a:lnTo>
+                  <a:lnTo>
+                    <a:pt x="4277931" y="3161005"/>
+                  </a:lnTo>
+                  <a:lnTo>
+                    <a:pt x="4355174" y="3174574"/>
+                  </a:lnTo>
+                  <a:lnTo>
+                    <a:pt x="4432418" y="3187573"/>
+                  </a:lnTo>
+                  <a:lnTo>
+                    <a:pt x="4509661" y="3200025"/>
+                  </a:lnTo>
+                  <a:lnTo>
+                    <a:pt x="4586905" y="3211953"/>
+                  </a:lnTo>
+                  <a:lnTo>
+                    <a:pt x="4664148" y="3223380"/>
+                  </a:lnTo>
+                  <a:lnTo>
+                    <a:pt x="4741392" y="3234327"/>
+                  </a:lnTo>
+                  <a:lnTo>
+                    <a:pt x="4818636" y="3244813"/>
+                  </a:lnTo>
+                  <a:lnTo>
+                    <a:pt x="4895879" y="3254858"/>
+                  </a:lnTo>
+                  <a:lnTo>
+                    <a:pt x="4973123" y="3264481"/>
+                  </a:lnTo>
+                  <a:lnTo>
+                    <a:pt x="5050366" y="3273700"/>
+                  </a:lnTo>
+                  <a:lnTo>
+                    <a:pt x="5127610" y="3282531"/>
+                  </a:lnTo>
+                  <a:lnTo>
+                    <a:pt x="5204853" y="3290991"/>
+                  </a:lnTo>
+                  <a:lnTo>
+                    <a:pt x="5282097" y="3299095"/>
+                  </a:lnTo>
+                  <a:lnTo>
+                    <a:pt x="5359341" y="3306858"/>
+                  </a:lnTo>
+                  <a:lnTo>
+                    <a:pt x="5436584" y="3314295"/>
+                  </a:lnTo>
+                  <a:lnTo>
+                    <a:pt x="5513828" y="3321419"/>
+                  </a:lnTo>
+                  <a:lnTo>
+                    <a:pt x="5591071" y="3328244"/>
+                  </a:lnTo>
+                  <a:lnTo>
+                    <a:pt x="5668315" y="3334781"/>
+                  </a:lnTo>
+                  <a:lnTo>
+                    <a:pt x="5745558" y="3341044"/>
+                  </a:lnTo>
+                  <a:lnTo>
+                    <a:pt x="5822802" y="3347044"/>
+                  </a:lnTo>
+                  <a:lnTo>
+                    <a:pt x="5900046" y="3352791"/>
+                  </a:lnTo>
+                  <a:lnTo>
+                    <a:pt x="5977289" y="3358297"/>
+                  </a:lnTo>
+                  <a:lnTo>
+                    <a:pt x="6054533" y="3363571"/>
+                  </a:lnTo>
+                  <a:lnTo>
+                    <a:pt x="6131776" y="3368624"/>
+                  </a:lnTo>
+                  <a:lnTo>
+                    <a:pt x="6209020" y="3373464"/>
+                  </a:lnTo>
+                  <a:lnTo>
+                    <a:pt x="6286263" y="3378100"/>
+                  </a:lnTo>
+                  <a:lnTo>
+                    <a:pt x="6363507" y="3382542"/>
+                  </a:lnTo>
+                  <a:lnTo>
+                    <a:pt x="6440751" y="3386797"/>
+                  </a:lnTo>
+                  <a:lnTo>
+                    <a:pt x="6517994" y="3390873"/>
+                  </a:lnTo>
+                  <a:lnTo>
+                    <a:pt x="6595238" y="3394778"/>
+                  </a:lnTo>
+                  <a:lnTo>
+                    <a:pt x="6672481" y="3398518"/>
+                  </a:lnTo>
+                  <a:lnTo>
+                    <a:pt x="6672481" y="3482839"/>
+                  </a:lnTo>
+                  <a:lnTo>
+                    <a:pt x="6595238" y="3482715"/>
+                  </a:lnTo>
+                  <a:lnTo>
+                    <a:pt x="6517994" y="3482573"/>
+                  </a:lnTo>
+                  <a:lnTo>
+                    <a:pt x="6440751" y="3482412"/>
+                  </a:lnTo>
+                  <a:lnTo>
+                    <a:pt x="6363507" y="3482228"/>
+                  </a:lnTo>
+                  <a:lnTo>
+                    <a:pt x="6286263" y="3482020"/>
+                  </a:lnTo>
+                  <a:lnTo>
+                    <a:pt x="6209020" y="3481783"/>
+                  </a:lnTo>
+                  <a:lnTo>
+                    <a:pt x="6131776" y="3481513"/>
+                  </a:lnTo>
+                  <a:lnTo>
+                    <a:pt x="6054533" y="3481206"/>
+                  </a:lnTo>
+                  <a:lnTo>
+                    <a:pt x="5977289" y="3480857"/>
+                  </a:lnTo>
+                  <a:lnTo>
+                    <a:pt x="5900046" y="3480461"/>
+                  </a:lnTo>
+                  <a:lnTo>
+                    <a:pt x="5822802" y="3480009"/>
+                  </a:lnTo>
+                  <a:lnTo>
+                    <a:pt x="5745558" y="3479496"/>
+                  </a:lnTo>
+                  <a:lnTo>
+                    <a:pt x="5668315" y="3478912"/>
+                  </a:lnTo>
+                  <a:lnTo>
+                    <a:pt x="5591071" y="3478248"/>
+                  </a:lnTo>
+                  <a:lnTo>
+                    <a:pt x="5513828" y="3477493"/>
+                  </a:lnTo>
+                  <a:lnTo>
+                    <a:pt x="5436584" y="3476634"/>
+                  </a:lnTo>
+                  <a:lnTo>
+                    <a:pt x="5359341" y="3475657"/>
+                  </a:lnTo>
+                  <a:lnTo>
+                    <a:pt x="5282097" y="3474546"/>
+                  </a:lnTo>
+                  <a:lnTo>
+                    <a:pt x="5204853" y="3473282"/>
+                  </a:lnTo>
+                  <a:lnTo>
+                    <a:pt x="5127610" y="3471845"/>
+                  </a:lnTo>
+                  <a:lnTo>
+                    <a:pt x="5050366" y="3470211"/>
+                  </a:lnTo>
+                  <a:lnTo>
+                    <a:pt x="4973123" y="3468351"/>
+                  </a:lnTo>
+                  <a:lnTo>
+                    <a:pt x="4895879" y="3466237"/>
+                  </a:lnTo>
+                  <a:lnTo>
+                    <a:pt x="4818636" y="3463832"/>
+                  </a:lnTo>
+                  <a:lnTo>
+                    <a:pt x="4741392" y="3461096"/>
+                  </a:lnTo>
+                  <a:lnTo>
+                    <a:pt x="4664148" y="3457985"/>
+                  </a:lnTo>
+                  <a:lnTo>
+                    <a:pt x="4586905" y="3454447"/>
+                  </a:lnTo>
+                  <a:lnTo>
+                    <a:pt x="4509661" y="3450423"/>
+                  </a:lnTo>
+                  <a:lnTo>
+                    <a:pt x="4432418" y="3445846"/>
+                  </a:lnTo>
+                  <a:lnTo>
+                    <a:pt x="4355174" y="3440640"/>
+                  </a:lnTo>
+                  <a:lnTo>
+                    <a:pt x="4277931" y="3434719"/>
+                  </a:lnTo>
+                  <a:lnTo>
+                    <a:pt x="4200687" y="3427985"/>
+                  </a:lnTo>
+                  <a:lnTo>
+                    <a:pt x="4123443" y="3420326"/>
+                  </a:lnTo>
+                  <a:lnTo>
+                    <a:pt x="4046200" y="3411616"/>
+                  </a:lnTo>
+                  <a:lnTo>
+                    <a:pt x="3968956" y="3401708"/>
+                  </a:lnTo>
+                  <a:lnTo>
+                    <a:pt x="3891713" y="3390440"/>
+                  </a:lnTo>
+                  <a:lnTo>
+                    <a:pt x="3814469" y="3377624"/>
+                  </a:lnTo>
+                  <a:lnTo>
+                    <a:pt x="3737226" y="3363048"/>
+                  </a:lnTo>
+                  <a:lnTo>
+                    <a:pt x="3659982" y="3346470"/>
+                  </a:lnTo>
+                  <a:lnTo>
+                    <a:pt x="3582738" y="3327615"/>
+                  </a:lnTo>
+                  <a:lnTo>
+                    <a:pt x="3505495" y="3306170"/>
+                  </a:lnTo>
+                  <a:lnTo>
+                    <a:pt x="3428251" y="3281779"/>
+                  </a:lnTo>
+                  <a:lnTo>
+                    <a:pt x="3351008" y="3254039"/>
+                  </a:lnTo>
+                  <a:lnTo>
+                    <a:pt x="3273764" y="3222488"/>
+                  </a:lnTo>
+                  <a:lnTo>
+                    <a:pt x="3196521" y="3186604"/>
+                  </a:lnTo>
+                  <a:lnTo>
+                    <a:pt x="3119277" y="3145790"/>
+                  </a:lnTo>
+                  <a:lnTo>
+                    <a:pt x="3042033" y="3099371"/>
+                  </a:lnTo>
+                  <a:lnTo>
+                    <a:pt x="2964790" y="3046577"/>
+                  </a:lnTo>
+                  <a:lnTo>
+                    <a:pt x="2887546" y="2986530"/>
+                  </a:lnTo>
+                  <a:lnTo>
+                    <a:pt x="2810303" y="2918237"/>
+                  </a:lnTo>
+                  <a:lnTo>
+                    <a:pt x="2733059" y="2840563"/>
+                  </a:lnTo>
+                  <a:lnTo>
+                    <a:pt x="2655816" y="2752220"/>
+                  </a:lnTo>
+                  <a:lnTo>
+                    <a:pt x="2578572" y="2653436"/>
+                  </a:lnTo>
+                  <a:lnTo>
+                    <a:pt x="2501328" y="2616996"/>
+                  </a:lnTo>
+                  <a:lnTo>
+                    <a:pt x="2424085" y="2578956"/>
+                  </a:lnTo>
+                  <a:lnTo>
+                    <a:pt x="2346841" y="2539246"/>
+                  </a:lnTo>
+                  <a:lnTo>
+                    <a:pt x="2269598" y="2497794"/>
+                  </a:lnTo>
+                  <a:lnTo>
+                    <a:pt x="2192354" y="2454522"/>
+                  </a:lnTo>
+                  <a:lnTo>
+                    <a:pt x="2115111" y="2409352"/>
+                  </a:lnTo>
+                  <a:lnTo>
+                    <a:pt x="2037867" y="2362199"/>
+                  </a:lnTo>
+                  <a:lnTo>
+                    <a:pt x="1960623" y="2312976"/>
+                  </a:lnTo>
+                  <a:lnTo>
+                    <a:pt x="1883380" y="2261594"/>
+                  </a:lnTo>
+                  <a:lnTo>
+                    <a:pt x="1806136" y="2207956"/>
+                  </a:lnTo>
+                  <a:lnTo>
+                    <a:pt x="1728893" y="2151964"/>
+                  </a:lnTo>
+                  <a:lnTo>
+                    <a:pt x="1651649" y="2093515"/>
+                  </a:lnTo>
+                  <a:lnTo>
+                    <a:pt x="1574405" y="2032500"/>
+                  </a:lnTo>
+                  <a:lnTo>
+                    <a:pt x="1497162" y="1968808"/>
+                  </a:lnTo>
+                  <a:lnTo>
+                    <a:pt x="1419918" y="1902320"/>
+                  </a:lnTo>
+                  <a:lnTo>
+                    <a:pt x="1342675" y="1832914"/>
+                  </a:lnTo>
+                  <a:lnTo>
+                    <a:pt x="1265431" y="1760463"/>
+                  </a:lnTo>
+                  <a:lnTo>
+                    <a:pt x="1188188" y="1684831"/>
+                  </a:lnTo>
+                  <a:lnTo>
+                    <a:pt x="1110944" y="1605881"/>
+                  </a:lnTo>
+                  <a:lnTo>
+                    <a:pt x="1033700" y="1523465"/>
+                  </a:lnTo>
+                  <a:lnTo>
+                    <a:pt x="956457" y="1437432"/>
+                  </a:lnTo>
+                  <a:lnTo>
+                    <a:pt x="879213" y="1347623"/>
+                  </a:lnTo>
+                  <a:lnTo>
+                    <a:pt x="801970" y="1253873"/>
+                  </a:lnTo>
+                  <a:lnTo>
+                    <a:pt x="724726" y="1156008"/>
+                  </a:lnTo>
+                  <a:lnTo>
+                    <a:pt x="647483" y="1053849"/>
+                  </a:lnTo>
+                  <a:lnTo>
+                    <a:pt x="570239" y="947205"/>
+                  </a:lnTo>
+                  <a:lnTo>
+                    <a:pt x="492995" y="835882"/>
+                  </a:lnTo>
+                  <a:lnTo>
+                    <a:pt x="415752" y="719672"/>
+                  </a:lnTo>
+                  <a:lnTo>
+                    <a:pt x="338508" y="598362"/>
+                  </a:lnTo>
+                  <a:lnTo>
+                    <a:pt x="261265" y="471729"/>
+                  </a:lnTo>
+                  <a:lnTo>
+                    <a:pt x="184021" y="339537"/>
+                  </a:lnTo>
+                  <a:lnTo>
+                    <a:pt x="106778" y="201544"/>
+                  </a:lnTo>
+                  <a:lnTo>
+                    <a:pt x="29534" y="57495"/>
                   </a:lnTo>
                   <a:lnTo>
                     <a:pt x="0" y="0"/>
@@ -3495,210 +3495,210 @@
           </p:nvSpPr>
           <p:spPr>
             <a:xfrm>
-              <a:off x="3256730" y="1896563"/>
-              <a:ext cx="4952828" cy="3563283"/>
+              <a:off x="3256730" y="2073503"/>
+              <a:ext cx="4952828" cy="3398518"/>
             </a:xfrm>
             <a:custGeom>
               <a:avLst/>
               <a:pathLst>
-                <a:path w="4952828" h="3563283">
+                <a:path w="4952828" h="3398518">
                   <a:moveTo>
                     <a:pt x="0" y="0"/>
                   </a:moveTo>
                   <a:lnTo>
-                    <a:pt x="9239" y="59041"/>
-                  </a:lnTo>
-                  <a:lnTo>
-                    <a:pt x="86483" y="493021"/>
-                  </a:lnTo>
-                  <a:lnTo>
-                    <a:pt x="163726" y="874593"/>
-                  </a:lnTo>
-                  <a:lnTo>
-                    <a:pt x="240970" y="1210083"/>
-                  </a:lnTo>
-                  <a:lnTo>
-                    <a:pt x="318213" y="1505059"/>
-                  </a:lnTo>
-                  <a:lnTo>
-                    <a:pt x="395457" y="1764411"/>
-                  </a:lnTo>
-                  <a:lnTo>
-                    <a:pt x="472700" y="1992443"/>
-                  </a:lnTo>
-                  <a:lnTo>
-                    <a:pt x="549944" y="2192937"/>
-                  </a:lnTo>
-                  <a:lnTo>
-                    <a:pt x="627188" y="2369218"/>
-                  </a:lnTo>
-                  <a:lnTo>
-                    <a:pt x="704431" y="2524211"/>
-                  </a:lnTo>
-                  <a:lnTo>
-                    <a:pt x="781675" y="2660486"/>
-                  </a:lnTo>
-                  <a:lnTo>
-                    <a:pt x="858918" y="2780304"/>
-                  </a:lnTo>
-                  <a:lnTo>
-                    <a:pt x="936162" y="2818680"/>
-                  </a:lnTo>
-                  <a:lnTo>
-                    <a:pt x="1013405" y="2853742"/>
-                  </a:lnTo>
-                  <a:lnTo>
-                    <a:pt x="1090649" y="2887330"/>
-                  </a:lnTo>
-                  <a:lnTo>
-                    <a:pt x="1167893" y="2919506"/>
-                  </a:lnTo>
-                  <a:lnTo>
-                    <a:pt x="1245136" y="2950329"/>
-                  </a:lnTo>
-                  <a:lnTo>
-                    <a:pt x="1322380" y="2979856"/>
-                  </a:lnTo>
-                  <a:lnTo>
-                    <a:pt x="1399623" y="3008142"/>
-                  </a:lnTo>
-                  <a:lnTo>
-                    <a:pt x="1476867" y="3035239"/>
-                  </a:lnTo>
-                  <a:lnTo>
-                    <a:pt x="1554110" y="3061196"/>
-                  </a:lnTo>
-                  <a:lnTo>
-                    <a:pt x="1631354" y="3086062"/>
-                  </a:lnTo>
-                  <a:lnTo>
-                    <a:pt x="1708598" y="3109883"/>
-                  </a:lnTo>
-                  <a:lnTo>
-                    <a:pt x="1785841" y="3132702"/>
-                  </a:lnTo>
-                  <a:lnTo>
-                    <a:pt x="1863085" y="3154562"/>
-                  </a:lnTo>
-                  <a:lnTo>
-                    <a:pt x="1940328" y="3175503"/>
-                  </a:lnTo>
-                  <a:lnTo>
-                    <a:pt x="2017572" y="3195563"/>
-                  </a:lnTo>
-                  <a:lnTo>
-                    <a:pt x="2094816" y="3214780"/>
-                  </a:lnTo>
-                  <a:lnTo>
-                    <a:pt x="2172059" y="3233189"/>
-                  </a:lnTo>
-                  <a:lnTo>
-                    <a:pt x="2249303" y="3250824"/>
-                  </a:lnTo>
-                  <a:lnTo>
-                    <a:pt x="2326546" y="3267718"/>
-                  </a:lnTo>
-                  <a:lnTo>
-                    <a:pt x="2403790" y="3283901"/>
-                  </a:lnTo>
-                  <a:lnTo>
-                    <a:pt x="2481033" y="3299404"/>
-                  </a:lnTo>
-                  <a:lnTo>
-                    <a:pt x="2558277" y="3314255"/>
-                  </a:lnTo>
-                  <a:lnTo>
-                    <a:pt x="2635521" y="3328482"/>
-                  </a:lnTo>
-                  <a:lnTo>
-                    <a:pt x="2712764" y="3342111"/>
-                  </a:lnTo>
-                  <a:lnTo>
-                    <a:pt x="2790008" y="3355166"/>
-                  </a:lnTo>
-                  <a:lnTo>
-                    <a:pt x="2867251" y="3367673"/>
-                  </a:lnTo>
-                  <a:lnTo>
-                    <a:pt x="2944495" y="3379654"/>
-                  </a:lnTo>
-                  <a:lnTo>
-                    <a:pt x="3021738" y="3391131"/>
-                  </a:lnTo>
-                  <a:lnTo>
-                    <a:pt x="3098982" y="3402126"/>
-                  </a:lnTo>
-                  <a:lnTo>
-                    <a:pt x="3176226" y="3412658"/>
-                  </a:lnTo>
-                  <a:lnTo>
-                    <a:pt x="3253469" y="3422748"/>
-                  </a:lnTo>
-                  <a:lnTo>
-                    <a:pt x="3330713" y="3432413"/>
-                  </a:lnTo>
-                  <a:lnTo>
-                    <a:pt x="3407956" y="3441673"/>
-                  </a:lnTo>
-                  <a:lnTo>
-                    <a:pt x="3485200" y="3450542"/>
-                  </a:lnTo>
-                  <a:lnTo>
-                    <a:pt x="3562443" y="3459039"/>
-                  </a:lnTo>
-                  <a:lnTo>
-                    <a:pt x="3639687" y="3467179"/>
-                  </a:lnTo>
-                  <a:lnTo>
-                    <a:pt x="3716931" y="3474976"/>
-                  </a:lnTo>
-                  <a:lnTo>
-                    <a:pt x="3794174" y="3482446"/>
-                  </a:lnTo>
-                  <a:lnTo>
-                    <a:pt x="3871418" y="3489602"/>
-                  </a:lnTo>
-                  <a:lnTo>
-                    <a:pt x="3948661" y="3496456"/>
-                  </a:lnTo>
-                  <a:lnTo>
-                    <a:pt x="4025905" y="3503023"/>
-                  </a:lnTo>
-                  <a:lnTo>
-                    <a:pt x="4103148" y="3509313"/>
-                  </a:lnTo>
-                  <a:lnTo>
-                    <a:pt x="4180392" y="3515339"/>
-                  </a:lnTo>
-                  <a:lnTo>
-                    <a:pt x="4257636" y="3521112"/>
-                  </a:lnTo>
-                  <a:lnTo>
-                    <a:pt x="4334879" y="3526642"/>
-                  </a:lnTo>
-                  <a:lnTo>
-                    <a:pt x="4412123" y="3531939"/>
-                  </a:lnTo>
-                  <a:lnTo>
-                    <a:pt x="4489366" y="3537014"/>
-                  </a:lnTo>
-                  <a:lnTo>
-                    <a:pt x="4566610" y="3541875"/>
-                  </a:lnTo>
-                  <a:lnTo>
-                    <a:pt x="4643853" y="3546532"/>
-                  </a:lnTo>
-                  <a:lnTo>
-                    <a:pt x="4721097" y="3550994"/>
-                  </a:lnTo>
-                  <a:lnTo>
-                    <a:pt x="4798341" y="3555267"/>
-                  </a:lnTo>
-                  <a:lnTo>
-                    <a:pt x="4875584" y="3559361"/>
-                  </a:lnTo>
-                  <a:lnTo>
-                    <a:pt x="4952828" y="3563283"/>
+                    <a:pt x="9239" y="56311"/>
+                  </a:lnTo>
+                  <a:lnTo>
+                    <a:pt x="86483" y="470224"/>
+                  </a:lnTo>
+                  <a:lnTo>
+                    <a:pt x="163726" y="834152"/>
+                  </a:lnTo>
+                  <a:lnTo>
+                    <a:pt x="240970" y="1154130"/>
+                  </a:lnTo>
+                  <a:lnTo>
+                    <a:pt x="318213" y="1435465"/>
+                  </a:lnTo>
+                  <a:lnTo>
+                    <a:pt x="395457" y="1682826"/>
+                  </a:lnTo>
+                  <a:lnTo>
+                    <a:pt x="472700" y="1900314"/>
+                  </a:lnTo>
+                  <a:lnTo>
+                    <a:pt x="549944" y="2091537"/>
+                  </a:lnTo>
+                  <a:lnTo>
+                    <a:pt x="627188" y="2259666"/>
+                  </a:lnTo>
+                  <a:lnTo>
+                    <a:pt x="704431" y="2407492"/>
+                  </a:lnTo>
+                  <a:lnTo>
+                    <a:pt x="781675" y="2537466"/>
+                  </a:lnTo>
+                  <a:lnTo>
+                    <a:pt x="858918" y="2651743"/>
+                  </a:lnTo>
+                  <a:lnTo>
+                    <a:pt x="936162" y="2688345"/>
+                  </a:lnTo>
+                  <a:lnTo>
+                    <a:pt x="1013405" y="2721786"/>
+                  </a:lnTo>
+                  <a:lnTo>
+                    <a:pt x="1090649" y="2753821"/>
+                  </a:lnTo>
+                  <a:lnTo>
+                    <a:pt x="1167893" y="2784509"/>
+                  </a:lnTo>
+                  <a:lnTo>
+                    <a:pt x="1245136" y="2813907"/>
+                  </a:lnTo>
+                  <a:lnTo>
+                    <a:pt x="1322380" y="2842069"/>
+                  </a:lnTo>
+                  <a:lnTo>
+                    <a:pt x="1399623" y="2869047"/>
+                  </a:lnTo>
+                  <a:lnTo>
+                    <a:pt x="1476867" y="2894890"/>
+                  </a:lnTo>
+                  <a:lnTo>
+                    <a:pt x="1554110" y="2919648"/>
+                  </a:lnTo>
+                  <a:lnTo>
+                    <a:pt x="1631354" y="2943364"/>
+                  </a:lnTo>
+                  <a:lnTo>
+                    <a:pt x="1708598" y="2966083"/>
+                  </a:lnTo>
+                  <a:lnTo>
+                    <a:pt x="1785841" y="2987847"/>
+                  </a:lnTo>
+                  <a:lnTo>
+                    <a:pt x="1863085" y="3008696"/>
+                  </a:lnTo>
+                  <a:lnTo>
+                    <a:pt x="1940328" y="3028669"/>
+                  </a:lnTo>
+                  <a:lnTo>
+                    <a:pt x="2017572" y="3047801"/>
+                  </a:lnTo>
+                  <a:lnTo>
+                    <a:pt x="2094816" y="3066130"/>
+                  </a:lnTo>
+                  <a:lnTo>
+                    <a:pt x="2172059" y="3083687"/>
+                  </a:lnTo>
+                  <a:lnTo>
+                    <a:pt x="2249303" y="3100507"/>
+                  </a:lnTo>
+                  <a:lnTo>
+                    <a:pt x="2326546" y="3116620"/>
+                  </a:lnTo>
+                  <a:lnTo>
+                    <a:pt x="2403790" y="3132055"/>
+                  </a:lnTo>
+                  <a:lnTo>
+                    <a:pt x="2481033" y="3146841"/>
+                  </a:lnTo>
+                  <a:lnTo>
+                    <a:pt x="2558277" y="3161005"/>
+                  </a:lnTo>
+                  <a:lnTo>
+                    <a:pt x="2635521" y="3174574"/>
+                  </a:lnTo>
+                  <a:lnTo>
+                    <a:pt x="2712764" y="3187573"/>
+                  </a:lnTo>
+                  <a:lnTo>
+                    <a:pt x="2790008" y="3200025"/>
+                  </a:lnTo>
+                  <a:lnTo>
+                    <a:pt x="2867251" y="3211953"/>
+                  </a:lnTo>
+                  <a:lnTo>
+                    <a:pt x="2944495" y="3223380"/>
+                  </a:lnTo>
+                  <a:lnTo>
+                    <a:pt x="3021738" y="3234327"/>
+                  </a:lnTo>
+                  <a:lnTo>
+                    <a:pt x="3098982" y="3244813"/>
+                  </a:lnTo>
+                  <a:lnTo>
+                    <a:pt x="3176226" y="3254858"/>
+                  </a:lnTo>
+                  <a:lnTo>
+                    <a:pt x="3253469" y="3264481"/>
+                  </a:lnTo>
+                  <a:lnTo>
+                    <a:pt x="3330713" y="3273700"/>
+                  </a:lnTo>
+                  <a:lnTo>
+                    <a:pt x="3407956" y="3282531"/>
+                  </a:lnTo>
+                  <a:lnTo>
+                    <a:pt x="3485200" y="3290991"/>
+                  </a:lnTo>
+                  <a:lnTo>
+                    <a:pt x="3562443" y="3299095"/>
+                  </a:lnTo>
+                  <a:lnTo>
+                    <a:pt x="3639687" y="3306858"/>
+                  </a:lnTo>
+                  <a:lnTo>
+                    <a:pt x="3716931" y="3314295"/>
+                  </a:lnTo>
+                  <a:lnTo>
+                    <a:pt x="3794174" y="3321419"/>
+                  </a:lnTo>
+                  <a:lnTo>
+                    <a:pt x="3871418" y="3328244"/>
+                  </a:lnTo>
+                  <a:lnTo>
+                    <a:pt x="3948661" y="3334781"/>
+                  </a:lnTo>
+                  <a:lnTo>
+                    <a:pt x="4025905" y="3341044"/>
+                  </a:lnTo>
+                  <a:lnTo>
+                    <a:pt x="4103148" y="3347044"/>
+                  </a:lnTo>
+                  <a:lnTo>
+                    <a:pt x="4180392" y="3352791"/>
+                  </a:lnTo>
+                  <a:lnTo>
+                    <a:pt x="4257636" y="3358297"/>
+                  </a:lnTo>
+                  <a:lnTo>
+                    <a:pt x="4334879" y="3363571"/>
+                  </a:lnTo>
+                  <a:lnTo>
+                    <a:pt x="4412123" y="3368624"/>
+                  </a:lnTo>
+                  <a:lnTo>
+                    <a:pt x="4489366" y="3373464"/>
+                  </a:lnTo>
+                  <a:lnTo>
+                    <a:pt x="4566610" y="3378100"/>
+                  </a:lnTo>
+                  <a:lnTo>
+                    <a:pt x="4643853" y="3382542"/>
+                  </a:lnTo>
+                  <a:lnTo>
+                    <a:pt x="4721097" y="3386797"/>
+                  </a:lnTo>
+                  <a:lnTo>
+                    <a:pt x="4798341" y="3390873"/>
+                  </a:lnTo>
+                  <a:lnTo>
+                    <a:pt x="4875584" y="3394778"/>
+                  </a:lnTo>
+                  <a:lnTo>
+                    <a:pt x="4952828" y="3398518"/>
                   </a:lnTo>
                 </a:path>
               </a:pathLst>
@@ -3718,273 +3718,273 @@
           </p:nvSpPr>
           <p:spPr>
             <a:xfrm>
-              <a:off x="1537077" y="1896563"/>
-              <a:ext cx="6672481" cy="3651692"/>
+              <a:off x="1537077" y="2073503"/>
+              <a:ext cx="6672481" cy="3482839"/>
             </a:xfrm>
             <a:custGeom>
               <a:avLst/>
               <a:pathLst>
-                <a:path w="6672481" h="3651692">
+                <a:path w="6672481" h="3482839">
                   <a:moveTo>
-                    <a:pt x="6672481" y="3651692"/>
+                    <a:pt x="6672481" y="3482839"/>
                   </a:moveTo>
                   <a:lnTo>
-                    <a:pt x="6595238" y="3651561"/>
-                  </a:lnTo>
-                  <a:lnTo>
-                    <a:pt x="6517994" y="3651413"/>
-                  </a:lnTo>
-                  <a:lnTo>
-                    <a:pt x="6440751" y="3651244"/>
-                  </a:lnTo>
-                  <a:lnTo>
-                    <a:pt x="6363507" y="3651052"/>
-                  </a:lnTo>
-                  <a:lnTo>
-                    <a:pt x="6286263" y="3650833"/>
-                  </a:lnTo>
-                  <a:lnTo>
-                    <a:pt x="6209020" y="3650584"/>
-                  </a:lnTo>
-                  <a:lnTo>
-                    <a:pt x="6131776" y="3650302"/>
-                  </a:lnTo>
-                  <a:lnTo>
-                    <a:pt x="6054533" y="3649980"/>
-                  </a:lnTo>
-                  <a:lnTo>
-                    <a:pt x="5977289" y="3649614"/>
-                  </a:lnTo>
-                  <a:lnTo>
-                    <a:pt x="5900046" y="3649198"/>
-                  </a:lnTo>
-                  <a:lnTo>
-                    <a:pt x="5822802" y="3648725"/>
-                  </a:lnTo>
-                  <a:lnTo>
-                    <a:pt x="5745558" y="3648187"/>
-                  </a:lnTo>
-                  <a:lnTo>
-                    <a:pt x="5668315" y="3647575"/>
-                  </a:lnTo>
-                  <a:lnTo>
-                    <a:pt x="5591071" y="3646879"/>
-                  </a:lnTo>
-                  <a:lnTo>
-                    <a:pt x="5513828" y="3646087"/>
-                  </a:lnTo>
-                  <a:lnTo>
-                    <a:pt x="5436584" y="3645186"/>
-                  </a:lnTo>
-                  <a:lnTo>
-                    <a:pt x="5359341" y="3644162"/>
-                  </a:lnTo>
-                  <a:lnTo>
-                    <a:pt x="5282097" y="3642997"/>
-                  </a:lnTo>
-                  <a:lnTo>
-                    <a:pt x="5204853" y="3641672"/>
-                  </a:lnTo>
-                  <a:lnTo>
-                    <a:pt x="5127610" y="3640165"/>
-                  </a:lnTo>
-                  <a:lnTo>
-                    <a:pt x="5050366" y="3638451"/>
-                  </a:lnTo>
-                  <a:lnTo>
-                    <a:pt x="4973123" y="3636502"/>
-                  </a:lnTo>
-                  <a:lnTo>
-                    <a:pt x="4895879" y="3634285"/>
-                  </a:lnTo>
-                  <a:lnTo>
-                    <a:pt x="4818636" y="3631763"/>
-                  </a:lnTo>
-                  <a:lnTo>
-                    <a:pt x="4741392" y="3628895"/>
-                  </a:lnTo>
-                  <a:lnTo>
-                    <a:pt x="4664148" y="3625633"/>
-                  </a:lnTo>
-                  <a:lnTo>
-                    <a:pt x="4586905" y="3621924"/>
-                  </a:lnTo>
-                  <a:lnTo>
-                    <a:pt x="4509661" y="3617704"/>
-                  </a:lnTo>
-                  <a:lnTo>
-                    <a:pt x="4432418" y="3612905"/>
-                  </a:lnTo>
-                  <a:lnTo>
-                    <a:pt x="4355174" y="3607447"/>
-                  </a:lnTo>
-                  <a:lnTo>
-                    <a:pt x="4277931" y="3601239"/>
-                  </a:lnTo>
-                  <a:lnTo>
-                    <a:pt x="4200687" y="3594179"/>
-                  </a:lnTo>
-                  <a:lnTo>
-                    <a:pt x="4123443" y="3586149"/>
-                  </a:lnTo>
-                  <a:lnTo>
-                    <a:pt x="4046200" y="3577015"/>
-                  </a:lnTo>
-                  <a:lnTo>
-                    <a:pt x="3968956" y="3566628"/>
-                  </a:lnTo>
-                  <a:lnTo>
-                    <a:pt x="3891713" y="3554813"/>
-                  </a:lnTo>
-                  <a:lnTo>
-                    <a:pt x="3814469" y="3541376"/>
-                  </a:lnTo>
-                  <a:lnTo>
-                    <a:pt x="3737226" y="3526093"/>
-                  </a:lnTo>
-                  <a:lnTo>
-                    <a:pt x="3659982" y="3508712"/>
-                  </a:lnTo>
-                  <a:lnTo>
-                    <a:pt x="3582738" y="3488942"/>
-                  </a:lnTo>
-                  <a:lnTo>
-                    <a:pt x="3505495" y="3466458"/>
-                  </a:lnTo>
-                  <a:lnTo>
-                    <a:pt x="3428251" y="3440885"/>
-                  </a:lnTo>
-                  <a:lnTo>
-                    <a:pt x="3351008" y="3411799"/>
-                  </a:lnTo>
-                  <a:lnTo>
-                    <a:pt x="3273764" y="3378719"/>
-                  </a:lnTo>
-                  <a:lnTo>
-                    <a:pt x="3196521" y="3341094"/>
-                  </a:lnTo>
-                  <a:lnTo>
-                    <a:pt x="3119277" y="3298303"/>
-                  </a:lnTo>
-                  <a:lnTo>
-                    <a:pt x="3042033" y="3249633"/>
-                  </a:lnTo>
-                  <a:lnTo>
-                    <a:pt x="2964790" y="3194279"/>
-                  </a:lnTo>
-                  <a:lnTo>
-                    <a:pt x="2887546" y="3131322"/>
-                  </a:lnTo>
-                  <a:lnTo>
-                    <a:pt x="2810303" y="3059717"/>
-                  </a:lnTo>
-                  <a:lnTo>
-                    <a:pt x="2733059" y="2978277"/>
-                  </a:lnTo>
-                  <a:lnTo>
-                    <a:pt x="2655816" y="2885652"/>
-                  </a:lnTo>
-                  <a:lnTo>
-                    <a:pt x="2578572" y="2782079"/>
-                  </a:lnTo>
-                  <a:lnTo>
-                    <a:pt x="2501328" y="2743871"/>
-                  </a:lnTo>
-                  <a:lnTo>
-                    <a:pt x="2424085" y="2703987"/>
-                  </a:lnTo>
-                  <a:lnTo>
-                    <a:pt x="2346841" y="2662352"/>
-                  </a:lnTo>
-                  <a:lnTo>
-                    <a:pt x="2269598" y="2618890"/>
-                  </a:lnTo>
-                  <a:lnTo>
-                    <a:pt x="2192354" y="2573521"/>
-                  </a:lnTo>
-                  <a:lnTo>
-                    <a:pt x="2115111" y="2526161"/>
-                  </a:lnTo>
-                  <a:lnTo>
-                    <a:pt x="2037867" y="2476722"/>
-                  </a:lnTo>
-                  <a:lnTo>
-                    <a:pt x="1960623" y="2425113"/>
-                  </a:lnTo>
-                  <a:lnTo>
-                    <a:pt x="1883380" y="2371239"/>
-                  </a:lnTo>
-                  <a:lnTo>
-                    <a:pt x="1806136" y="2315001"/>
-                  </a:lnTo>
-                  <a:lnTo>
-                    <a:pt x="1728893" y="2256294"/>
-                  </a:lnTo>
-                  <a:lnTo>
-                    <a:pt x="1651649" y="2195011"/>
-                  </a:lnTo>
-                  <a:lnTo>
-                    <a:pt x="1574405" y="2131039"/>
-                  </a:lnTo>
-                  <a:lnTo>
-                    <a:pt x="1497162" y="2064258"/>
-                  </a:lnTo>
-                  <a:lnTo>
-                    <a:pt x="1419918" y="1994547"/>
-                  </a:lnTo>
-                  <a:lnTo>
-                    <a:pt x="1342675" y="1921777"/>
-                  </a:lnTo>
-                  <a:lnTo>
-                    <a:pt x="1265431" y="1845812"/>
-                  </a:lnTo>
-                  <a:lnTo>
-                    <a:pt x="1188188" y="1766514"/>
-                  </a:lnTo>
-                  <a:lnTo>
-                    <a:pt x="1110944" y="1683736"/>
-                  </a:lnTo>
-                  <a:lnTo>
-                    <a:pt x="1033700" y="1597324"/>
-                  </a:lnTo>
-                  <a:lnTo>
-                    <a:pt x="956457" y="1507121"/>
-                  </a:lnTo>
-                  <a:lnTo>
-                    <a:pt x="879213" y="1412958"/>
-                  </a:lnTo>
-                  <a:lnTo>
-                    <a:pt x="801970" y="1314663"/>
-                  </a:lnTo>
-                  <a:lnTo>
-                    <a:pt x="724726" y="1212053"/>
-                  </a:lnTo>
-                  <a:lnTo>
-                    <a:pt x="647483" y="1104941"/>
-                  </a:lnTo>
-                  <a:lnTo>
-                    <a:pt x="570239" y="993127"/>
-                  </a:lnTo>
-                  <a:lnTo>
-                    <a:pt x="492995" y="876406"/>
-                  </a:lnTo>
-                  <a:lnTo>
-                    <a:pt x="415752" y="754563"/>
-                  </a:lnTo>
-                  <a:lnTo>
-                    <a:pt x="338508" y="627372"/>
-                  </a:lnTo>
-                  <a:lnTo>
-                    <a:pt x="261265" y="494599"/>
-                  </a:lnTo>
-                  <a:lnTo>
-                    <a:pt x="184021" y="355999"/>
-                  </a:lnTo>
-                  <a:lnTo>
-                    <a:pt x="106778" y="211315"/>
-                  </a:lnTo>
-                  <a:lnTo>
-                    <a:pt x="29534" y="60282"/>
+                    <a:pt x="6595238" y="3482715"/>
+                  </a:lnTo>
+                  <a:lnTo>
+                    <a:pt x="6517994" y="3482573"/>
+                  </a:lnTo>
+                  <a:lnTo>
+                    <a:pt x="6440751" y="3482412"/>
+                  </a:lnTo>
+                  <a:lnTo>
+                    <a:pt x="6363507" y="3482228"/>
+                  </a:lnTo>
+                  <a:lnTo>
+                    <a:pt x="6286263" y="3482020"/>
+                  </a:lnTo>
+                  <a:lnTo>
+                    <a:pt x="6209020" y="3481783"/>
+                  </a:lnTo>
+                  <a:lnTo>
+                    <a:pt x="6131776" y="3481513"/>
+                  </a:lnTo>
+                  <a:lnTo>
+                    <a:pt x="6054533" y="3481206"/>
+                  </a:lnTo>
+                  <a:lnTo>
+                    <a:pt x="5977289" y="3480857"/>
+                  </a:lnTo>
+                  <a:lnTo>
+                    <a:pt x="5900046" y="3480461"/>
+                  </a:lnTo>
+                  <a:lnTo>
+                    <a:pt x="5822802" y="3480009"/>
+                  </a:lnTo>
+                  <a:lnTo>
+                    <a:pt x="5745558" y="3479496"/>
+                  </a:lnTo>
+                  <a:lnTo>
+                    <a:pt x="5668315" y="3478912"/>
+                  </a:lnTo>
+                  <a:lnTo>
+                    <a:pt x="5591071" y="3478248"/>
+                  </a:lnTo>
+                  <a:lnTo>
+                    <a:pt x="5513828" y="3477493"/>
+                  </a:lnTo>
+                  <a:lnTo>
+                    <a:pt x="5436584" y="3476634"/>
+                  </a:lnTo>
+                  <a:lnTo>
+                    <a:pt x="5359341" y="3475657"/>
+                  </a:lnTo>
+                  <a:lnTo>
+                    <a:pt x="5282097" y="3474546"/>
+                  </a:lnTo>
+                  <a:lnTo>
+                    <a:pt x="5204853" y="3473282"/>
+                  </a:lnTo>
+                  <a:lnTo>
+                    <a:pt x="5127610" y="3471845"/>
+                  </a:lnTo>
+                  <a:lnTo>
+                    <a:pt x="5050366" y="3470211"/>
+                  </a:lnTo>
+                  <a:lnTo>
+                    <a:pt x="4973123" y="3468351"/>
+                  </a:lnTo>
+                  <a:lnTo>
+                    <a:pt x="4895879" y="3466237"/>
+                  </a:lnTo>
+                  <a:lnTo>
+                    <a:pt x="4818636" y="3463832"/>
+                  </a:lnTo>
+                  <a:lnTo>
+                    <a:pt x="4741392" y="3461096"/>
+                  </a:lnTo>
+                  <a:lnTo>
+                    <a:pt x="4664148" y="3457985"/>
+                  </a:lnTo>
+                  <a:lnTo>
+                    <a:pt x="4586905" y="3454447"/>
+                  </a:lnTo>
+                  <a:lnTo>
+                    <a:pt x="4509661" y="3450423"/>
+                  </a:lnTo>
+                  <a:lnTo>
+                    <a:pt x="4432418" y="3445846"/>
+                  </a:lnTo>
+                  <a:lnTo>
+                    <a:pt x="4355174" y="3440640"/>
+                  </a:lnTo>
+                  <a:lnTo>
+                    <a:pt x="4277931" y="3434719"/>
+                  </a:lnTo>
+                  <a:lnTo>
+                    <a:pt x="4200687" y="3427985"/>
+                  </a:lnTo>
+                  <a:lnTo>
+                    <a:pt x="4123443" y="3420326"/>
+                  </a:lnTo>
+                  <a:lnTo>
+                    <a:pt x="4046200" y="3411616"/>
+                  </a:lnTo>
+                  <a:lnTo>
+                    <a:pt x="3968956" y="3401708"/>
+                  </a:lnTo>
+                  <a:lnTo>
+                    <a:pt x="3891713" y="3390440"/>
+                  </a:lnTo>
+                  <a:lnTo>
+                    <a:pt x="3814469" y="3377624"/>
+                  </a:lnTo>
+                  <a:lnTo>
+                    <a:pt x="3737226" y="3363048"/>
+                  </a:lnTo>
+                  <a:lnTo>
+                    <a:pt x="3659982" y="3346470"/>
+                  </a:lnTo>
+                  <a:lnTo>
+                    <a:pt x="3582738" y="3327615"/>
+                  </a:lnTo>
+                  <a:lnTo>
+                    <a:pt x="3505495" y="3306170"/>
+                  </a:lnTo>
+                  <a:lnTo>
+                    <a:pt x="3428251" y="3281779"/>
+                  </a:lnTo>
+                  <a:lnTo>
+                    <a:pt x="3351008" y="3254039"/>
+                  </a:lnTo>
+                  <a:lnTo>
+                    <a:pt x="3273764" y="3222488"/>
+                  </a:lnTo>
+                  <a:lnTo>
+                    <a:pt x="3196521" y="3186604"/>
+                  </a:lnTo>
+                  <a:lnTo>
+                    <a:pt x="3119277" y="3145790"/>
+                  </a:lnTo>
+                  <a:lnTo>
+                    <a:pt x="3042033" y="3099371"/>
+                  </a:lnTo>
+                  <a:lnTo>
+                    <a:pt x="2964790" y="3046577"/>
+                  </a:lnTo>
+                  <a:lnTo>
+                    <a:pt x="2887546" y="2986530"/>
+                  </a:lnTo>
+                  <a:lnTo>
+                    <a:pt x="2810303" y="2918237"/>
+                  </a:lnTo>
+                  <a:lnTo>
+                    <a:pt x="2733059" y="2840563"/>
+                  </a:lnTo>
+                  <a:lnTo>
+                    <a:pt x="2655816" y="2752220"/>
+                  </a:lnTo>
+                  <a:lnTo>
+                    <a:pt x="2578572" y="2653436"/>
+                  </a:lnTo>
+                  <a:lnTo>
+                    <a:pt x="2501328" y="2616996"/>
+                  </a:lnTo>
+                  <a:lnTo>
+                    <a:pt x="2424085" y="2578956"/>
+                  </a:lnTo>
+                  <a:lnTo>
+                    <a:pt x="2346841" y="2539246"/>
+                  </a:lnTo>
+                  <a:lnTo>
+                    <a:pt x="2269598" y="2497794"/>
+                  </a:lnTo>
+                  <a:lnTo>
+                    <a:pt x="2192354" y="2454522"/>
+                  </a:lnTo>
+                  <a:lnTo>
+                    <a:pt x="2115111" y="2409352"/>
+                  </a:lnTo>
+                  <a:lnTo>
+                    <a:pt x="2037867" y="2362199"/>
+                  </a:lnTo>
+                  <a:lnTo>
+                    <a:pt x="1960623" y="2312976"/>
+                  </a:lnTo>
+                  <a:lnTo>
+                    <a:pt x="1883380" y="2261594"/>
+                  </a:lnTo>
+                  <a:lnTo>
+                    <a:pt x="1806136" y="2207956"/>
+                  </a:lnTo>
+                  <a:lnTo>
+                    <a:pt x="1728893" y="2151964"/>
+                  </a:lnTo>
+                  <a:lnTo>
+                    <a:pt x="1651649" y="2093515"/>
+                  </a:lnTo>
+                  <a:lnTo>
+                    <a:pt x="1574405" y="2032500"/>
+                  </a:lnTo>
+                  <a:lnTo>
+                    <a:pt x="1497162" y="1968808"/>
+                  </a:lnTo>
+                  <a:lnTo>
+                    <a:pt x="1419918" y="1902320"/>
+                  </a:lnTo>
+                  <a:lnTo>
+                    <a:pt x="1342675" y="1832914"/>
+                  </a:lnTo>
+                  <a:lnTo>
+                    <a:pt x="1265431" y="1760463"/>
+                  </a:lnTo>
+                  <a:lnTo>
+                    <a:pt x="1188188" y="1684831"/>
+                  </a:lnTo>
+                  <a:lnTo>
+                    <a:pt x="1110944" y="1605881"/>
+                  </a:lnTo>
+                  <a:lnTo>
+                    <a:pt x="1033700" y="1523465"/>
+                  </a:lnTo>
+                  <a:lnTo>
+                    <a:pt x="956457" y="1437432"/>
+                  </a:lnTo>
+                  <a:lnTo>
+                    <a:pt x="879213" y="1347623"/>
+                  </a:lnTo>
+                  <a:lnTo>
+                    <a:pt x="801970" y="1253873"/>
+                  </a:lnTo>
+                  <a:lnTo>
+                    <a:pt x="724726" y="1156008"/>
+                  </a:lnTo>
+                  <a:lnTo>
+                    <a:pt x="647483" y="1053849"/>
+                  </a:lnTo>
+                  <a:lnTo>
+                    <a:pt x="570239" y="947205"/>
+                  </a:lnTo>
+                  <a:lnTo>
+                    <a:pt x="492995" y="835882"/>
+                  </a:lnTo>
+                  <a:lnTo>
+                    <a:pt x="415752" y="719672"/>
+                  </a:lnTo>
+                  <a:lnTo>
+                    <a:pt x="338508" y="598362"/>
+                  </a:lnTo>
+                  <a:lnTo>
+                    <a:pt x="261265" y="471729"/>
+                  </a:lnTo>
+                  <a:lnTo>
+                    <a:pt x="184021" y="339537"/>
+                  </a:lnTo>
+                  <a:lnTo>
+                    <a:pt x="106778" y="201544"/>
+                  </a:lnTo>
+                  <a:lnTo>
+                    <a:pt x="29534" y="57495"/>
                   </a:lnTo>
                   <a:lnTo>
                     <a:pt x="0" y="0"/>
@@ -4007,225 +4007,225 @@
           </p:nvSpPr>
           <p:spPr>
             <a:xfrm>
-              <a:off x="2826632" y="1896563"/>
-              <a:ext cx="5382926" cy="3643424"/>
+              <a:off x="2826632" y="2073503"/>
+              <a:ext cx="5382926" cy="3474953"/>
             </a:xfrm>
             <a:custGeom>
               <a:avLst/>
               <a:pathLst>
-                <a:path w="5382926" h="3643424">
+                <a:path w="5382926" h="3474953">
                   <a:moveTo>
                     <a:pt x="0" y="0"/>
                   </a:moveTo>
                   <a:lnTo>
-                    <a:pt x="53119" y="212043"/>
-                  </a:lnTo>
-                  <a:lnTo>
-                    <a:pt x="130363" y="495024"/>
-                  </a:lnTo>
-                  <a:lnTo>
-                    <a:pt x="207606" y="754730"/>
-                  </a:lnTo>
-                  <a:lnTo>
-                    <a:pt x="284850" y="993076"/>
-                  </a:lnTo>
-                  <a:lnTo>
-                    <a:pt x="362094" y="1211819"/>
-                  </a:lnTo>
-                  <a:lnTo>
-                    <a:pt x="439337" y="1412571"/>
-                  </a:lnTo>
-                  <a:lnTo>
-                    <a:pt x="516581" y="1596811"/>
-                  </a:lnTo>
-                  <a:lnTo>
-                    <a:pt x="593824" y="1765898"/>
-                  </a:lnTo>
-                  <a:lnTo>
-                    <a:pt x="671068" y="1921078"/>
-                  </a:lnTo>
-                  <a:lnTo>
-                    <a:pt x="748311" y="2063495"/>
-                  </a:lnTo>
-                  <a:lnTo>
-                    <a:pt x="825555" y="2194199"/>
-                  </a:lnTo>
-                  <a:lnTo>
-                    <a:pt x="902799" y="2314152"/>
-                  </a:lnTo>
-                  <a:lnTo>
-                    <a:pt x="980042" y="2424240"/>
-                  </a:lnTo>
-                  <a:lnTo>
-                    <a:pt x="1057286" y="2525273"/>
-                  </a:lnTo>
-                  <a:lnTo>
-                    <a:pt x="1134529" y="2617996"/>
-                  </a:lnTo>
-                  <a:lnTo>
-                    <a:pt x="1211773" y="2703093"/>
-                  </a:lnTo>
-                  <a:lnTo>
-                    <a:pt x="1289016" y="2781191"/>
-                  </a:lnTo>
-                  <a:lnTo>
-                    <a:pt x="1366260" y="2852866"/>
-                  </a:lnTo>
-                  <a:lnTo>
-                    <a:pt x="1443504" y="2918646"/>
-                  </a:lnTo>
-                  <a:lnTo>
-                    <a:pt x="1520747" y="2979015"/>
-                  </a:lnTo>
-                  <a:lnTo>
-                    <a:pt x="1597991" y="3034420"/>
-                  </a:lnTo>
-                  <a:lnTo>
-                    <a:pt x="1675234" y="3085267"/>
-                  </a:lnTo>
-                  <a:lnTo>
-                    <a:pt x="1752478" y="3131932"/>
-                  </a:lnTo>
-                  <a:lnTo>
-                    <a:pt x="1829721" y="3174759"/>
-                  </a:lnTo>
-                  <a:lnTo>
-                    <a:pt x="1906965" y="3214064"/>
-                  </a:lnTo>
-                  <a:lnTo>
-                    <a:pt x="1984209" y="3250136"/>
-                  </a:lnTo>
-                  <a:lnTo>
-                    <a:pt x="2061452" y="3283241"/>
-                  </a:lnTo>
-                  <a:lnTo>
-                    <a:pt x="2138696" y="3313624"/>
-                  </a:lnTo>
-                  <a:lnTo>
-                    <a:pt x="2215939" y="3341507"/>
-                  </a:lnTo>
-                  <a:lnTo>
-                    <a:pt x="2293183" y="3367097"/>
-                  </a:lnTo>
-                  <a:lnTo>
-                    <a:pt x="2370426" y="3390583"/>
-                  </a:lnTo>
-                  <a:lnTo>
-                    <a:pt x="2447670" y="3412137"/>
-                  </a:lnTo>
-                  <a:lnTo>
-                    <a:pt x="2524914" y="3431918"/>
-                  </a:lnTo>
-                  <a:lnTo>
-                    <a:pt x="2602157" y="3450072"/>
-                  </a:lnTo>
-                  <a:lnTo>
-                    <a:pt x="2679401" y="3466733"/>
-                  </a:lnTo>
-                  <a:lnTo>
-                    <a:pt x="2756644" y="3482024"/>
-                  </a:lnTo>
-                  <a:lnTo>
-                    <a:pt x="2833888" y="3496057"/>
-                  </a:lnTo>
-                  <a:lnTo>
-                    <a:pt x="2911131" y="3508935"/>
-                  </a:lnTo>
-                  <a:lnTo>
-                    <a:pt x="2988375" y="3520755"/>
-                  </a:lnTo>
-                  <a:lnTo>
-                    <a:pt x="3065619" y="3531603"/>
-                  </a:lnTo>
-                  <a:lnTo>
-                    <a:pt x="3142862" y="3541558"/>
-                  </a:lnTo>
-                  <a:lnTo>
-                    <a:pt x="3220106" y="3550694"/>
-                  </a:lnTo>
-                  <a:lnTo>
-                    <a:pt x="3297349" y="3559079"/>
-                  </a:lnTo>
-                  <a:lnTo>
-                    <a:pt x="3374593" y="3566775"/>
-                  </a:lnTo>
-                  <a:lnTo>
-                    <a:pt x="3451836" y="3573837"/>
-                  </a:lnTo>
-                  <a:lnTo>
-                    <a:pt x="3529080" y="3580319"/>
-                  </a:lnTo>
-                  <a:lnTo>
-                    <a:pt x="3606324" y="3586267"/>
-                  </a:lnTo>
-                  <a:lnTo>
-                    <a:pt x="3683567" y="3591727"/>
-                  </a:lnTo>
-                  <a:lnTo>
-                    <a:pt x="3760811" y="3596737"/>
-                  </a:lnTo>
-                  <a:lnTo>
-                    <a:pt x="3838054" y="3601335"/>
-                  </a:lnTo>
-                  <a:lnTo>
-                    <a:pt x="3915298" y="3605555"/>
-                  </a:lnTo>
-                  <a:lnTo>
-                    <a:pt x="3992541" y="3609428"/>
-                  </a:lnTo>
-                  <a:lnTo>
-                    <a:pt x="4069785" y="3612982"/>
-                  </a:lnTo>
-                  <a:lnTo>
-                    <a:pt x="4147029" y="3616244"/>
-                  </a:lnTo>
-                  <a:lnTo>
-                    <a:pt x="4224272" y="3619238"/>
-                  </a:lnTo>
-                  <a:lnTo>
-                    <a:pt x="4301516" y="3621986"/>
-                  </a:lnTo>
-                  <a:lnTo>
-                    <a:pt x="4378759" y="3624507"/>
-                  </a:lnTo>
-                  <a:lnTo>
-                    <a:pt x="4456003" y="3626821"/>
-                  </a:lnTo>
-                  <a:lnTo>
-                    <a:pt x="4533246" y="3628945"/>
-                  </a:lnTo>
-                  <a:lnTo>
-                    <a:pt x="4610490" y="3630894"/>
-                  </a:lnTo>
-                  <a:lnTo>
-                    <a:pt x="4687734" y="3632683"/>
-                  </a:lnTo>
-                  <a:lnTo>
-                    <a:pt x="4764977" y="3634325"/>
-                  </a:lnTo>
-                  <a:lnTo>
-                    <a:pt x="4842221" y="3635831"/>
-                  </a:lnTo>
-                  <a:lnTo>
-                    <a:pt x="4919464" y="3637214"/>
-                  </a:lnTo>
-                  <a:lnTo>
-                    <a:pt x="4996708" y="3638483"/>
-                  </a:lnTo>
-                  <a:lnTo>
-                    <a:pt x="5073951" y="3639648"/>
-                  </a:lnTo>
-                  <a:lnTo>
-                    <a:pt x="5151195" y="3640717"/>
-                  </a:lnTo>
-                  <a:lnTo>
-                    <a:pt x="5228439" y="3641697"/>
-                  </a:lnTo>
-                  <a:lnTo>
-                    <a:pt x="5305682" y="3642598"/>
-                  </a:lnTo>
-                  <a:lnTo>
-                    <a:pt x="5382926" y="3643424"/>
+                    <a:pt x="53119" y="202238"/>
+                  </a:lnTo>
+                  <a:lnTo>
+                    <a:pt x="130363" y="472134"/>
+                  </a:lnTo>
+                  <a:lnTo>
+                    <a:pt x="207606" y="719832"/>
+                  </a:lnTo>
+                  <a:lnTo>
+                    <a:pt x="284850" y="947157"/>
+                  </a:lnTo>
+                  <a:lnTo>
+                    <a:pt x="362094" y="1155785"/>
+                  </a:lnTo>
+                  <a:lnTo>
+                    <a:pt x="439337" y="1347254"/>
+                  </a:lnTo>
+                  <a:lnTo>
+                    <a:pt x="516581" y="1522975"/>
+                  </a:lnTo>
+                  <a:lnTo>
+                    <a:pt x="593824" y="1684244"/>
+                  </a:lnTo>
+                  <a:lnTo>
+                    <a:pt x="671068" y="1832248"/>
+                  </a:lnTo>
+                  <a:lnTo>
+                    <a:pt x="748311" y="1968080"/>
+                  </a:lnTo>
+                  <a:lnTo>
+                    <a:pt x="825555" y="2092740"/>
+                  </a:lnTo>
+                  <a:lnTo>
+                    <a:pt x="902799" y="2207147"/>
+                  </a:lnTo>
+                  <a:lnTo>
+                    <a:pt x="980042" y="2312144"/>
+                  </a:lnTo>
+                  <a:lnTo>
+                    <a:pt x="1057286" y="2408505"/>
+                  </a:lnTo>
+                  <a:lnTo>
+                    <a:pt x="1134529" y="2496941"/>
+                  </a:lnTo>
+                  <a:lnTo>
+                    <a:pt x="1211773" y="2578103"/>
+                  </a:lnTo>
+                  <a:lnTo>
+                    <a:pt x="1289016" y="2652590"/>
+                  </a:lnTo>
+                  <a:lnTo>
+                    <a:pt x="1366260" y="2720951"/>
+                  </a:lnTo>
+                  <a:lnTo>
+                    <a:pt x="1443504" y="2783689"/>
+                  </a:lnTo>
+                  <a:lnTo>
+                    <a:pt x="1520747" y="2841267"/>
+                  </a:lnTo>
+                  <a:lnTo>
+                    <a:pt x="1597991" y="2894109"/>
+                  </a:lnTo>
+                  <a:lnTo>
+                    <a:pt x="1675234" y="2942605"/>
+                  </a:lnTo>
+                  <a:lnTo>
+                    <a:pt x="1752478" y="2987113"/>
+                  </a:lnTo>
+                  <a:lnTo>
+                    <a:pt x="1829721" y="3027960"/>
+                  </a:lnTo>
+                  <a:lnTo>
+                    <a:pt x="1906965" y="3065447"/>
+                  </a:lnTo>
+                  <a:lnTo>
+                    <a:pt x="1984209" y="3099851"/>
+                  </a:lnTo>
+                  <a:lnTo>
+                    <a:pt x="2061452" y="3131426"/>
+                  </a:lnTo>
+                  <a:lnTo>
+                    <a:pt x="2138696" y="3160403"/>
+                  </a:lnTo>
+                  <a:lnTo>
+                    <a:pt x="2215939" y="3186997"/>
+                  </a:lnTo>
+                  <a:lnTo>
+                    <a:pt x="2293183" y="3211404"/>
+                  </a:lnTo>
+                  <a:lnTo>
+                    <a:pt x="2370426" y="3233804"/>
+                  </a:lnTo>
+                  <a:lnTo>
+                    <a:pt x="2447670" y="3254361"/>
+                  </a:lnTo>
+                  <a:lnTo>
+                    <a:pt x="2524914" y="3273227"/>
+                  </a:lnTo>
+                  <a:lnTo>
+                    <a:pt x="2602157" y="3290542"/>
+                  </a:lnTo>
+                  <a:lnTo>
+                    <a:pt x="2679401" y="3306432"/>
+                  </a:lnTo>
+                  <a:lnTo>
+                    <a:pt x="2756644" y="3321016"/>
+                  </a:lnTo>
+                  <a:lnTo>
+                    <a:pt x="2833888" y="3334400"/>
+                  </a:lnTo>
+                  <a:lnTo>
+                    <a:pt x="2911131" y="3346684"/>
+                  </a:lnTo>
+                  <a:lnTo>
+                    <a:pt x="2988375" y="3357957"/>
+                  </a:lnTo>
+                  <a:lnTo>
+                    <a:pt x="3065619" y="3368303"/>
+                  </a:lnTo>
+                  <a:lnTo>
+                    <a:pt x="3142862" y="3377798"/>
+                  </a:lnTo>
+                  <a:lnTo>
+                    <a:pt x="3220106" y="3386512"/>
+                  </a:lnTo>
+                  <a:lnTo>
+                    <a:pt x="3297349" y="3394509"/>
+                  </a:lnTo>
+                  <a:lnTo>
+                    <a:pt x="3374593" y="3401848"/>
+                  </a:lnTo>
+                  <a:lnTo>
+                    <a:pt x="3451836" y="3408584"/>
+                  </a:lnTo>
+                  <a:lnTo>
+                    <a:pt x="3529080" y="3414766"/>
+                  </a:lnTo>
+                  <a:lnTo>
+                    <a:pt x="3606324" y="3420440"/>
+                  </a:lnTo>
+                  <a:lnTo>
+                    <a:pt x="3683567" y="3425646"/>
+                  </a:lnTo>
+                  <a:lnTo>
+                    <a:pt x="3760811" y="3430425"/>
+                  </a:lnTo>
+                  <a:lnTo>
+                    <a:pt x="3838054" y="3434811"/>
+                  </a:lnTo>
+                  <a:lnTo>
+                    <a:pt x="3915298" y="3438835"/>
+                  </a:lnTo>
+                  <a:lnTo>
+                    <a:pt x="3992541" y="3442529"/>
+                  </a:lnTo>
+                  <a:lnTo>
+                    <a:pt x="4069785" y="3445919"/>
+                  </a:lnTo>
+                  <a:lnTo>
+                    <a:pt x="4147029" y="3449030"/>
+                  </a:lnTo>
+                  <a:lnTo>
+                    <a:pt x="4224272" y="3451886"/>
+                  </a:lnTo>
+                  <a:lnTo>
+                    <a:pt x="4301516" y="3454506"/>
+                  </a:lnTo>
+                  <a:lnTo>
+                    <a:pt x="4378759" y="3456911"/>
+                  </a:lnTo>
+                  <a:lnTo>
+                    <a:pt x="4456003" y="3459118"/>
+                  </a:lnTo>
+                  <a:lnTo>
+                    <a:pt x="4533246" y="3461144"/>
+                  </a:lnTo>
+                  <a:lnTo>
+                    <a:pt x="4610490" y="3463003"/>
+                  </a:lnTo>
+                  <a:lnTo>
+                    <a:pt x="4687734" y="3464709"/>
+                  </a:lnTo>
+                  <a:lnTo>
+                    <a:pt x="4764977" y="3466275"/>
+                  </a:lnTo>
+                  <a:lnTo>
+                    <a:pt x="4842221" y="3467712"/>
+                  </a:lnTo>
+                  <a:lnTo>
+                    <a:pt x="4919464" y="3469031"/>
+                  </a:lnTo>
+                  <a:lnTo>
+                    <a:pt x="4996708" y="3470241"/>
+                  </a:lnTo>
+                  <a:lnTo>
+                    <a:pt x="5073951" y="3471352"/>
+                  </a:lnTo>
+                  <a:lnTo>
+                    <a:pt x="5151195" y="3472371"/>
+                  </a:lnTo>
+                  <a:lnTo>
+                    <a:pt x="5228439" y="3473307"/>
+                  </a:lnTo>
+                  <a:lnTo>
+                    <a:pt x="5305682" y="3474165"/>
+                  </a:lnTo>
+                  <a:lnTo>
+                    <a:pt x="5382926" y="3474953"/>
                   </a:lnTo>
                 </a:path>
               </a:pathLst>
@@ -4254,7 +4254,7 @@
           </p:nvSpPr>
           <p:spPr>
             <a:xfrm>
-              <a:off x="817517" y="4679530"/>
+              <a:off x="817517" y="4727786"/>
               <a:ext cx="7799693" cy="0"/>
             </a:xfrm>
             <a:custGeom>
@@ -4297,15 +4297,15 @@
           </p:nvSpPr>
           <p:spPr>
             <a:xfrm>
-              <a:off x="4117484" y="1896563"/>
-              <a:ext cx="0" cy="3826579"/>
+              <a:off x="4117484" y="2073503"/>
+              <a:ext cx="0" cy="3649639"/>
             </a:xfrm>
             <a:custGeom>
               <a:avLst/>
               <a:pathLst>
-                <a:path w="0" h="3826579">
+                <a:path w="0" h="3649639">
                   <a:moveTo>
-                    <a:pt x="0" y="3826579"/>
+                    <a:pt x="0" y="3649639"/>
                   </a:moveTo>
                   <a:lnTo>
                     <a:pt x="0" y="0"/>
@@ -4340,7 +4340,7 @@
           </p:nvSpPr>
           <p:spPr>
             <a:xfrm>
-              <a:off x="692708" y="5509156"/>
+              <a:off x="692708" y="5517199"/>
               <a:ext cx="62179" cy="80101"/>
             </a:xfrm>
             <a:prstGeom prst="rect">
@@ -4386,7 +4386,7 @@
           </p:nvSpPr>
           <p:spPr>
             <a:xfrm>
-              <a:off x="692708" y="4639479"/>
+              <a:off x="692708" y="4687735"/>
               <a:ext cx="62179" cy="80101"/>
             </a:xfrm>
             <a:prstGeom prst="rect">
@@ -4432,7 +4432,7 @@
           </p:nvSpPr>
           <p:spPr>
             <a:xfrm>
-              <a:off x="692708" y="3769802"/>
+              <a:off x="692708" y="3858272"/>
               <a:ext cx="62179" cy="80101"/>
             </a:xfrm>
             <a:prstGeom prst="rect">
@@ -4478,7 +4478,7 @@
           </p:nvSpPr>
           <p:spPr>
             <a:xfrm>
-              <a:off x="692708" y="2900125"/>
+              <a:off x="692708" y="3028808"/>
               <a:ext cx="62179" cy="80101"/>
             </a:xfrm>
             <a:prstGeom prst="rect">
@@ -4524,7 +4524,7 @@
           </p:nvSpPr>
           <p:spPr>
             <a:xfrm>
-              <a:off x="692708" y="2030448"/>
+              <a:off x="692708" y="2199345"/>
               <a:ext cx="62179" cy="80101"/>
             </a:xfrm>
             <a:prstGeom prst="rect">
@@ -4800,7 +4800,7 @@
           </p:nvSpPr>
           <p:spPr>
             <a:xfrm rot="-5400000">
-              <a:off x="181100" y="3759743"/>
+              <a:off x="181100" y="3848213"/>
               <a:ext cx="791596" cy="100218"/>
             </a:xfrm>
             <a:prstGeom prst="rect">
@@ -4841,6 +4841,52 @@
         <p:sp>
           <p:nvSpPr>
             <p:cNvPr id="38" name="tx38"/>
+            <p:cNvSpPr/>
+            <p:nvPr/>
+          </p:nvSpPr>
+          <p:spPr>
+            <a:xfrm>
+              <a:off x="817517" y="1896563"/>
+              <a:ext cx="5569061" cy="82021"/>
+            </a:xfrm>
+            <a:prstGeom prst="rect">
+              <a:avLst/>
+            </a:prstGeom>
+            <a:noFill/>
+          </p:spPr>
+          <p:txBody>
+            <a:bodyPr lIns="0" rIns="0" tIns="0" bIns="0" anchorCtr="1" anchor="ctr" wrap="none"/>
+            <a:lstStyle/>
+            <a:p>
+              <a:pPr algn="l" marL="0" marR="0" indent="0">
+                <a:lnSpc>
+                  <a:spcPts val="900"/>
+                </a:lnSpc>
+                <a:spcBef>
+                  <a:spcPts val="0"/>
+                </a:spcBef>
+                <a:spcAft>
+                  <a:spcPts val="0"/>
+                </a:spcAft>
+              </a:pPr>
+              <a:r>
+                <a:rPr sz="900">
+                  <a:solidFill>
+                    <a:srgbClr val="404040">
+                      <a:alpha val="100000"/>
+                    </a:srgbClr>
+                  </a:solidFill>
+                  <a:latin typeface="Helvetica"/>
+                  <a:cs typeface="Helvetica"/>
+                </a:rPr>
+                <a:t>HR per 0.1 ratio decline: 2.68 (1.64-4.38)  |  per IQR decline (Δ = 0.30): 18.33 (4.29-78.40)  |  IQR: [0.84, 1.14]</a:t>
+              </a:r>
+            </a:p>
+          </p:txBody>
+        </p:sp>
+        <p:sp>
+          <p:nvSpPr>
+            <p:cNvPr id="39" name="tx39"/>
             <p:cNvSpPr/>
             <p:nvPr/>
           </p:nvSpPr>

</xml_diff>

<commit_message>
Add Wald p-value to linear (sub)HR plot subtitles
Both eGFR-ratio plots (plot_subhr_linear_ratio /
plot_cox_linear_ratio) and eGFR-discrepancy plots
(plot_subhr_linear_disc / plot_cox_linear_disc /
plot_subhr_linear_egfrdisc / plot_cox_linear_egfrdisc) in all three
Jiaxuan files now report the two-sided Wald p-value for the linear
predictor's coefficient immediately after the per-unit (sub)HR:

  "subHR per 0.1 ratio decline: X.XX (Y.YY-Z.ZZ), p = P.PPP  |  ..."

p is computed as 2 * (1 - pnorm(|beta / se|)), rendered as "<0.001"
below threshold and three decimal places otherwise.

No other content of the subtitle changed; curves, axes, IQR vertical
lines, and reference dotted lines are unchanged.

Co-Authored-By: Claude Opus 4.6 (1M context) <noreply@anthropic.com>
</commit_message>
<xml_diff>
--- a/docs/pptx/auc3/jx-auc3-cox-linear-ratio-death.pptx
+++ b/docs/pptx/auc3/jx-auc3-cox-linear-ratio-death.pptx
@@ -4847,7 +4847,7 @@
           <p:spPr>
             <a:xfrm>
               <a:off x="817517" y="1896563"/>
-              <a:ext cx="5569061" cy="82021"/>
+              <a:ext cx="6178966" cy="82021"/>
             </a:xfrm>
             <a:prstGeom prst="rect">
               <a:avLst/>
@@ -4879,7 +4879,7 @@
                   <a:latin typeface="Helvetica"/>
                   <a:cs typeface="Helvetica"/>
                 </a:rPr>
-                <a:t>HR per 0.1 ratio decline: 2.68 (1.64-4.38)  |  per IQR decline (Δ = 0.30): 18.33 (4.29-78.40)  |  IQR: [0.84, 1.14]</a:t>
+                <a:t>HR per 0.1 ratio decline: 2.68 (1.64-4.38), p = &lt;0.001  |  per IQR decline (Δ = 0.30): 18.33 (4.29-78.40)  |  IQR: [0.84, 1.14]</a:t>
               </a:r>
             </a:p>
           </p:txBody>

</xml_diff>

<commit_message>
Switch primary + sensitivity exposures from eGFR ratio to eGFR difference (%)
Primary predictor egfr_diff_pct = 100 * (CKD-EPI Cr-Cys unindexed - CG) / CG,
reported per 10 percentage-point decline. Sensitivity predictor
egfr_diff_pct_sens = 100 * (CKD-EPI 2012 CysC - CKD-EPI 2021 Cr) / CKD-EPI 2021 Cr,
also per 10 % decline. Old egfr_ratio/egfr_ratio_sens derivations retained
in Section 1 setup but unused downstream. Whole cohort gets a new Section 3.3
distribution histogram; Section 3.2 mL/min discordance histogram and the
mL/min discrepancy analysis sections (Section 7 whole; Section 10 carbo/AUC3)
remain unchanged as parallel comparisons.

Co-Authored-By: Claude Opus 4.7 (1M context) <noreply@anthropic.com>
</commit_message>
<xml_diff>
--- a/docs/pptx/auc3/jx-auc3-cox-linear-ratio-death.pptx
+++ b/docs/pptx/auc3/jx-auc3-cox-linear-ratio-death.pptx
@@ -2443,7 +2443,7 @@
           </p:nvSpPr>
           <p:spPr>
             <a:xfrm>
-              <a:off x="1615213" y="2073503"/>
+              <a:off x="1531834" y="2073503"/>
               <a:ext cx="0" cy="3649639"/>
             </a:xfrm>
             <a:custGeom>
@@ -2486,7 +2486,7 @@
           </p:nvSpPr>
           <p:spPr>
             <a:xfrm>
-              <a:off x="3387871" y="2073503"/>
+              <a:off x="3586410" y="2073503"/>
               <a:ext cx="0" cy="3649639"/>
             </a:xfrm>
             <a:custGeom>
@@ -2529,7 +2529,7 @@
           </p:nvSpPr>
           <p:spPr>
             <a:xfrm>
-              <a:off x="5160528" y="2073503"/>
+              <a:off x="5640985" y="2073503"/>
               <a:ext cx="0" cy="3649639"/>
             </a:xfrm>
             <a:custGeom>
@@ -2572,7 +2572,7 @@
           </p:nvSpPr>
           <p:spPr>
             <a:xfrm>
-              <a:off x="6933186" y="2073503"/>
+              <a:off x="7695561" y="2073503"/>
               <a:ext cx="0" cy="3649639"/>
             </a:xfrm>
             <a:custGeom>
@@ -2830,7 +2830,7 @@
           </p:nvSpPr>
           <p:spPr>
             <a:xfrm>
-              <a:off x="2501542" y="2073503"/>
+              <a:off x="2559122" y="2073503"/>
               <a:ext cx="0" cy="3649639"/>
             </a:xfrm>
             <a:custGeom>
@@ -2873,7 +2873,7 @@
           </p:nvSpPr>
           <p:spPr>
             <a:xfrm>
-              <a:off x="4274200" y="2073503"/>
+              <a:off x="4613698" y="2073503"/>
               <a:ext cx="0" cy="3649639"/>
             </a:xfrm>
             <a:custGeom>
@@ -2916,7 +2916,7 @@
           </p:nvSpPr>
           <p:spPr>
             <a:xfrm>
-              <a:off x="6046857" y="2073503"/>
+              <a:off x="6668273" y="2073503"/>
               <a:ext cx="0" cy="3649639"/>
             </a:xfrm>
             <a:custGeom>
@@ -2953,520 +2953,477 @@
         </p:sp>
         <p:sp>
           <p:nvSpPr>
-            <p:cNvPr id="20" name="pl20"/>
+            <p:cNvPr id="20" name="pg20"/>
             <p:cNvSpPr/>
             <p:nvPr/>
           </p:nvSpPr>
           <p:spPr>
             <a:xfrm>
-              <a:off x="7819515" y="2073503"/>
-              <a:ext cx="0" cy="3649639"/>
+              <a:off x="2075756" y="2073503"/>
+              <a:ext cx="6186922" cy="3482839"/>
             </a:xfrm>
             <a:custGeom>
               <a:avLst/>
               <a:pathLst>
-                <a:path w="0" h="3649639">
+                <a:path w="6186922" h="3482839">
                   <a:moveTo>
-                    <a:pt x="0" y="3649639"/>
+                    <a:pt x="1594513" y="0"/>
                   </a:moveTo>
                   <a:lnTo>
-                    <a:pt x="0" y="0"/>
-                  </a:lnTo>
-                  <a:lnTo>
-                    <a:pt x="0" y="0"/>
-                  </a:lnTo>
-                </a:path>
-              </a:pathLst>
-            </a:custGeom>
-            <a:ln w="13550" cap="flat">
-              <a:solidFill>
-                <a:srgbClr val="EBEBEB">
-                  <a:alpha val="100000"/>
-                </a:srgbClr>
-              </a:solidFill>
-              <a:prstDash val="solid"/>
-              <a:round/>
-            </a:ln>
-          </p:spPr>
-          <p:txBody>
-            <a:bodyPr/>
-            <a:lstStyle/>
-            <a:p/>
-          </p:txBody>
-        </p:sp>
-        <p:sp>
-          <p:nvSpPr>
-            <p:cNvPr id="21" name="pg21"/>
-            <p:cNvSpPr/>
-            <p:nvPr/>
-          </p:nvSpPr>
-          <p:spPr>
-            <a:xfrm>
-              <a:off x="1537077" y="2073503"/>
-              <a:ext cx="6672481" cy="3482839"/>
-            </a:xfrm>
-            <a:custGeom>
-              <a:avLst/>
-              <a:pathLst>
-                <a:path w="6672481" h="3482839">
-                  <a:moveTo>
-                    <a:pt x="1719653" y="0"/>
-                  </a:moveTo>
-                  <a:lnTo>
-                    <a:pt x="1728893" y="56311"/>
-                  </a:lnTo>
-                  <a:lnTo>
-                    <a:pt x="1806136" y="470224"/>
-                  </a:lnTo>
-                  <a:lnTo>
-                    <a:pt x="1883380" y="834152"/>
-                  </a:lnTo>
-                  <a:lnTo>
-                    <a:pt x="1960623" y="1154130"/>
-                  </a:lnTo>
-                  <a:lnTo>
-                    <a:pt x="2037867" y="1435465"/>
-                  </a:lnTo>
-                  <a:lnTo>
-                    <a:pt x="2115111" y="1682826"/>
-                  </a:lnTo>
-                  <a:lnTo>
-                    <a:pt x="2192354" y="1900314"/>
-                  </a:lnTo>
-                  <a:lnTo>
-                    <a:pt x="2269598" y="2091537"/>
-                  </a:lnTo>
-                  <a:lnTo>
-                    <a:pt x="2346841" y="2259666"/>
-                  </a:lnTo>
-                  <a:lnTo>
-                    <a:pt x="2424085" y="2407492"/>
-                  </a:lnTo>
-                  <a:lnTo>
-                    <a:pt x="2501328" y="2537466"/>
-                  </a:lnTo>
-                  <a:lnTo>
-                    <a:pt x="2578572" y="2651743"/>
-                  </a:lnTo>
-                  <a:lnTo>
-                    <a:pt x="2655816" y="2688345"/>
-                  </a:lnTo>
-                  <a:lnTo>
-                    <a:pt x="2733059" y="2721786"/>
-                  </a:lnTo>
-                  <a:lnTo>
-                    <a:pt x="2810303" y="2753821"/>
-                  </a:lnTo>
-                  <a:lnTo>
-                    <a:pt x="2887546" y="2784509"/>
-                  </a:lnTo>
-                  <a:lnTo>
-                    <a:pt x="2964790" y="2813907"/>
-                  </a:lnTo>
-                  <a:lnTo>
-                    <a:pt x="3042033" y="2842069"/>
-                  </a:lnTo>
-                  <a:lnTo>
-                    <a:pt x="3119277" y="2869047"/>
-                  </a:lnTo>
-                  <a:lnTo>
-                    <a:pt x="3196521" y="2894890"/>
-                  </a:lnTo>
-                  <a:lnTo>
-                    <a:pt x="3273764" y="2919648"/>
-                  </a:lnTo>
-                  <a:lnTo>
-                    <a:pt x="3351008" y="2943364"/>
-                  </a:lnTo>
-                  <a:lnTo>
-                    <a:pt x="3428251" y="2966083"/>
-                  </a:lnTo>
-                  <a:lnTo>
-                    <a:pt x="3505495" y="2987847"/>
-                  </a:lnTo>
-                  <a:lnTo>
-                    <a:pt x="3582738" y="3008696"/>
-                  </a:lnTo>
-                  <a:lnTo>
-                    <a:pt x="3659982" y="3028669"/>
-                  </a:lnTo>
-                  <a:lnTo>
-                    <a:pt x="3737226" y="3047801"/>
-                  </a:lnTo>
-                  <a:lnTo>
-                    <a:pt x="3814469" y="3066130"/>
-                  </a:lnTo>
-                  <a:lnTo>
-                    <a:pt x="3891713" y="3083687"/>
-                  </a:lnTo>
-                  <a:lnTo>
-                    <a:pt x="3968956" y="3100507"/>
-                  </a:lnTo>
-                  <a:lnTo>
-                    <a:pt x="4046200" y="3116620"/>
-                  </a:lnTo>
-                  <a:lnTo>
-                    <a:pt x="4123443" y="3132055"/>
-                  </a:lnTo>
-                  <a:lnTo>
-                    <a:pt x="4200687" y="3146841"/>
-                  </a:lnTo>
-                  <a:lnTo>
-                    <a:pt x="4277931" y="3161005"/>
-                  </a:lnTo>
-                  <a:lnTo>
-                    <a:pt x="4355174" y="3174574"/>
-                  </a:lnTo>
-                  <a:lnTo>
-                    <a:pt x="4432418" y="3187573"/>
-                  </a:lnTo>
-                  <a:lnTo>
-                    <a:pt x="4509661" y="3200025"/>
-                  </a:lnTo>
-                  <a:lnTo>
-                    <a:pt x="4586905" y="3211953"/>
-                  </a:lnTo>
-                  <a:lnTo>
-                    <a:pt x="4664148" y="3223380"/>
-                  </a:lnTo>
-                  <a:lnTo>
-                    <a:pt x="4741392" y="3234327"/>
-                  </a:lnTo>
-                  <a:lnTo>
-                    <a:pt x="4818636" y="3244813"/>
-                  </a:lnTo>
-                  <a:lnTo>
-                    <a:pt x="4895879" y="3254858"/>
-                  </a:lnTo>
-                  <a:lnTo>
-                    <a:pt x="4973123" y="3264481"/>
-                  </a:lnTo>
-                  <a:lnTo>
-                    <a:pt x="5050366" y="3273700"/>
-                  </a:lnTo>
-                  <a:lnTo>
-                    <a:pt x="5127610" y="3282531"/>
-                  </a:lnTo>
-                  <a:lnTo>
-                    <a:pt x="5204853" y="3290991"/>
-                  </a:lnTo>
-                  <a:lnTo>
-                    <a:pt x="5282097" y="3299095"/>
-                  </a:lnTo>
-                  <a:lnTo>
-                    <a:pt x="5359341" y="3306858"/>
-                  </a:lnTo>
-                  <a:lnTo>
-                    <a:pt x="5436584" y="3314295"/>
-                  </a:lnTo>
-                  <a:lnTo>
-                    <a:pt x="5513828" y="3321419"/>
-                  </a:lnTo>
-                  <a:lnTo>
-                    <a:pt x="5591071" y="3328244"/>
-                  </a:lnTo>
-                  <a:lnTo>
-                    <a:pt x="5668315" y="3334781"/>
-                  </a:lnTo>
-                  <a:lnTo>
-                    <a:pt x="5745558" y="3341044"/>
-                  </a:lnTo>
-                  <a:lnTo>
-                    <a:pt x="5822802" y="3347044"/>
-                  </a:lnTo>
-                  <a:lnTo>
-                    <a:pt x="5900046" y="3352791"/>
-                  </a:lnTo>
-                  <a:lnTo>
-                    <a:pt x="5977289" y="3358297"/>
-                  </a:lnTo>
-                  <a:lnTo>
-                    <a:pt x="6054533" y="3363571"/>
-                  </a:lnTo>
-                  <a:lnTo>
-                    <a:pt x="6131776" y="3368624"/>
-                  </a:lnTo>
-                  <a:lnTo>
-                    <a:pt x="6209020" y="3373464"/>
-                  </a:lnTo>
-                  <a:lnTo>
-                    <a:pt x="6286263" y="3378100"/>
-                  </a:lnTo>
-                  <a:lnTo>
-                    <a:pt x="6363507" y="3382542"/>
-                  </a:lnTo>
-                  <a:lnTo>
-                    <a:pt x="6440751" y="3386797"/>
-                  </a:lnTo>
-                  <a:lnTo>
-                    <a:pt x="6517994" y="3390873"/>
-                  </a:lnTo>
-                  <a:lnTo>
-                    <a:pt x="6595238" y="3394778"/>
-                  </a:lnTo>
-                  <a:lnTo>
-                    <a:pt x="6672481" y="3398518"/>
-                  </a:lnTo>
-                  <a:lnTo>
-                    <a:pt x="6672481" y="3482839"/>
-                  </a:lnTo>
-                  <a:lnTo>
-                    <a:pt x="6595238" y="3482715"/>
-                  </a:lnTo>
-                  <a:lnTo>
-                    <a:pt x="6517994" y="3482573"/>
-                  </a:lnTo>
-                  <a:lnTo>
-                    <a:pt x="6440751" y="3482412"/>
-                  </a:lnTo>
-                  <a:lnTo>
-                    <a:pt x="6363507" y="3482228"/>
-                  </a:lnTo>
-                  <a:lnTo>
-                    <a:pt x="6286263" y="3482020"/>
-                  </a:lnTo>
-                  <a:lnTo>
-                    <a:pt x="6209020" y="3481783"/>
-                  </a:lnTo>
-                  <a:lnTo>
-                    <a:pt x="6131776" y="3481513"/>
-                  </a:lnTo>
-                  <a:lnTo>
-                    <a:pt x="6054533" y="3481206"/>
-                  </a:lnTo>
-                  <a:lnTo>
-                    <a:pt x="5977289" y="3480857"/>
-                  </a:lnTo>
-                  <a:lnTo>
-                    <a:pt x="5900046" y="3480461"/>
-                  </a:lnTo>
-                  <a:lnTo>
-                    <a:pt x="5822802" y="3480009"/>
-                  </a:lnTo>
-                  <a:lnTo>
-                    <a:pt x="5745558" y="3479496"/>
-                  </a:lnTo>
-                  <a:lnTo>
-                    <a:pt x="5668315" y="3478912"/>
-                  </a:lnTo>
-                  <a:lnTo>
-                    <a:pt x="5591071" y="3478248"/>
-                  </a:lnTo>
-                  <a:lnTo>
-                    <a:pt x="5513828" y="3477493"/>
-                  </a:lnTo>
-                  <a:lnTo>
-                    <a:pt x="5436584" y="3476634"/>
-                  </a:lnTo>
-                  <a:lnTo>
-                    <a:pt x="5359341" y="3475657"/>
-                  </a:lnTo>
-                  <a:lnTo>
-                    <a:pt x="5282097" y="3474546"/>
-                  </a:lnTo>
-                  <a:lnTo>
-                    <a:pt x="5204853" y="3473282"/>
-                  </a:lnTo>
-                  <a:lnTo>
-                    <a:pt x="5127610" y="3471845"/>
-                  </a:lnTo>
-                  <a:lnTo>
-                    <a:pt x="5050366" y="3470211"/>
-                  </a:lnTo>
-                  <a:lnTo>
-                    <a:pt x="4973123" y="3468351"/>
-                  </a:lnTo>
-                  <a:lnTo>
-                    <a:pt x="4895879" y="3466237"/>
-                  </a:lnTo>
-                  <a:lnTo>
-                    <a:pt x="4818636" y="3463832"/>
-                  </a:lnTo>
-                  <a:lnTo>
-                    <a:pt x="4741392" y="3461096"/>
-                  </a:lnTo>
-                  <a:lnTo>
-                    <a:pt x="4664148" y="3457985"/>
-                  </a:lnTo>
-                  <a:lnTo>
-                    <a:pt x="4586905" y="3454447"/>
-                  </a:lnTo>
-                  <a:lnTo>
-                    <a:pt x="4509661" y="3450423"/>
-                  </a:lnTo>
-                  <a:lnTo>
-                    <a:pt x="4432418" y="3445846"/>
-                  </a:lnTo>
-                  <a:lnTo>
-                    <a:pt x="4355174" y="3440640"/>
-                  </a:lnTo>
-                  <a:lnTo>
-                    <a:pt x="4277931" y="3434719"/>
-                  </a:lnTo>
-                  <a:lnTo>
-                    <a:pt x="4200687" y="3427985"/>
-                  </a:lnTo>
-                  <a:lnTo>
-                    <a:pt x="4123443" y="3420326"/>
-                  </a:lnTo>
-                  <a:lnTo>
-                    <a:pt x="4046200" y="3411616"/>
-                  </a:lnTo>
-                  <a:lnTo>
-                    <a:pt x="3968956" y="3401708"/>
-                  </a:lnTo>
-                  <a:lnTo>
-                    <a:pt x="3891713" y="3390440"/>
-                  </a:lnTo>
-                  <a:lnTo>
-                    <a:pt x="3814469" y="3377624"/>
-                  </a:lnTo>
-                  <a:lnTo>
-                    <a:pt x="3737226" y="3363048"/>
-                  </a:lnTo>
-                  <a:lnTo>
-                    <a:pt x="3659982" y="3346470"/>
-                  </a:lnTo>
-                  <a:lnTo>
-                    <a:pt x="3582738" y="3327615"/>
-                  </a:lnTo>
-                  <a:lnTo>
-                    <a:pt x="3505495" y="3306170"/>
-                  </a:lnTo>
-                  <a:lnTo>
-                    <a:pt x="3428251" y="3281779"/>
-                  </a:lnTo>
-                  <a:lnTo>
-                    <a:pt x="3351008" y="3254039"/>
-                  </a:lnTo>
-                  <a:lnTo>
-                    <a:pt x="3273764" y="3222488"/>
-                  </a:lnTo>
-                  <a:lnTo>
-                    <a:pt x="3196521" y="3186604"/>
-                  </a:lnTo>
-                  <a:lnTo>
-                    <a:pt x="3119277" y="3145790"/>
-                  </a:lnTo>
-                  <a:lnTo>
-                    <a:pt x="3042033" y="3099371"/>
-                  </a:lnTo>
-                  <a:lnTo>
-                    <a:pt x="2964790" y="3046577"/>
-                  </a:lnTo>
-                  <a:lnTo>
-                    <a:pt x="2887546" y="2986530"/>
-                  </a:lnTo>
-                  <a:lnTo>
-                    <a:pt x="2810303" y="2918237"/>
-                  </a:lnTo>
-                  <a:lnTo>
-                    <a:pt x="2733059" y="2840563"/>
-                  </a:lnTo>
-                  <a:lnTo>
-                    <a:pt x="2655816" y="2752220"/>
-                  </a:lnTo>
-                  <a:lnTo>
-                    <a:pt x="2578572" y="2653436"/>
-                  </a:lnTo>
-                  <a:lnTo>
-                    <a:pt x="2501328" y="2616996"/>
-                  </a:lnTo>
-                  <a:lnTo>
-                    <a:pt x="2424085" y="2578956"/>
-                  </a:lnTo>
-                  <a:lnTo>
-                    <a:pt x="2346841" y="2539246"/>
-                  </a:lnTo>
-                  <a:lnTo>
-                    <a:pt x="2269598" y="2497794"/>
-                  </a:lnTo>
-                  <a:lnTo>
-                    <a:pt x="2192354" y="2454522"/>
-                  </a:lnTo>
-                  <a:lnTo>
-                    <a:pt x="2115111" y="2409352"/>
-                  </a:lnTo>
-                  <a:lnTo>
-                    <a:pt x="2037867" y="2362199"/>
-                  </a:lnTo>
-                  <a:lnTo>
-                    <a:pt x="1960623" y="2312976"/>
-                  </a:lnTo>
-                  <a:lnTo>
-                    <a:pt x="1883380" y="2261594"/>
-                  </a:lnTo>
-                  <a:lnTo>
-                    <a:pt x="1806136" y="2207956"/>
-                  </a:lnTo>
-                  <a:lnTo>
-                    <a:pt x="1728893" y="2151964"/>
-                  </a:lnTo>
-                  <a:lnTo>
-                    <a:pt x="1651649" y="2093515"/>
-                  </a:lnTo>
-                  <a:lnTo>
-                    <a:pt x="1574405" y="2032500"/>
-                  </a:lnTo>
-                  <a:lnTo>
-                    <a:pt x="1497162" y="1968808"/>
-                  </a:lnTo>
-                  <a:lnTo>
-                    <a:pt x="1419918" y="1902320"/>
-                  </a:lnTo>
-                  <a:lnTo>
-                    <a:pt x="1342675" y="1832914"/>
-                  </a:lnTo>
-                  <a:lnTo>
-                    <a:pt x="1265431" y="1760463"/>
-                  </a:lnTo>
-                  <a:lnTo>
-                    <a:pt x="1188188" y="1684831"/>
-                  </a:lnTo>
-                  <a:lnTo>
-                    <a:pt x="1110944" y="1605881"/>
-                  </a:lnTo>
-                  <a:lnTo>
-                    <a:pt x="1033700" y="1523465"/>
-                  </a:lnTo>
-                  <a:lnTo>
-                    <a:pt x="956457" y="1437432"/>
-                  </a:lnTo>
-                  <a:lnTo>
-                    <a:pt x="879213" y="1347623"/>
-                  </a:lnTo>
-                  <a:lnTo>
-                    <a:pt x="801970" y="1253873"/>
-                  </a:lnTo>
-                  <a:lnTo>
-                    <a:pt x="724726" y="1156008"/>
-                  </a:lnTo>
-                  <a:lnTo>
-                    <a:pt x="647483" y="1053849"/>
-                  </a:lnTo>
-                  <a:lnTo>
-                    <a:pt x="570239" y="947205"/>
-                  </a:lnTo>
-                  <a:lnTo>
-                    <a:pt x="492995" y="835882"/>
-                  </a:lnTo>
-                  <a:lnTo>
-                    <a:pt x="415752" y="719672"/>
-                  </a:lnTo>
-                  <a:lnTo>
-                    <a:pt x="338508" y="598362"/>
-                  </a:lnTo>
-                  <a:lnTo>
-                    <a:pt x="261265" y="471729"/>
-                  </a:lnTo>
-                  <a:lnTo>
-                    <a:pt x="184021" y="339537"/>
-                  </a:lnTo>
-                  <a:lnTo>
-                    <a:pt x="106778" y="201544"/>
-                  </a:lnTo>
-                  <a:lnTo>
-                    <a:pt x="29534" y="57495"/>
+                    <a:pt x="1603080" y="56311"/>
+                  </a:lnTo>
+                  <a:lnTo>
+                    <a:pt x="1674703" y="470224"/>
+                  </a:lnTo>
+                  <a:lnTo>
+                    <a:pt x="1746325" y="834152"/>
+                  </a:lnTo>
+                  <a:lnTo>
+                    <a:pt x="1817948" y="1154130"/>
+                  </a:lnTo>
+                  <a:lnTo>
+                    <a:pt x="1889570" y="1435465"/>
+                  </a:lnTo>
+                  <a:lnTo>
+                    <a:pt x="1961193" y="1682826"/>
+                  </a:lnTo>
+                  <a:lnTo>
+                    <a:pt x="2032816" y="1900314"/>
+                  </a:lnTo>
+                  <a:lnTo>
+                    <a:pt x="2104438" y="2091537"/>
+                  </a:lnTo>
+                  <a:lnTo>
+                    <a:pt x="2176061" y="2259666"/>
+                  </a:lnTo>
+                  <a:lnTo>
+                    <a:pt x="2247683" y="2407492"/>
+                  </a:lnTo>
+                  <a:lnTo>
+                    <a:pt x="2319306" y="2537466"/>
+                  </a:lnTo>
+                  <a:lnTo>
+                    <a:pt x="2390928" y="2651743"/>
+                  </a:lnTo>
+                  <a:lnTo>
+                    <a:pt x="2462551" y="2688345"/>
+                  </a:lnTo>
+                  <a:lnTo>
+                    <a:pt x="2534173" y="2721786"/>
+                  </a:lnTo>
+                  <a:lnTo>
+                    <a:pt x="2605796" y="2753821"/>
+                  </a:lnTo>
+                  <a:lnTo>
+                    <a:pt x="2677418" y="2784509"/>
+                  </a:lnTo>
+                  <a:lnTo>
+                    <a:pt x="2749041" y="2813907"/>
+                  </a:lnTo>
+                  <a:lnTo>
+                    <a:pt x="2820663" y="2842069"/>
+                  </a:lnTo>
+                  <a:lnTo>
+                    <a:pt x="2892286" y="2869047"/>
+                  </a:lnTo>
+                  <a:lnTo>
+                    <a:pt x="2963908" y="2894890"/>
+                  </a:lnTo>
+                  <a:lnTo>
+                    <a:pt x="3035531" y="2919648"/>
+                  </a:lnTo>
+                  <a:lnTo>
+                    <a:pt x="3107153" y="2943364"/>
+                  </a:lnTo>
+                  <a:lnTo>
+                    <a:pt x="3178776" y="2966083"/>
+                  </a:lnTo>
+                  <a:lnTo>
+                    <a:pt x="3250398" y="2987847"/>
+                  </a:lnTo>
+                  <a:lnTo>
+                    <a:pt x="3322021" y="3008696"/>
+                  </a:lnTo>
+                  <a:lnTo>
+                    <a:pt x="3393644" y="3028669"/>
+                  </a:lnTo>
+                  <a:lnTo>
+                    <a:pt x="3465266" y="3047801"/>
+                  </a:lnTo>
+                  <a:lnTo>
+                    <a:pt x="3536889" y="3066130"/>
+                  </a:lnTo>
+                  <a:lnTo>
+                    <a:pt x="3608511" y="3083687"/>
+                  </a:lnTo>
+                  <a:lnTo>
+                    <a:pt x="3680134" y="3100507"/>
+                  </a:lnTo>
+                  <a:lnTo>
+                    <a:pt x="3751756" y="3116620"/>
+                  </a:lnTo>
+                  <a:lnTo>
+                    <a:pt x="3823379" y="3132055"/>
+                  </a:lnTo>
+                  <a:lnTo>
+                    <a:pt x="3895001" y="3146841"/>
+                  </a:lnTo>
+                  <a:lnTo>
+                    <a:pt x="3966624" y="3161005"/>
+                  </a:lnTo>
+                  <a:lnTo>
+                    <a:pt x="4038246" y="3174574"/>
+                  </a:lnTo>
+                  <a:lnTo>
+                    <a:pt x="4109869" y="3187573"/>
+                  </a:lnTo>
+                  <a:lnTo>
+                    <a:pt x="4181491" y="3200025"/>
+                  </a:lnTo>
+                  <a:lnTo>
+                    <a:pt x="4253114" y="3211953"/>
+                  </a:lnTo>
+                  <a:lnTo>
+                    <a:pt x="4324736" y="3223380"/>
+                  </a:lnTo>
+                  <a:lnTo>
+                    <a:pt x="4396359" y="3234327"/>
+                  </a:lnTo>
+                  <a:lnTo>
+                    <a:pt x="4467981" y="3244813"/>
+                  </a:lnTo>
+                  <a:lnTo>
+                    <a:pt x="4539604" y="3254858"/>
+                  </a:lnTo>
+                  <a:lnTo>
+                    <a:pt x="4611226" y="3264481"/>
+                  </a:lnTo>
+                  <a:lnTo>
+                    <a:pt x="4682849" y="3273700"/>
+                  </a:lnTo>
+                  <a:lnTo>
+                    <a:pt x="4754472" y="3282531"/>
+                  </a:lnTo>
+                  <a:lnTo>
+                    <a:pt x="4826094" y="3290991"/>
+                  </a:lnTo>
+                  <a:lnTo>
+                    <a:pt x="4897717" y="3299095"/>
+                  </a:lnTo>
+                  <a:lnTo>
+                    <a:pt x="4969339" y="3306858"/>
+                  </a:lnTo>
+                  <a:lnTo>
+                    <a:pt x="5040962" y="3314295"/>
+                  </a:lnTo>
+                  <a:lnTo>
+                    <a:pt x="5112584" y="3321419"/>
+                  </a:lnTo>
+                  <a:lnTo>
+                    <a:pt x="5184207" y="3328244"/>
+                  </a:lnTo>
+                  <a:lnTo>
+                    <a:pt x="5255829" y="3334781"/>
+                  </a:lnTo>
+                  <a:lnTo>
+                    <a:pt x="5327452" y="3341044"/>
+                  </a:lnTo>
+                  <a:lnTo>
+                    <a:pt x="5399074" y="3347044"/>
+                  </a:lnTo>
+                  <a:lnTo>
+                    <a:pt x="5470697" y="3352791"/>
+                  </a:lnTo>
+                  <a:lnTo>
+                    <a:pt x="5542319" y="3358297"/>
+                  </a:lnTo>
+                  <a:lnTo>
+                    <a:pt x="5613942" y="3363571"/>
+                  </a:lnTo>
+                  <a:lnTo>
+                    <a:pt x="5685564" y="3368624"/>
+                  </a:lnTo>
+                  <a:lnTo>
+                    <a:pt x="5757187" y="3373464"/>
+                  </a:lnTo>
+                  <a:lnTo>
+                    <a:pt x="5828809" y="3378100"/>
+                  </a:lnTo>
+                  <a:lnTo>
+                    <a:pt x="5900432" y="3382542"/>
+                  </a:lnTo>
+                  <a:lnTo>
+                    <a:pt x="5972054" y="3386797"/>
+                  </a:lnTo>
+                  <a:lnTo>
+                    <a:pt x="6043677" y="3390873"/>
+                  </a:lnTo>
+                  <a:lnTo>
+                    <a:pt x="6115300" y="3394778"/>
+                  </a:lnTo>
+                  <a:lnTo>
+                    <a:pt x="6186922" y="3398518"/>
+                  </a:lnTo>
+                  <a:lnTo>
+                    <a:pt x="6186922" y="3482839"/>
+                  </a:lnTo>
+                  <a:lnTo>
+                    <a:pt x="6115300" y="3482715"/>
+                  </a:lnTo>
+                  <a:lnTo>
+                    <a:pt x="6043677" y="3482573"/>
+                  </a:lnTo>
+                  <a:lnTo>
+                    <a:pt x="5972054" y="3482412"/>
+                  </a:lnTo>
+                  <a:lnTo>
+                    <a:pt x="5900432" y="3482228"/>
+                  </a:lnTo>
+                  <a:lnTo>
+                    <a:pt x="5828809" y="3482020"/>
+                  </a:lnTo>
+                  <a:lnTo>
+                    <a:pt x="5757187" y="3481783"/>
+                  </a:lnTo>
+                  <a:lnTo>
+                    <a:pt x="5685564" y="3481513"/>
+                  </a:lnTo>
+                  <a:lnTo>
+                    <a:pt x="5613942" y="3481206"/>
+                  </a:lnTo>
+                  <a:lnTo>
+                    <a:pt x="5542319" y="3480857"/>
+                  </a:lnTo>
+                  <a:lnTo>
+                    <a:pt x="5470697" y="3480461"/>
+                  </a:lnTo>
+                  <a:lnTo>
+                    <a:pt x="5399074" y="3480009"/>
+                  </a:lnTo>
+                  <a:lnTo>
+                    <a:pt x="5327452" y="3479496"/>
+                  </a:lnTo>
+                  <a:lnTo>
+                    <a:pt x="5255829" y="3478912"/>
+                  </a:lnTo>
+                  <a:lnTo>
+                    <a:pt x="5184207" y="3478248"/>
+                  </a:lnTo>
+                  <a:lnTo>
+                    <a:pt x="5112584" y="3477493"/>
+                  </a:lnTo>
+                  <a:lnTo>
+                    <a:pt x="5040962" y="3476634"/>
+                  </a:lnTo>
+                  <a:lnTo>
+                    <a:pt x="4969339" y="3475657"/>
+                  </a:lnTo>
+                  <a:lnTo>
+                    <a:pt x="4897717" y="3474546"/>
+                  </a:lnTo>
+                  <a:lnTo>
+                    <a:pt x="4826094" y="3473282"/>
+                  </a:lnTo>
+                  <a:lnTo>
+                    <a:pt x="4754472" y="3471845"/>
+                  </a:lnTo>
+                  <a:lnTo>
+                    <a:pt x="4682849" y="3470211"/>
+                  </a:lnTo>
+                  <a:lnTo>
+                    <a:pt x="4611226" y="3468351"/>
+                  </a:lnTo>
+                  <a:lnTo>
+                    <a:pt x="4539604" y="3466237"/>
+                  </a:lnTo>
+                  <a:lnTo>
+                    <a:pt x="4467981" y="3463832"/>
+                  </a:lnTo>
+                  <a:lnTo>
+                    <a:pt x="4396359" y="3461096"/>
+                  </a:lnTo>
+                  <a:lnTo>
+                    <a:pt x="4324736" y="3457985"/>
+                  </a:lnTo>
+                  <a:lnTo>
+                    <a:pt x="4253114" y="3454447"/>
+                  </a:lnTo>
+                  <a:lnTo>
+                    <a:pt x="4181491" y="3450423"/>
+                  </a:lnTo>
+                  <a:lnTo>
+                    <a:pt x="4109869" y="3445846"/>
+                  </a:lnTo>
+                  <a:lnTo>
+                    <a:pt x="4038246" y="3440640"/>
+                  </a:lnTo>
+                  <a:lnTo>
+                    <a:pt x="3966624" y="3434719"/>
+                  </a:lnTo>
+                  <a:lnTo>
+                    <a:pt x="3895001" y="3427985"/>
+                  </a:lnTo>
+                  <a:lnTo>
+                    <a:pt x="3823379" y="3420326"/>
+                  </a:lnTo>
+                  <a:lnTo>
+                    <a:pt x="3751756" y="3411616"/>
+                  </a:lnTo>
+                  <a:lnTo>
+                    <a:pt x="3680134" y="3401708"/>
+                  </a:lnTo>
+                  <a:lnTo>
+                    <a:pt x="3608511" y="3390440"/>
+                  </a:lnTo>
+                  <a:lnTo>
+                    <a:pt x="3536889" y="3377624"/>
+                  </a:lnTo>
+                  <a:lnTo>
+                    <a:pt x="3465266" y="3363048"/>
+                  </a:lnTo>
+                  <a:lnTo>
+                    <a:pt x="3393644" y="3346470"/>
+                  </a:lnTo>
+                  <a:lnTo>
+                    <a:pt x="3322021" y="3327615"/>
+                  </a:lnTo>
+                  <a:lnTo>
+                    <a:pt x="3250398" y="3306170"/>
+                  </a:lnTo>
+                  <a:lnTo>
+                    <a:pt x="3178776" y="3281779"/>
+                  </a:lnTo>
+                  <a:lnTo>
+                    <a:pt x="3107153" y="3254039"/>
+                  </a:lnTo>
+                  <a:lnTo>
+                    <a:pt x="3035531" y="3222488"/>
+                  </a:lnTo>
+                  <a:lnTo>
+                    <a:pt x="2963908" y="3186604"/>
+                  </a:lnTo>
+                  <a:lnTo>
+                    <a:pt x="2892286" y="3145790"/>
+                  </a:lnTo>
+                  <a:lnTo>
+                    <a:pt x="2820663" y="3099371"/>
+                  </a:lnTo>
+                  <a:lnTo>
+                    <a:pt x="2749041" y="3046577"/>
+                  </a:lnTo>
+                  <a:lnTo>
+                    <a:pt x="2677418" y="2986530"/>
+                  </a:lnTo>
+                  <a:lnTo>
+                    <a:pt x="2605796" y="2918237"/>
+                  </a:lnTo>
+                  <a:lnTo>
+                    <a:pt x="2534173" y="2840563"/>
+                  </a:lnTo>
+                  <a:lnTo>
+                    <a:pt x="2462551" y="2752220"/>
+                  </a:lnTo>
+                  <a:lnTo>
+                    <a:pt x="2390928" y="2653436"/>
+                  </a:lnTo>
+                  <a:lnTo>
+                    <a:pt x="2319306" y="2616996"/>
+                  </a:lnTo>
+                  <a:lnTo>
+                    <a:pt x="2247683" y="2578956"/>
+                  </a:lnTo>
+                  <a:lnTo>
+                    <a:pt x="2176061" y="2539246"/>
+                  </a:lnTo>
+                  <a:lnTo>
+                    <a:pt x="2104438" y="2497794"/>
+                  </a:lnTo>
+                  <a:lnTo>
+                    <a:pt x="2032816" y="2454522"/>
+                  </a:lnTo>
+                  <a:lnTo>
+                    <a:pt x="1961193" y="2409352"/>
+                  </a:lnTo>
+                  <a:lnTo>
+                    <a:pt x="1889570" y="2362199"/>
+                  </a:lnTo>
+                  <a:lnTo>
+                    <a:pt x="1817948" y="2312976"/>
+                  </a:lnTo>
+                  <a:lnTo>
+                    <a:pt x="1746325" y="2261594"/>
+                  </a:lnTo>
+                  <a:lnTo>
+                    <a:pt x="1674703" y="2207956"/>
+                  </a:lnTo>
+                  <a:lnTo>
+                    <a:pt x="1603080" y="2151964"/>
+                  </a:lnTo>
+                  <a:lnTo>
+                    <a:pt x="1531458" y="2093515"/>
+                  </a:lnTo>
+                  <a:lnTo>
+                    <a:pt x="1459835" y="2032500"/>
+                  </a:lnTo>
+                  <a:lnTo>
+                    <a:pt x="1388213" y="1968808"/>
+                  </a:lnTo>
+                  <a:lnTo>
+                    <a:pt x="1316590" y="1902320"/>
+                  </a:lnTo>
+                  <a:lnTo>
+                    <a:pt x="1244968" y="1832914"/>
+                  </a:lnTo>
+                  <a:lnTo>
+                    <a:pt x="1173345" y="1760463"/>
+                  </a:lnTo>
+                  <a:lnTo>
+                    <a:pt x="1101723" y="1684831"/>
+                  </a:lnTo>
+                  <a:lnTo>
+                    <a:pt x="1030100" y="1605881"/>
+                  </a:lnTo>
+                  <a:lnTo>
+                    <a:pt x="958478" y="1523465"/>
+                  </a:lnTo>
+                  <a:lnTo>
+                    <a:pt x="886855" y="1437432"/>
+                  </a:lnTo>
+                  <a:lnTo>
+                    <a:pt x="815233" y="1347623"/>
+                  </a:lnTo>
+                  <a:lnTo>
+                    <a:pt x="743610" y="1253873"/>
+                  </a:lnTo>
+                  <a:lnTo>
+                    <a:pt x="671988" y="1156008"/>
+                  </a:lnTo>
+                  <a:lnTo>
+                    <a:pt x="600365" y="1053849"/>
+                  </a:lnTo>
+                  <a:lnTo>
+                    <a:pt x="528742" y="947205"/>
+                  </a:lnTo>
+                  <a:lnTo>
+                    <a:pt x="457120" y="835882"/>
+                  </a:lnTo>
+                  <a:lnTo>
+                    <a:pt x="385497" y="719672"/>
+                  </a:lnTo>
+                  <a:lnTo>
+                    <a:pt x="313875" y="598362"/>
+                  </a:lnTo>
+                  <a:lnTo>
+                    <a:pt x="242252" y="471729"/>
+                  </a:lnTo>
+                  <a:lnTo>
+                    <a:pt x="170630" y="339537"/>
+                  </a:lnTo>
+                  <a:lnTo>
+                    <a:pt x="99007" y="201544"/>
+                  </a:lnTo>
+                  <a:lnTo>
+                    <a:pt x="27385" y="57495"/>
                   </a:lnTo>
                   <a:lnTo>
                     <a:pt x="0" y="0"/>
@@ -3489,216 +3446,505 @@
         </p:sp>
         <p:sp>
           <p:nvSpPr>
+            <p:cNvPr id="21" name="pl21"/>
+            <p:cNvSpPr/>
+            <p:nvPr/>
+          </p:nvSpPr>
+          <p:spPr>
+            <a:xfrm>
+              <a:off x="3670270" y="2073503"/>
+              <a:ext cx="4592408" cy="3398518"/>
+            </a:xfrm>
+            <a:custGeom>
+              <a:avLst/>
+              <a:pathLst>
+                <a:path w="4592408" h="3398518">
+                  <a:moveTo>
+                    <a:pt x="0" y="0"/>
+                  </a:moveTo>
+                  <a:lnTo>
+                    <a:pt x="8567" y="56311"/>
+                  </a:lnTo>
+                  <a:lnTo>
+                    <a:pt x="80189" y="470224"/>
+                  </a:lnTo>
+                  <a:lnTo>
+                    <a:pt x="151812" y="834152"/>
+                  </a:lnTo>
+                  <a:lnTo>
+                    <a:pt x="223434" y="1154130"/>
+                  </a:lnTo>
+                  <a:lnTo>
+                    <a:pt x="295057" y="1435465"/>
+                  </a:lnTo>
+                  <a:lnTo>
+                    <a:pt x="366679" y="1682826"/>
+                  </a:lnTo>
+                  <a:lnTo>
+                    <a:pt x="438302" y="1900314"/>
+                  </a:lnTo>
+                  <a:lnTo>
+                    <a:pt x="509924" y="2091537"/>
+                  </a:lnTo>
+                  <a:lnTo>
+                    <a:pt x="581547" y="2259666"/>
+                  </a:lnTo>
+                  <a:lnTo>
+                    <a:pt x="653169" y="2407492"/>
+                  </a:lnTo>
+                  <a:lnTo>
+                    <a:pt x="724792" y="2537466"/>
+                  </a:lnTo>
+                  <a:lnTo>
+                    <a:pt x="796414" y="2651743"/>
+                  </a:lnTo>
+                  <a:lnTo>
+                    <a:pt x="868037" y="2688345"/>
+                  </a:lnTo>
+                  <a:lnTo>
+                    <a:pt x="939660" y="2721786"/>
+                  </a:lnTo>
+                  <a:lnTo>
+                    <a:pt x="1011282" y="2753821"/>
+                  </a:lnTo>
+                  <a:lnTo>
+                    <a:pt x="1082905" y="2784509"/>
+                  </a:lnTo>
+                  <a:lnTo>
+                    <a:pt x="1154527" y="2813907"/>
+                  </a:lnTo>
+                  <a:lnTo>
+                    <a:pt x="1226150" y="2842069"/>
+                  </a:lnTo>
+                  <a:lnTo>
+                    <a:pt x="1297772" y="2869047"/>
+                  </a:lnTo>
+                  <a:lnTo>
+                    <a:pt x="1369395" y="2894890"/>
+                  </a:lnTo>
+                  <a:lnTo>
+                    <a:pt x="1441017" y="2919648"/>
+                  </a:lnTo>
+                  <a:lnTo>
+                    <a:pt x="1512640" y="2943364"/>
+                  </a:lnTo>
+                  <a:lnTo>
+                    <a:pt x="1584262" y="2966083"/>
+                  </a:lnTo>
+                  <a:lnTo>
+                    <a:pt x="1655885" y="2987847"/>
+                  </a:lnTo>
+                  <a:lnTo>
+                    <a:pt x="1727507" y="3008696"/>
+                  </a:lnTo>
+                  <a:lnTo>
+                    <a:pt x="1799130" y="3028669"/>
+                  </a:lnTo>
+                  <a:lnTo>
+                    <a:pt x="1870752" y="3047801"/>
+                  </a:lnTo>
+                  <a:lnTo>
+                    <a:pt x="1942375" y="3066130"/>
+                  </a:lnTo>
+                  <a:lnTo>
+                    <a:pt x="2013997" y="3083687"/>
+                  </a:lnTo>
+                  <a:lnTo>
+                    <a:pt x="2085620" y="3100507"/>
+                  </a:lnTo>
+                  <a:lnTo>
+                    <a:pt x="2157242" y="3116620"/>
+                  </a:lnTo>
+                  <a:lnTo>
+                    <a:pt x="2228865" y="3132055"/>
+                  </a:lnTo>
+                  <a:lnTo>
+                    <a:pt x="2300488" y="3146841"/>
+                  </a:lnTo>
+                  <a:lnTo>
+                    <a:pt x="2372110" y="3161005"/>
+                  </a:lnTo>
+                  <a:lnTo>
+                    <a:pt x="2443733" y="3174574"/>
+                  </a:lnTo>
+                  <a:lnTo>
+                    <a:pt x="2515355" y="3187573"/>
+                  </a:lnTo>
+                  <a:lnTo>
+                    <a:pt x="2586978" y="3200025"/>
+                  </a:lnTo>
+                  <a:lnTo>
+                    <a:pt x="2658600" y="3211953"/>
+                  </a:lnTo>
+                  <a:lnTo>
+                    <a:pt x="2730223" y="3223380"/>
+                  </a:lnTo>
+                  <a:lnTo>
+                    <a:pt x="2801845" y="3234327"/>
+                  </a:lnTo>
+                  <a:lnTo>
+                    <a:pt x="2873468" y="3244813"/>
+                  </a:lnTo>
+                  <a:lnTo>
+                    <a:pt x="2945090" y="3254858"/>
+                  </a:lnTo>
+                  <a:lnTo>
+                    <a:pt x="3016713" y="3264481"/>
+                  </a:lnTo>
+                  <a:lnTo>
+                    <a:pt x="3088335" y="3273700"/>
+                  </a:lnTo>
+                  <a:lnTo>
+                    <a:pt x="3159958" y="3282531"/>
+                  </a:lnTo>
+                  <a:lnTo>
+                    <a:pt x="3231580" y="3290991"/>
+                  </a:lnTo>
+                  <a:lnTo>
+                    <a:pt x="3303203" y="3299095"/>
+                  </a:lnTo>
+                  <a:lnTo>
+                    <a:pt x="3374825" y="3306858"/>
+                  </a:lnTo>
+                  <a:lnTo>
+                    <a:pt x="3446448" y="3314295"/>
+                  </a:lnTo>
+                  <a:lnTo>
+                    <a:pt x="3518070" y="3321419"/>
+                  </a:lnTo>
+                  <a:lnTo>
+                    <a:pt x="3589693" y="3328244"/>
+                  </a:lnTo>
+                  <a:lnTo>
+                    <a:pt x="3661316" y="3334781"/>
+                  </a:lnTo>
+                  <a:lnTo>
+                    <a:pt x="3732938" y="3341044"/>
+                  </a:lnTo>
+                  <a:lnTo>
+                    <a:pt x="3804561" y="3347044"/>
+                  </a:lnTo>
+                  <a:lnTo>
+                    <a:pt x="3876183" y="3352791"/>
+                  </a:lnTo>
+                  <a:lnTo>
+                    <a:pt x="3947806" y="3358297"/>
+                  </a:lnTo>
+                  <a:lnTo>
+                    <a:pt x="4019428" y="3363571"/>
+                  </a:lnTo>
+                  <a:lnTo>
+                    <a:pt x="4091051" y="3368624"/>
+                  </a:lnTo>
+                  <a:lnTo>
+                    <a:pt x="4162673" y="3373464"/>
+                  </a:lnTo>
+                  <a:lnTo>
+                    <a:pt x="4234296" y="3378100"/>
+                  </a:lnTo>
+                  <a:lnTo>
+                    <a:pt x="4305918" y="3382542"/>
+                  </a:lnTo>
+                  <a:lnTo>
+                    <a:pt x="4377541" y="3386797"/>
+                  </a:lnTo>
+                  <a:lnTo>
+                    <a:pt x="4449163" y="3390873"/>
+                  </a:lnTo>
+                  <a:lnTo>
+                    <a:pt x="4520786" y="3394778"/>
+                  </a:lnTo>
+                  <a:lnTo>
+                    <a:pt x="4592408" y="3398518"/>
+                  </a:lnTo>
+                </a:path>
+              </a:pathLst>
+            </a:custGeom>
+          </p:spPr>
+          <p:txBody>
+            <a:bodyPr/>
+            <a:lstStyle/>
+            <a:p/>
+          </p:txBody>
+        </p:sp>
+        <p:sp>
+          <p:nvSpPr>
             <p:cNvPr id="22" name="pl22"/>
             <p:cNvSpPr/>
             <p:nvPr/>
           </p:nvSpPr>
           <p:spPr>
             <a:xfrm>
-              <a:off x="3256730" y="2073503"/>
-              <a:ext cx="4952828" cy="3398518"/>
+              <a:off x="2075756" y="2073503"/>
+              <a:ext cx="6186922" cy="3482839"/>
             </a:xfrm>
             <a:custGeom>
               <a:avLst/>
               <a:pathLst>
-                <a:path w="4952828" h="3398518">
+                <a:path w="6186922" h="3482839">
                   <a:moveTo>
+                    <a:pt x="6186922" y="3482839"/>
+                  </a:moveTo>
+                  <a:lnTo>
+                    <a:pt x="6115300" y="3482715"/>
+                  </a:lnTo>
+                  <a:lnTo>
+                    <a:pt x="6043677" y="3482573"/>
+                  </a:lnTo>
+                  <a:lnTo>
+                    <a:pt x="5972054" y="3482412"/>
+                  </a:lnTo>
+                  <a:lnTo>
+                    <a:pt x="5900432" y="3482228"/>
+                  </a:lnTo>
+                  <a:lnTo>
+                    <a:pt x="5828809" y="3482020"/>
+                  </a:lnTo>
+                  <a:lnTo>
+                    <a:pt x="5757187" y="3481783"/>
+                  </a:lnTo>
+                  <a:lnTo>
+                    <a:pt x="5685564" y="3481513"/>
+                  </a:lnTo>
+                  <a:lnTo>
+                    <a:pt x="5613942" y="3481206"/>
+                  </a:lnTo>
+                  <a:lnTo>
+                    <a:pt x="5542319" y="3480857"/>
+                  </a:lnTo>
+                  <a:lnTo>
+                    <a:pt x="5470697" y="3480461"/>
+                  </a:lnTo>
+                  <a:lnTo>
+                    <a:pt x="5399074" y="3480009"/>
+                  </a:lnTo>
+                  <a:lnTo>
+                    <a:pt x="5327452" y="3479496"/>
+                  </a:lnTo>
+                  <a:lnTo>
+                    <a:pt x="5255829" y="3478912"/>
+                  </a:lnTo>
+                  <a:lnTo>
+                    <a:pt x="5184207" y="3478248"/>
+                  </a:lnTo>
+                  <a:lnTo>
+                    <a:pt x="5112584" y="3477493"/>
+                  </a:lnTo>
+                  <a:lnTo>
+                    <a:pt x="5040962" y="3476634"/>
+                  </a:lnTo>
+                  <a:lnTo>
+                    <a:pt x="4969339" y="3475657"/>
+                  </a:lnTo>
+                  <a:lnTo>
+                    <a:pt x="4897717" y="3474546"/>
+                  </a:lnTo>
+                  <a:lnTo>
+                    <a:pt x="4826094" y="3473282"/>
+                  </a:lnTo>
+                  <a:lnTo>
+                    <a:pt x="4754472" y="3471845"/>
+                  </a:lnTo>
+                  <a:lnTo>
+                    <a:pt x="4682849" y="3470211"/>
+                  </a:lnTo>
+                  <a:lnTo>
+                    <a:pt x="4611226" y="3468351"/>
+                  </a:lnTo>
+                  <a:lnTo>
+                    <a:pt x="4539604" y="3466237"/>
+                  </a:lnTo>
+                  <a:lnTo>
+                    <a:pt x="4467981" y="3463832"/>
+                  </a:lnTo>
+                  <a:lnTo>
+                    <a:pt x="4396359" y="3461096"/>
+                  </a:lnTo>
+                  <a:lnTo>
+                    <a:pt x="4324736" y="3457985"/>
+                  </a:lnTo>
+                  <a:lnTo>
+                    <a:pt x="4253114" y="3454447"/>
+                  </a:lnTo>
+                  <a:lnTo>
+                    <a:pt x="4181491" y="3450423"/>
+                  </a:lnTo>
+                  <a:lnTo>
+                    <a:pt x="4109869" y="3445846"/>
+                  </a:lnTo>
+                  <a:lnTo>
+                    <a:pt x="4038246" y="3440640"/>
+                  </a:lnTo>
+                  <a:lnTo>
+                    <a:pt x="3966624" y="3434719"/>
+                  </a:lnTo>
+                  <a:lnTo>
+                    <a:pt x="3895001" y="3427985"/>
+                  </a:lnTo>
+                  <a:lnTo>
+                    <a:pt x="3823379" y="3420326"/>
+                  </a:lnTo>
+                  <a:lnTo>
+                    <a:pt x="3751756" y="3411616"/>
+                  </a:lnTo>
+                  <a:lnTo>
+                    <a:pt x="3680134" y="3401708"/>
+                  </a:lnTo>
+                  <a:lnTo>
+                    <a:pt x="3608511" y="3390440"/>
+                  </a:lnTo>
+                  <a:lnTo>
+                    <a:pt x="3536889" y="3377624"/>
+                  </a:lnTo>
+                  <a:lnTo>
+                    <a:pt x="3465266" y="3363048"/>
+                  </a:lnTo>
+                  <a:lnTo>
+                    <a:pt x="3393644" y="3346470"/>
+                  </a:lnTo>
+                  <a:lnTo>
+                    <a:pt x="3322021" y="3327615"/>
+                  </a:lnTo>
+                  <a:lnTo>
+                    <a:pt x="3250398" y="3306170"/>
+                  </a:lnTo>
+                  <a:lnTo>
+                    <a:pt x="3178776" y="3281779"/>
+                  </a:lnTo>
+                  <a:lnTo>
+                    <a:pt x="3107153" y="3254039"/>
+                  </a:lnTo>
+                  <a:lnTo>
+                    <a:pt x="3035531" y="3222488"/>
+                  </a:lnTo>
+                  <a:lnTo>
+                    <a:pt x="2963908" y="3186604"/>
+                  </a:lnTo>
+                  <a:lnTo>
+                    <a:pt x="2892286" y="3145790"/>
+                  </a:lnTo>
+                  <a:lnTo>
+                    <a:pt x="2820663" y="3099371"/>
+                  </a:lnTo>
+                  <a:lnTo>
+                    <a:pt x="2749041" y="3046577"/>
+                  </a:lnTo>
+                  <a:lnTo>
+                    <a:pt x="2677418" y="2986530"/>
+                  </a:lnTo>
+                  <a:lnTo>
+                    <a:pt x="2605796" y="2918237"/>
+                  </a:lnTo>
+                  <a:lnTo>
+                    <a:pt x="2534173" y="2840563"/>
+                  </a:lnTo>
+                  <a:lnTo>
+                    <a:pt x="2462551" y="2752220"/>
+                  </a:lnTo>
+                  <a:lnTo>
+                    <a:pt x="2390928" y="2653436"/>
+                  </a:lnTo>
+                  <a:lnTo>
+                    <a:pt x="2319306" y="2616996"/>
+                  </a:lnTo>
+                  <a:lnTo>
+                    <a:pt x="2247683" y="2578956"/>
+                  </a:lnTo>
+                  <a:lnTo>
+                    <a:pt x="2176061" y="2539246"/>
+                  </a:lnTo>
+                  <a:lnTo>
+                    <a:pt x="2104438" y="2497794"/>
+                  </a:lnTo>
+                  <a:lnTo>
+                    <a:pt x="2032816" y="2454522"/>
+                  </a:lnTo>
+                  <a:lnTo>
+                    <a:pt x="1961193" y="2409352"/>
+                  </a:lnTo>
+                  <a:lnTo>
+                    <a:pt x="1889570" y="2362199"/>
+                  </a:lnTo>
+                  <a:lnTo>
+                    <a:pt x="1817948" y="2312976"/>
+                  </a:lnTo>
+                  <a:lnTo>
+                    <a:pt x="1746325" y="2261594"/>
+                  </a:lnTo>
+                  <a:lnTo>
+                    <a:pt x="1674703" y="2207956"/>
+                  </a:lnTo>
+                  <a:lnTo>
+                    <a:pt x="1603080" y="2151964"/>
+                  </a:lnTo>
+                  <a:lnTo>
+                    <a:pt x="1531458" y="2093515"/>
+                  </a:lnTo>
+                  <a:lnTo>
+                    <a:pt x="1459835" y="2032500"/>
+                  </a:lnTo>
+                  <a:lnTo>
+                    <a:pt x="1388213" y="1968808"/>
+                  </a:lnTo>
+                  <a:lnTo>
+                    <a:pt x="1316590" y="1902320"/>
+                  </a:lnTo>
+                  <a:lnTo>
+                    <a:pt x="1244968" y="1832914"/>
+                  </a:lnTo>
+                  <a:lnTo>
+                    <a:pt x="1173345" y="1760463"/>
+                  </a:lnTo>
+                  <a:lnTo>
+                    <a:pt x="1101723" y="1684831"/>
+                  </a:lnTo>
+                  <a:lnTo>
+                    <a:pt x="1030100" y="1605881"/>
+                  </a:lnTo>
+                  <a:lnTo>
+                    <a:pt x="958478" y="1523465"/>
+                  </a:lnTo>
+                  <a:lnTo>
+                    <a:pt x="886855" y="1437432"/>
+                  </a:lnTo>
+                  <a:lnTo>
+                    <a:pt x="815233" y="1347623"/>
+                  </a:lnTo>
+                  <a:lnTo>
+                    <a:pt x="743610" y="1253873"/>
+                  </a:lnTo>
+                  <a:lnTo>
+                    <a:pt x="671988" y="1156008"/>
+                  </a:lnTo>
+                  <a:lnTo>
+                    <a:pt x="600365" y="1053849"/>
+                  </a:lnTo>
+                  <a:lnTo>
+                    <a:pt x="528742" y="947205"/>
+                  </a:lnTo>
+                  <a:lnTo>
+                    <a:pt x="457120" y="835882"/>
+                  </a:lnTo>
+                  <a:lnTo>
+                    <a:pt x="385497" y="719672"/>
+                  </a:lnTo>
+                  <a:lnTo>
+                    <a:pt x="313875" y="598362"/>
+                  </a:lnTo>
+                  <a:lnTo>
+                    <a:pt x="242252" y="471729"/>
+                  </a:lnTo>
+                  <a:lnTo>
+                    <a:pt x="170630" y="339537"/>
+                  </a:lnTo>
+                  <a:lnTo>
+                    <a:pt x="99007" y="201544"/>
+                  </a:lnTo>
+                  <a:lnTo>
+                    <a:pt x="27385" y="57495"/>
+                  </a:lnTo>
+                  <a:lnTo>
                     <a:pt x="0" y="0"/>
-                  </a:moveTo>
-                  <a:lnTo>
-                    <a:pt x="9239" y="56311"/>
-                  </a:lnTo>
-                  <a:lnTo>
-                    <a:pt x="86483" y="470224"/>
-                  </a:lnTo>
-                  <a:lnTo>
-                    <a:pt x="163726" y="834152"/>
-                  </a:lnTo>
-                  <a:lnTo>
-                    <a:pt x="240970" y="1154130"/>
-                  </a:lnTo>
-                  <a:lnTo>
-                    <a:pt x="318213" y="1435465"/>
-                  </a:lnTo>
-                  <a:lnTo>
-                    <a:pt x="395457" y="1682826"/>
-                  </a:lnTo>
-                  <a:lnTo>
-                    <a:pt x="472700" y="1900314"/>
-                  </a:lnTo>
-                  <a:lnTo>
-                    <a:pt x="549944" y="2091537"/>
-                  </a:lnTo>
-                  <a:lnTo>
-                    <a:pt x="627188" y="2259666"/>
-                  </a:lnTo>
-                  <a:lnTo>
-                    <a:pt x="704431" y="2407492"/>
-                  </a:lnTo>
-                  <a:lnTo>
-                    <a:pt x="781675" y="2537466"/>
-                  </a:lnTo>
-                  <a:lnTo>
-                    <a:pt x="858918" y="2651743"/>
-                  </a:lnTo>
-                  <a:lnTo>
-                    <a:pt x="936162" y="2688345"/>
-                  </a:lnTo>
-                  <a:lnTo>
-                    <a:pt x="1013405" y="2721786"/>
-                  </a:lnTo>
-                  <a:lnTo>
-                    <a:pt x="1090649" y="2753821"/>
-                  </a:lnTo>
-                  <a:lnTo>
-                    <a:pt x="1167893" y="2784509"/>
-                  </a:lnTo>
-                  <a:lnTo>
-                    <a:pt x="1245136" y="2813907"/>
-                  </a:lnTo>
-                  <a:lnTo>
-                    <a:pt x="1322380" y="2842069"/>
-                  </a:lnTo>
-                  <a:lnTo>
-                    <a:pt x="1399623" y="2869047"/>
-                  </a:lnTo>
-                  <a:lnTo>
-                    <a:pt x="1476867" y="2894890"/>
-                  </a:lnTo>
-                  <a:lnTo>
-                    <a:pt x="1554110" y="2919648"/>
-                  </a:lnTo>
-                  <a:lnTo>
-                    <a:pt x="1631354" y="2943364"/>
-                  </a:lnTo>
-                  <a:lnTo>
-                    <a:pt x="1708598" y="2966083"/>
-                  </a:lnTo>
-                  <a:lnTo>
-                    <a:pt x="1785841" y="2987847"/>
-                  </a:lnTo>
-                  <a:lnTo>
-                    <a:pt x="1863085" y="3008696"/>
-                  </a:lnTo>
-                  <a:lnTo>
-                    <a:pt x="1940328" y="3028669"/>
-                  </a:lnTo>
-                  <a:lnTo>
-                    <a:pt x="2017572" y="3047801"/>
-                  </a:lnTo>
-                  <a:lnTo>
-                    <a:pt x="2094816" y="3066130"/>
-                  </a:lnTo>
-                  <a:lnTo>
-                    <a:pt x="2172059" y="3083687"/>
-                  </a:lnTo>
-                  <a:lnTo>
-                    <a:pt x="2249303" y="3100507"/>
-                  </a:lnTo>
-                  <a:lnTo>
-                    <a:pt x="2326546" y="3116620"/>
-                  </a:lnTo>
-                  <a:lnTo>
-                    <a:pt x="2403790" y="3132055"/>
-                  </a:lnTo>
-                  <a:lnTo>
-                    <a:pt x="2481033" y="3146841"/>
-                  </a:lnTo>
-                  <a:lnTo>
-                    <a:pt x="2558277" y="3161005"/>
-                  </a:lnTo>
-                  <a:lnTo>
-                    <a:pt x="2635521" y="3174574"/>
-                  </a:lnTo>
-                  <a:lnTo>
-                    <a:pt x="2712764" y="3187573"/>
-                  </a:lnTo>
-                  <a:lnTo>
-                    <a:pt x="2790008" y="3200025"/>
-                  </a:lnTo>
-                  <a:lnTo>
-                    <a:pt x="2867251" y="3211953"/>
-                  </a:lnTo>
-                  <a:lnTo>
-                    <a:pt x="2944495" y="3223380"/>
-                  </a:lnTo>
-                  <a:lnTo>
-                    <a:pt x="3021738" y="3234327"/>
-                  </a:lnTo>
-                  <a:lnTo>
-                    <a:pt x="3098982" y="3244813"/>
-                  </a:lnTo>
-                  <a:lnTo>
-                    <a:pt x="3176226" y="3254858"/>
-                  </a:lnTo>
-                  <a:lnTo>
-                    <a:pt x="3253469" y="3264481"/>
-                  </a:lnTo>
-                  <a:lnTo>
-                    <a:pt x="3330713" y="3273700"/>
-                  </a:lnTo>
-                  <a:lnTo>
-                    <a:pt x="3407956" y="3282531"/>
-                  </a:lnTo>
-                  <a:lnTo>
-                    <a:pt x="3485200" y="3290991"/>
-                  </a:lnTo>
-                  <a:lnTo>
-                    <a:pt x="3562443" y="3299095"/>
-                  </a:lnTo>
-                  <a:lnTo>
-                    <a:pt x="3639687" y="3306858"/>
-                  </a:lnTo>
-                  <a:lnTo>
-                    <a:pt x="3716931" y="3314295"/>
-                  </a:lnTo>
-                  <a:lnTo>
-                    <a:pt x="3794174" y="3321419"/>
-                  </a:lnTo>
-                  <a:lnTo>
-                    <a:pt x="3871418" y="3328244"/>
-                  </a:lnTo>
-                  <a:lnTo>
-                    <a:pt x="3948661" y="3334781"/>
-                  </a:lnTo>
-                  <a:lnTo>
-                    <a:pt x="4025905" y="3341044"/>
-                  </a:lnTo>
-                  <a:lnTo>
-                    <a:pt x="4103148" y="3347044"/>
-                  </a:lnTo>
-                  <a:lnTo>
-                    <a:pt x="4180392" y="3352791"/>
-                  </a:lnTo>
-                  <a:lnTo>
-                    <a:pt x="4257636" y="3358297"/>
-                  </a:lnTo>
-                  <a:lnTo>
-                    <a:pt x="4334879" y="3363571"/>
-                  </a:lnTo>
-                  <a:lnTo>
-                    <a:pt x="4412123" y="3368624"/>
-                  </a:lnTo>
-                  <a:lnTo>
-                    <a:pt x="4489366" y="3373464"/>
-                  </a:lnTo>
-                  <a:lnTo>
-                    <a:pt x="4566610" y="3378100"/>
-                  </a:lnTo>
-                  <a:lnTo>
-                    <a:pt x="4643853" y="3382542"/>
-                  </a:lnTo>
-                  <a:lnTo>
-                    <a:pt x="4721097" y="3386797"/>
-                  </a:lnTo>
-                  <a:lnTo>
-                    <a:pt x="4798341" y="3390873"/>
-                  </a:lnTo>
-                  <a:lnTo>
-                    <a:pt x="4875584" y="3394778"/>
-                  </a:lnTo>
-                  <a:lnTo>
-                    <a:pt x="4952828" y="3398518"/>
                   </a:lnTo>
                 </a:path>
               </a:pathLst>
@@ -3718,514 +3964,225 @@
           </p:nvSpPr>
           <p:spPr>
             <a:xfrm>
-              <a:off x="1537077" y="2073503"/>
-              <a:ext cx="6672481" cy="3482839"/>
+              <a:off x="3271470" y="2073503"/>
+              <a:ext cx="4991208" cy="3474953"/>
             </a:xfrm>
             <a:custGeom>
               <a:avLst/>
               <a:pathLst>
-                <a:path w="6672481" h="3482839">
-                  <a:moveTo>
-                    <a:pt x="6672481" y="3482839"/>
-                  </a:moveTo>
-                  <a:lnTo>
-                    <a:pt x="6595238" y="3482715"/>
-                  </a:lnTo>
-                  <a:lnTo>
-                    <a:pt x="6517994" y="3482573"/>
-                  </a:lnTo>
-                  <a:lnTo>
-                    <a:pt x="6440751" y="3482412"/>
-                  </a:lnTo>
-                  <a:lnTo>
-                    <a:pt x="6363507" y="3482228"/>
-                  </a:lnTo>
-                  <a:lnTo>
-                    <a:pt x="6286263" y="3482020"/>
-                  </a:lnTo>
-                  <a:lnTo>
-                    <a:pt x="6209020" y="3481783"/>
-                  </a:lnTo>
-                  <a:lnTo>
-                    <a:pt x="6131776" y="3481513"/>
-                  </a:lnTo>
-                  <a:lnTo>
-                    <a:pt x="6054533" y="3481206"/>
-                  </a:lnTo>
-                  <a:lnTo>
-                    <a:pt x="5977289" y="3480857"/>
-                  </a:lnTo>
-                  <a:lnTo>
-                    <a:pt x="5900046" y="3480461"/>
-                  </a:lnTo>
-                  <a:lnTo>
-                    <a:pt x="5822802" y="3480009"/>
-                  </a:lnTo>
-                  <a:lnTo>
-                    <a:pt x="5745558" y="3479496"/>
-                  </a:lnTo>
-                  <a:lnTo>
-                    <a:pt x="5668315" y="3478912"/>
-                  </a:lnTo>
-                  <a:lnTo>
-                    <a:pt x="5591071" y="3478248"/>
-                  </a:lnTo>
-                  <a:lnTo>
-                    <a:pt x="5513828" y="3477493"/>
-                  </a:lnTo>
-                  <a:lnTo>
-                    <a:pt x="5436584" y="3476634"/>
-                  </a:lnTo>
-                  <a:lnTo>
-                    <a:pt x="5359341" y="3475657"/>
-                  </a:lnTo>
-                  <a:lnTo>
-                    <a:pt x="5282097" y="3474546"/>
-                  </a:lnTo>
-                  <a:lnTo>
-                    <a:pt x="5204853" y="3473282"/>
-                  </a:lnTo>
-                  <a:lnTo>
-                    <a:pt x="5127610" y="3471845"/>
-                  </a:lnTo>
-                  <a:lnTo>
-                    <a:pt x="5050366" y="3470211"/>
-                  </a:lnTo>
-                  <a:lnTo>
-                    <a:pt x="4973123" y="3468351"/>
-                  </a:lnTo>
-                  <a:lnTo>
-                    <a:pt x="4895879" y="3466237"/>
-                  </a:lnTo>
-                  <a:lnTo>
-                    <a:pt x="4818636" y="3463832"/>
-                  </a:lnTo>
-                  <a:lnTo>
-                    <a:pt x="4741392" y="3461096"/>
-                  </a:lnTo>
-                  <a:lnTo>
-                    <a:pt x="4664148" y="3457985"/>
-                  </a:lnTo>
-                  <a:lnTo>
-                    <a:pt x="4586905" y="3454447"/>
-                  </a:lnTo>
-                  <a:lnTo>
-                    <a:pt x="4509661" y="3450423"/>
-                  </a:lnTo>
-                  <a:lnTo>
-                    <a:pt x="4432418" y="3445846"/>
-                  </a:lnTo>
-                  <a:lnTo>
-                    <a:pt x="4355174" y="3440640"/>
-                  </a:lnTo>
-                  <a:lnTo>
-                    <a:pt x="4277931" y="3434719"/>
-                  </a:lnTo>
-                  <a:lnTo>
-                    <a:pt x="4200687" y="3427985"/>
-                  </a:lnTo>
-                  <a:lnTo>
-                    <a:pt x="4123443" y="3420326"/>
-                  </a:lnTo>
-                  <a:lnTo>
-                    <a:pt x="4046200" y="3411616"/>
-                  </a:lnTo>
-                  <a:lnTo>
-                    <a:pt x="3968956" y="3401708"/>
-                  </a:lnTo>
-                  <a:lnTo>
-                    <a:pt x="3891713" y="3390440"/>
-                  </a:lnTo>
-                  <a:lnTo>
-                    <a:pt x="3814469" y="3377624"/>
-                  </a:lnTo>
-                  <a:lnTo>
-                    <a:pt x="3737226" y="3363048"/>
-                  </a:lnTo>
-                  <a:lnTo>
-                    <a:pt x="3659982" y="3346470"/>
-                  </a:lnTo>
-                  <a:lnTo>
-                    <a:pt x="3582738" y="3327615"/>
-                  </a:lnTo>
-                  <a:lnTo>
-                    <a:pt x="3505495" y="3306170"/>
-                  </a:lnTo>
-                  <a:lnTo>
-                    <a:pt x="3428251" y="3281779"/>
-                  </a:lnTo>
-                  <a:lnTo>
-                    <a:pt x="3351008" y="3254039"/>
-                  </a:lnTo>
-                  <a:lnTo>
-                    <a:pt x="3273764" y="3222488"/>
-                  </a:lnTo>
-                  <a:lnTo>
-                    <a:pt x="3196521" y="3186604"/>
-                  </a:lnTo>
-                  <a:lnTo>
-                    <a:pt x="3119277" y="3145790"/>
-                  </a:lnTo>
-                  <a:lnTo>
-                    <a:pt x="3042033" y="3099371"/>
-                  </a:lnTo>
-                  <a:lnTo>
-                    <a:pt x="2964790" y="3046577"/>
-                  </a:lnTo>
-                  <a:lnTo>
-                    <a:pt x="2887546" y="2986530"/>
-                  </a:lnTo>
-                  <a:lnTo>
-                    <a:pt x="2810303" y="2918237"/>
-                  </a:lnTo>
-                  <a:lnTo>
-                    <a:pt x="2733059" y="2840563"/>
-                  </a:lnTo>
-                  <a:lnTo>
-                    <a:pt x="2655816" y="2752220"/>
-                  </a:lnTo>
-                  <a:lnTo>
-                    <a:pt x="2578572" y="2653436"/>
-                  </a:lnTo>
-                  <a:lnTo>
-                    <a:pt x="2501328" y="2616996"/>
-                  </a:lnTo>
-                  <a:lnTo>
-                    <a:pt x="2424085" y="2578956"/>
-                  </a:lnTo>
-                  <a:lnTo>
-                    <a:pt x="2346841" y="2539246"/>
-                  </a:lnTo>
-                  <a:lnTo>
-                    <a:pt x="2269598" y="2497794"/>
-                  </a:lnTo>
-                  <a:lnTo>
-                    <a:pt x="2192354" y="2454522"/>
-                  </a:lnTo>
-                  <a:lnTo>
-                    <a:pt x="2115111" y="2409352"/>
-                  </a:lnTo>
-                  <a:lnTo>
-                    <a:pt x="2037867" y="2362199"/>
-                  </a:lnTo>
-                  <a:lnTo>
-                    <a:pt x="1960623" y="2312976"/>
-                  </a:lnTo>
-                  <a:lnTo>
-                    <a:pt x="1883380" y="2261594"/>
-                  </a:lnTo>
-                  <a:lnTo>
-                    <a:pt x="1806136" y="2207956"/>
-                  </a:lnTo>
-                  <a:lnTo>
-                    <a:pt x="1728893" y="2151964"/>
-                  </a:lnTo>
-                  <a:lnTo>
-                    <a:pt x="1651649" y="2093515"/>
-                  </a:lnTo>
-                  <a:lnTo>
-                    <a:pt x="1574405" y="2032500"/>
-                  </a:lnTo>
-                  <a:lnTo>
-                    <a:pt x="1497162" y="1968808"/>
-                  </a:lnTo>
-                  <a:lnTo>
-                    <a:pt x="1419918" y="1902320"/>
-                  </a:lnTo>
-                  <a:lnTo>
-                    <a:pt x="1342675" y="1832914"/>
-                  </a:lnTo>
-                  <a:lnTo>
-                    <a:pt x="1265431" y="1760463"/>
-                  </a:lnTo>
-                  <a:lnTo>
-                    <a:pt x="1188188" y="1684831"/>
-                  </a:lnTo>
-                  <a:lnTo>
-                    <a:pt x="1110944" y="1605881"/>
-                  </a:lnTo>
-                  <a:lnTo>
-                    <a:pt x="1033700" y="1523465"/>
-                  </a:lnTo>
-                  <a:lnTo>
-                    <a:pt x="956457" y="1437432"/>
-                  </a:lnTo>
-                  <a:lnTo>
-                    <a:pt x="879213" y="1347623"/>
-                  </a:lnTo>
-                  <a:lnTo>
-                    <a:pt x="801970" y="1253873"/>
-                  </a:lnTo>
-                  <a:lnTo>
-                    <a:pt x="724726" y="1156008"/>
-                  </a:lnTo>
-                  <a:lnTo>
-                    <a:pt x="647483" y="1053849"/>
-                  </a:lnTo>
-                  <a:lnTo>
-                    <a:pt x="570239" y="947205"/>
-                  </a:lnTo>
-                  <a:lnTo>
-                    <a:pt x="492995" y="835882"/>
-                  </a:lnTo>
-                  <a:lnTo>
-                    <a:pt x="415752" y="719672"/>
-                  </a:lnTo>
-                  <a:lnTo>
-                    <a:pt x="338508" y="598362"/>
-                  </a:lnTo>
-                  <a:lnTo>
-                    <a:pt x="261265" y="471729"/>
-                  </a:lnTo>
-                  <a:lnTo>
-                    <a:pt x="184021" y="339537"/>
-                  </a:lnTo>
-                  <a:lnTo>
-                    <a:pt x="106778" y="201544"/>
-                  </a:lnTo>
-                  <a:lnTo>
-                    <a:pt x="29534" y="57495"/>
-                  </a:lnTo>
-                  <a:lnTo>
-                    <a:pt x="0" y="0"/>
-                  </a:lnTo>
-                </a:path>
-              </a:pathLst>
-            </a:custGeom>
-          </p:spPr>
-          <p:txBody>
-            <a:bodyPr/>
-            <a:lstStyle/>
-            <a:p/>
-          </p:txBody>
-        </p:sp>
-        <p:sp>
-          <p:nvSpPr>
-            <p:cNvPr id="24" name="pl24"/>
-            <p:cNvSpPr/>
-            <p:nvPr/>
-          </p:nvSpPr>
-          <p:spPr>
-            <a:xfrm>
-              <a:off x="2826632" y="2073503"/>
-              <a:ext cx="5382926" cy="3474953"/>
-            </a:xfrm>
-            <a:custGeom>
-              <a:avLst/>
-              <a:pathLst>
-                <a:path w="5382926" h="3474953">
+                <a:path w="4991208" h="3474953">
                   <a:moveTo>
                     <a:pt x="0" y="0"/>
                   </a:moveTo>
                   <a:lnTo>
-                    <a:pt x="53119" y="202238"/>
-                  </a:lnTo>
-                  <a:lnTo>
-                    <a:pt x="130363" y="472134"/>
-                  </a:lnTo>
-                  <a:lnTo>
-                    <a:pt x="207606" y="719832"/>
-                  </a:lnTo>
-                  <a:lnTo>
-                    <a:pt x="284850" y="947157"/>
-                  </a:lnTo>
-                  <a:lnTo>
-                    <a:pt x="362094" y="1155785"/>
-                  </a:lnTo>
-                  <a:lnTo>
-                    <a:pt x="439337" y="1347254"/>
-                  </a:lnTo>
-                  <a:lnTo>
-                    <a:pt x="516581" y="1522975"/>
-                  </a:lnTo>
-                  <a:lnTo>
-                    <a:pt x="593824" y="1684244"/>
-                  </a:lnTo>
-                  <a:lnTo>
-                    <a:pt x="671068" y="1832248"/>
-                  </a:lnTo>
-                  <a:lnTo>
-                    <a:pt x="748311" y="1968080"/>
-                  </a:lnTo>
-                  <a:lnTo>
-                    <a:pt x="825555" y="2092740"/>
-                  </a:lnTo>
-                  <a:lnTo>
-                    <a:pt x="902799" y="2207147"/>
-                  </a:lnTo>
-                  <a:lnTo>
-                    <a:pt x="980042" y="2312144"/>
-                  </a:lnTo>
-                  <a:lnTo>
-                    <a:pt x="1057286" y="2408505"/>
-                  </a:lnTo>
-                  <a:lnTo>
-                    <a:pt x="1134529" y="2496941"/>
-                  </a:lnTo>
-                  <a:lnTo>
-                    <a:pt x="1211773" y="2578103"/>
-                  </a:lnTo>
-                  <a:lnTo>
-                    <a:pt x="1289016" y="2652590"/>
-                  </a:lnTo>
-                  <a:lnTo>
-                    <a:pt x="1366260" y="2720951"/>
-                  </a:lnTo>
-                  <a:lnTo>
-                    <a:pt x="1443504" y="2783689"/>
-                  </a:lnTo>
-                  <a:lnTo>
-                    <a:pt x="1520747" y="2841267"/>
-                  </a:lnTo>
-                  <a:lnTo>
-                    <a:pt x="1597991" y="2894109"/>
-                  </a:lnTo>
-                  <a:lnTo>
-                    <a:pt x="1675234" y="2942605"/>
-                  </a:lnTo>
-                  <a:lnTo>
-                    <a:pt x="1752478" y="2987113"/>
-                  </a:lnTo>
-                  <a:lnTo>
-                    <a:pt x="1829721" y="3027960"/>
-                  </a:lnTo>
-                  <a:lnTo>
-                    <a:pt x="1906965" y="3065447"/>
-                  </a:lnTo>
-                  <a:lnTo>
-                    <a:pt x="1984209" y="3099851"/>
-                  </a:lnTo>
-                  <a:lnTo>
-                    <a:pt x="2061452" y="3131426"/>
-                  </a:lnTo>
-                  <a:lnTo>
-                    <a:pt x="2138696" y="3160403"/>
-                  </a:lnTo>
-                  <a:lnTo>
-                    <a:pt x="2215939" y="3186997"/>
-                  </a:lnTo>
-                  <a:lnTo>
-                    <a:pt x="2293183" y="3211404"/>
-                  </a:lnTo>
-                  <a:lnTo>
-                    <a:pt x="2370426" y="3233804"/>
-                  </a:lnTo>
-                  <a:lnTo>
-                    <a:pt x="2447670" y="3254361"/>
-                  </a:lnTo>
-                  <a:lnTo>
-                    <a:pt x="2524914" y="3273227"/>
-                  </a:lnTo>
-                  <a:lnTo>
-                    <a:pt x="2602157" y="3290542"/>
-                  </a:lnTo>
-                  <a:lnTo>
-                    <a:pt x="2679401" y="3306432"/>
-                  </a:lnTo>
-                  <a:lnTo>
-                    <a:pt x="2756644" y="3321016"/>
-                  </a:lnTo>
-                  <a:lnTo>
-                    <a:pt x="2833888" y="3334400"/>
-                  </a:lnTo>
-                  <a:lnTo>
-                    <a:pt x="2911131" y="3346684"/>
-                  </a:lnTo>
-                  <a:lnTo>
-                    <a:pt x="2988375" y="3357957"/>
-                  </a:lnTo>
-                  <a:lnTo>
-                    <a:pt x="3065619" y="3368303"/>
-                  </a:lnTo>
-                  <a:lnTo>
-                    <a:pt x="3142862" y="3377798"/>
-                  </a:lnTo>
-                  <a:lnTo>
-                    <a:pt x="3220106" y="3386512"/>
-                  </a:lnTo>
-                  <a:lnTo>
-                    <a:pt x="3297349" y="3394509"/>
-                  </a:lnTo>
-                  <a:lnTo>
-                    <a:pt x="3374593" y="3401848"/>
-                  </a:lnTo>
-                  <a:lnTo>
-                    <a:pt x="3451836" y="3408584"/>
-                  </a:lnTo>
-                  <a:lnTo>
-                    <a:pt x="3529080" y="3414766"/>
-                  </a:lnTo>
-                  <a:lnTo>
-                    <a:pt x="3606324" y="3420440"/>
-                  </a:lnTo>
-                  <a:lnTo>
-                    <a:pt x="3683567" y="3425646"/>
-                  </a:lnTo>
-                  <a:lnTo>
-                    <a:pt x="3760811" y="3430425"/>
-                  </a:lnTo>
-                  <a:lnTo>
-                    <a:pt x="3838054" y="3434811"/>
-                  </a:lnTo>
-                  <a:lnTo>
-                    <a:pt x="3915298" y="3438835"/>
-                  </a:lnTo>
-                  <a:lnTo>
-                    <a:pt x="3992541" y="3442529"/>
-                  </a:lnTo>
-                  <a:lnTo>
-                    <a:pt x="4069785" y="3445919"/>
-                  </a:lnTo>
-                  <a:lnTo>
-                    <a:pt x="4147029" y="3449030"/>
-                  </a:lnTo>
-                  <a:lnTo>
-                    <a:pt x="4224272" y="3451886"/>
-                  </a:lnTo>
-                  <a:lnTo>
-                    <a:pt x="4301516" y="3454506"/>
-                  </a:lnTo>
-                  <a:lnTo>
-                    <a:pt x="4378759" y="3456911"/>
-                  </a:lnTo>
-                  <a:lnTo>
-                    <a:pt x="4456003" y="3459118"/>
-                  </a:lnTo>
-                  <a:lnTo>
-                    <a:pt x="4533246" y="3461144"/>
-                  </a:lnTo>
-                  <a:lnTo>
-                    <a:pt x="4610490" y="3463003"/>
-                  </a:lnTo>
-                  <a:lnTo>
-                    <a:pt x="4687734" y="3464709"/>
-                  </a:lnTo>
-                  <a:lnTo>
-                    <a:pt x="4764977" y="3466275"/>
-                  </a:lnTo>
-                  <a:lnTo>
-                    <a:pt x="4842221" y="3467712"/>
-                  </a:lnTo>
-                  <a:lnTo>
-                    <a:pt x="4919464" y="3469031"/>
-                  </a:lnTo>
-                  <a:lnTo>
-                    <a:pt x="4996708" y="3470241"/>
-                  </a:lnTo>
-                  <a:lnTo>
-                    <a:pt x="5073951" y="3471352"/>
-                  </a:lnTo>
-                  <a:lnTo>
-                    <a:pt x="5151195" y="3472371"/>
-                  </a:lnTo>
-                  <a:lnTo>
-                    <a:pt x="5228439" y="3473307"/>
-                  </a:lnTo>
-                  <a:lnTo>
-                    <a:pt x="5305682" y="3474165"/>
-                  </a:lnTo>
-                  <a:lnTo>
-                    <a:pt x="5382926" y="3474953"/>
+                    <a:pt x="49254" y="202238"/>
+                  </a:lnTo>
+                  <a:lnTo>
+                    <a:pt x="120876" y="472134"/>
+                  </a:lnTo>
+                  <a:lnTo>
+                    <a:pt x="192499" y="719832"/>
+                  </a:lnTo>
+                  <a:lnTo>
+                    <a:pt x="264121" y="947157"/>
+                  </a:lnTo>
+                  <a:lnTo>
+                    <a:pt x="335744" y="1155785"/>
+                  </a:lnTo>
+                  <a:lnTo>
+                    <a:pt x="407366" y="1347254"/>
+                  </a:lnTo>
+                  <a:lnTo>
+                    <a:pt x="478989" y="1522975"/>
+                  </a:lnTo>
+                  <a:lnTo>
+                    <a:pt x="550611" y="1684244"/>
+                  </a:lnTo>
+                  <a:lnTo>
+                    <a:pt x="622234" y="1832248"/>
+                  </a:lnTo>
+                  <a:lnTo>
+                    <a:pt x="693857" y="1968080"/>
+                  </a:lnTo>
+                  <a:lnTo>
+                    <a:pt x="765479" y="2092740"/>
+                  </a:lnTo>
+                  <a:lnTo>
+                    <a:pt x="837102" y="2207147"/>
+                  </a:lnTo>
+                  <a:lnTo>
+                    <a:pt x="908724" y="2312144"/>
+                  </a:lnTo>
+                  <a:lnTo>
+                    <a:pt x="980347" y="2408505"/>
+                  </a:lnTo>
+                  <a:lnTo>
+                    <a:pt x="1051969" y="2496941"/>
+                  </a:lnTo>
+                  <a:lnTo>
+                    <a:pt x="1123592" y="2578103"/>
+                  </a:lnTo>
+                  <a:lnTo>
+                    <a:pt x="1195214" y="2652590"/>
+                  </a:lnTo>
+                  <a:lnTo>
+                    <a:pt x="1266837" y="2720951"/>
+                  </a:lnTo>
+                  <a:lnTo>
+                    <a:pt x="1338459" y="2783689"/>
+                  </a:lnTo>
+                  <a:lnTo>
+                    <a:pt x="1410082" y="2841267"/>
+                  </a:lnTo>
+                  <a:lnTo>
+                    <a:pt x="1481704" y="2894109"/>
+                  </a:lnTo>
+                  <a:lnTo>
+                    <a:pt x="1553327" y="2942605"/>
+                  </a:lnTo>
+                  <a:lnTo>
+                    <a:pt x="1624949" y="2987113"/>
+                  </a:lnTo>
+                  <a:lnTo>
+                    <a:pt x="1696572" y="3027960"/>
+                  </a:lnTo>
+                  <a:lnTo>
+                    <a:pt x="1768194" y="3065447"/>
+                  </a:lnTo>
+                  <a:lnTo>
+                    <a:pt x="1839817" y="3099851"/>
+                  </a:lnTo>
+                  <a:lnTo>
+                    <a:pt x="1911439" y="3131426"/>
+                  </a:lnTo>
+                  <a:lnTo>
+                    <a:pt x="1983062" y="3160403"/>
+                  </a:lnTo>
+                  <a:lnTo>
+                    <a:pt x="2054685" y="3186997"/>
+                  </a:lnTo>
+                  <a:lnTo>
+                    <a:pt x="2126307" y="3211404"/>
+                  </a:lnTo>
+                  <a:lnTo>
+                    <a:pt x="2197930" y="3233804"/>
+                  </a:lnTo>
+                  <a:lnTo>
+                    <a:pt x="2269552" y="3254361"/>
+                  </a:lnTo>
+                  <a:lnTo>
+                    <a:pt x="2341175" y="3273227"/>
+                  </a:lnTo>
+                  <a:lnTo>
+                    <a:pt x="2412797" y="3290542"/>
+                  </a:lnTo>
+                  <a:lnTo>
+                    <a:pt x="2484420" y="3306432"/>
+                  </a:lnTo>
+                  <a:lnTo>
+                    <a:pt x="2556042" y="3321016"/>
+                  </a:lnTo>
+                  <a:lnTo>
+                    <a:pt x="2627665" y="3334400"/>
+                  </a:lnTo>
+                  <a:lnTo>
+                    <a:pt x="2699287" y="3346684"/>
+                  </a:lnTo>
+                  <a:lnTo>
+                    <a:pt x="2770910" y="3357957"/>
+                  </a:lnTo>
+                  <a:lnTo>
+                    <a:pt x="2842532" y="3368303"/>
+                  </a:lnTo>
+                  <a:lnTo>
+                    <a:pt x="2914155" y="3377798"/>
+                  </a:lnTo>
+                  <a:lnTo>
+                    <a:pt x="2985777" y="3386512"/>
+                  </a:lnTo>
+                  <a:lnTo>
+                    <a:pt x="3057400" y="3394509"/>
+                  </a:lnTo>
+                  <a:lnTo>
+                    <a:pt x="3129022" y="3401848"/>
+                  </a:lnTo>
+                  <a:lnTo>
+                    <a:pt x="3200645" y="3408584"/>
+                  </a:lnTo>
+                  <a:lnTo>
+                    <a:pt x="3272267" y="3414766"/>
+                  </a:lnTo>
+                  <a:lnTo>
+                    <a:pt x="3343890" y="3420440"/>
+                  </a:lnTo>
+                  <a:lnTo>
+                    <a:pt x="3415512" y="3425646"/>
+                  </a:lnTo>
+                  <a:lnTo>
+                    <a:pt x="3487135" y="3430425"/>
+                  </a:lnTo>
+                  <a:lnTo>
+                    <a:pt x="3558758" y="3434811"/>
+                  </a:lnTo>
+                  <a:lnTo>
+                    <a:pt x="3630380" y="3438835"/>
+                  </a:lnTo>
+                  <a:lnTo>
+                    <a:pt x="3702003" y="3442529"/>
+                  </a:lnTo>
+                  <a:lnTo>
+                    <a:pt x="3773625" y="3445919"/>
+                  </a:lnTo>
+                  <a:lnTo>
+                    <a:pt x="3845248" y="3449030"/>
+                  </a:lnTo>
+                  <a:lnTo>
+                    <a:pt x="3916870" y="3451886"/>
+                  </a:lnTo>
+                  <a:lnTo>
+                    <a:pt x="3988493" y="3454506"/>
+                  </a:lnTo>
+                  <a:lnTo>
+                    <a:pt x="4060115" y="3456911"/>
+                  </a:lnTo>
+                  <a:lnTo>
+                    <a:pt x="4131738" y="3459118"/>
+                  </a:lnTo>
+                  <a:lnTo>
+                    <a:pt x="4203360" y="3461144"/>
+                  </a:lnTo>
+                  <a:lnTo>
+                    <a:pt x="4274983" y="3463003"/>
+                  </a:lnTo>
+                  <a:lnTo>
+                    <a:pt x="4346605" y="3464709"/>
+                  </a:lnTo>
+                  <a:lnTo>
+                    <a:pt x="4418228" y="3466275"/>
+                  </a:lnTo>
+                  <a:lnTo>
+                    <a:pt x="4489850" y="3467712"/>
+                  </a:lnTo>
+                  <a:lnTo>
+                    <a:pt x="4561473" y="3469031"/>
+                  </a:lnTo>
+                  <a:lnTo>
+                    <a:pt x="4633095" y="3470241"/>
+                  </a:lnTo>
+                  <a:lnTo>
+                    <a:pt x="4704718" y="3471352"/>
+                  </a:lnTo>
+                  <a:lnTo>
+                    <a:pt x="4776340" y="3472371"/>
+                  </a:lnTo>
+                  <a:lnTo>
+                    <a:pt x="4847963" y="3473307"/>
+                  </a:lnTo>
+                  <a:lnTo>
+                    <a:pt x="4919586" y="3474165"/>
+                  </a:lnTo>
+                  <a:lnTo>
+                    <a:pt x="4991208" y="3474953"/>
                   </a:lnTo>
                 </a:path>
               </a:pathLst>
@@ -4248,7 +4205,7 @@
         </p:sp>
         <p:sp>
           <p:nvSpPr>
-            <p:cNvPr id="25" name="pl25"/>
+            <p:cNvPr id="24" name="pl24"/>
             <p:cNvSpPr/>
             <p:nvPr/>
           </p:nvSpPr>
@@ -4291,13 +4248,13 @@
         </p:sp>
         <p:sp>
           <p:nvSpPr>
-            <p:cNvPr id="26" name="pl26"/>
+            <p:cNvPr id="25" name="pl25"/>
             <p:cNvSpPr/>
             <p:nvPr/>
           </p:nvSpPr>
           <p:spPr>
             <a:xfrm>
-              <a:off x="4117484" y="2073503"/>
+              <a:off x="4468386" y="2073503"/>
               <a:ext cx="0" cy="3649639"/>
             </a:xfrm>
             <a:custGeom>
@@ -4334,7 +4291,7 @@
         </p:sp>
         <p:sp>
           <p:nvSpPr>
-            <p:cNvPr id="27" name="tx27"/>
+            <p:cNvPr id="26" name="tx26"/>
             <p:cNvSpPr/>
             <p:nvPr/>
           </p:nvSpPr>
@@ -4380,7 +4337,7 @@
         </p:sp>
         <p:sp>
           <p:nvSpPr>
-            <p:cNvPr id="28" name="tx28"/>
+            <p:cNvPr id="27" name="tx27"/>
             <p:cNvSpPr/>
             <p:nvPr/>
           </p:nvSpPr>
@@ -4426,7 +4383,7 @@
         </p:sp>
         <p:sp>
           <p:nvSpPr>
-            <p:cNvPr id="29" name="tx29"/>
+            <p:cNvPr id="28" name="tx28"/>
             <p:cNvSpPr/>
             <p:nvPr/>
           </p:nvSpPr>
@@ -4472,7 +4429,7 @@
         </p:sp>
         <p:sp>
           <p:nvSpPr>
-            <p:cNvPr id="30" name="tx30"/>
+            <p:cNvPr id="29" name="tx29"/>
             <p:cNvSpPr/>
             <p:nvPr/>
           </p:nvSpPr>
@@ -4518,7 +4475,7 @@
         </p:sp>
         <p:sp>
           <p:nvSpPr>
-            <p:cNvPr id="31" name="tx31"/>
+            <p:cNvPr id="30" name="tx30"/>
             <p:cNvSpPr/>
             <p:nvPr/>
           </p:nvSpPr>
@@ -4564,14 +4521,14 @@
         </p:sp>
         <p:sp>
           <p:nvSpPr>
-            <p:cNvPr id="32" name="tx32"/>
+            <p:cNvPr id="31" name="tx31"/>
             <p:cNvSpPr/>
             <p:nvPr/>
           </p:nvSpPr>
           <p:spPr>
             <a:xfrm>
-              <a:off x="2423864" y="5785772"/>
-              <a:ext cx="155356" cy="80101"/>
+              <a:off x="2478335" y="5785772"/>
+              <a:ext cx="161574" cy="80101"/>
             </a:xfrm>
             <a:prstGeom prst="rect">
               <a:avLst/>
@@ -4603,21 +4560,21 @@
                   <a:latin typeface="Helvetica"/>
                   <a:cs typeface="Helvetica"/>
                 </a:rPr>
-                <a:t>0.8</a:t>
+                <a:t>-25</a:t>
               </a:r>
             </a:p>
           </p:txBody>
         </p:sp>
         <p:sp>
           <p:nvSpPr>
-            <p:cNvPr id="33" name="tx33"/>
+            <p:cNvPr id="32" name="tx32"/>
             <p:cNvSpPr/>
             <p:nvPr/>
           </p:nvSpPr>
           <p:spPr>
             <a:xfrm>
-              <a:off x="4196521" y="5785772"/>
-              <a:ext cx="155356" cy="80101"/>
+              <a:off x="4582608" y="5785772"/>
+              <a:ext cx="62179" cy="80101"/>
             </a:xfrm>
             <a:prstGeom prst="rect">
               <a:avLst/>
@@ -4649,21 +4606,21 @@
                   <a:latin typeface="Helvetica"/>
                   <a:cs typeface="Helvetica"/>
                 </a:rPr>
-                <a:t>1.0</a:t>
+                <a:t>0</a:t>
               </a:r>
             </a:p>
           </p:txBody>
         </p:sp>
         <p:sp>
           <p:nvSpPr>
-            <p:cNvPr id="34" name="tx34"/>
+            <p:cNvPr id="33" name="tx33"/>
             <p:cNvSpPr/>
             <p:nvPr/>
           </p:nvSpPr>
           <p:spPr>
             <a:xfrm>
-              <a:off x="5969179" y="5785772"/>
-              <a:ext cx="155356" cy="80101"/>
+              <a:off x="6606094" y="5785772"/>
+              <a:ext cx="124358" cy="80101"/>
             </a:xfrm>
             <a:prstGeom prst="rect">
               <a:avLst/>
@@ -4695,67 +4652,21 @@
                   <a:latin typeface="Helvetica"/>
                   <a:cs typeface="Helvetica"/>
                 </a:rPr>
-                <a:t>1.2</a:t>
+                <a:t>25</a:t>
               </a:r>
             </a:p>
           </p:txBody>
         </p:sp>
         <p:sp>
           <p:nvSpPr>
-            <p:cNvPr id="35" name="tx35"/>
+            <p:cNvPr id="34" name="tx34"/>
             <p:cNvSpPr/>
             <p:nvPr/>
           </p:nvSpPr>
           <p:spPr>
             <a:xfrm>
-              <a:off x="7741836" y="5785772"/>
-              <a:ext cx="155356" cy="80101"/>
-            </a:xfrm>
-            <a:prstGeom prst="rect">
-              <a:avLst/>
-            </a:prstGeom>
-            <a:noFill/>
-          </p:spPr>
-          <p:txBody>
-            <a:bodyPr lIns="0" rIns="0" tIns="0" bIns="0" anchorCtr="1" anchor="ctr" wrap="none"/>
-            <a:lstStyle/>
-            <a:p>
-              <a:pPr algn="l" marL="0" marR="0" indent="0">
-                <a:lnSpc>
-                  <a:spcPts val="880"/>
-                </a:lnSpc>
-                <a:spcBef>
-                  <a:spcPts val="0"/>
-                </a:spcBef>
-                <a:spcAft>
-                  <a:spcPts val="0"/>
-                </a:spcAft>
-              </a:pPr>
-              <a:r>
-                <a:rPr sz="880">
-                  <a:solidFill>
-                    <a:srgbClr val="4D4D4D">
-                      <a:alpha val="100000"/>
-                    </a:srgbClr>
-                  </a:solidFill>
-                  <a:latin typeface="Helvetica"/>
-                  <a:cs typeface="Helvetica"/>
-                </a:rPr>
-                <a:t>1.4</a:t>
-              </a:r>
-            </a:p>
-          </p:txBody>
-        </p:sp>
-        <p:sp>
-          <p:nvSpPr>
-            <p:cNvPr id="36" name="tx36"/>
-            <p:cNvSpPr/>
-            <p:nvPr/>
-          </p:nvSpPr>
-          <p:spPr>
-            <a:xfrm>
-              <a:off x="3879271" y="5925448"/>
-              <a:ext cx="1676186" cy="100218"/>
+              <a:off x="2928340" y="5925448"/>
+              <a:ext cx="3578047" cy="100218"/>
             </a:xfrm>
             <a:prstGeom prst="rect">
               <a:avLst/>
@@ -4787,14 +4698,14 @@
                   <a:latin typeface="Helvetica"/>
                   <a:cs typeface="Helvetica"/>
                 </a:rPr>
-                <a:t>CKD-EPI Cr-Cys / CG ratio</a:t>
+                <a:t>eGFR difference (%): 100 × (CKD-EPI Cr-Cys − CG) / CG</a:t>
               </a:r>
             </a:p>
           </p:txBody>
         </p:sp>
         <p:sp>
           <p:nvSpPr>
-            <p:cNvPr id="37" name="tx37"/>
+            <p:cNvPr id="35" name="tx35"/>
             <p:cNvSpPr/>
             <p:nvPr/>
           </p:nvSpPr>
@@ -4840,14 +4751,14 @@
         </p:sp>
         <p:sp>
           <p:nvSpPr>
-            <p:cNvPr id="38" name="tx38"/>
+            <p:cNvPr id="36" name="tx36"/>
             <p:cNvSpPr/>
             <p:nvPr/>
           </p:nvSpPr>
           <p:spPr>
             <a:xfrm>
               <a:off x="817517" y="1896563"/>
-              <a:ext cx="6842729" cy="82021"/>
+              <a:ext cx="6994977" cy="82021"/>
             </a:xfrm>
             <a:prstGeom prst="rect">
               <a:avLst/>
@@ -4879,14 +4790,14 @@
                   <a:latin typeface="Helvetica"/>
                   <a:cs typeface="Helvetica"/>
                 </a:rPr>
-                <a:t>HR per 0.1 ratio decline: 2.68 (1.64-4.38), p_Bonf = &lt;0.001 (n = 6)  |  per IQR decline (Δ = 0.30): 18.33 (4.29-78.40)  |  IQR: [0.84, 1.14]</a:t>
+                <a:t>HR per 10 % decline: 2.68 (1.64-4.38), p_Bonf = &lt;0.001 (n = 6)  |  per IQR decline (Δ = 29.5 %): 18.33 (4.29-78.40)  |  IQR: [-15.6, 13.9] %</a:t>
               </a:r>
             </a:p>
           </p:txBody>
         </p:sp>
         <p:sp>
           <p:nvSpPr>
-            <p:cNvPr id="39" name="tx39"/>
+            <p:cNvPr id="37" name="tx37"/>
             <p:cNvSpPr/>
             <p:nvPr/>
           </p:nvSpPr>

</xml_diff>